<commit_message>
docs: align P100 presentation detail states
</commit_message>
<xml_diff>
--- a/docs/report/Theta_Pen_Plotter_Summer_Progress_Update.pptx
+++ b/docs/report/Theta_Pen_Plotter_Summer_Progress_Update.pptx
@@ -2538,64 +2538,22 @@
       </p:pic>
       <p:sp>
         <p:nvSpPr>
-          <p:cNvPr id="7" name="Rectangle: Rounded Corners 6">
-            <a:extLst>
-              <a:ext uri="{FF2B5EF4-FFF2-40B4-BE49-F238E27FC236}">
-                <a16:creationId xmlns:a16="http://schemas.microsoft.com/office/drawing/2014/main" id="{288213A0-7735-4712-A466-0BAF35E8CDFE}"/>
-              </a:ext>
-            </a:extLst>
-          </p:cNvPr>
-          <p:cNvSpPr>
-            <a:spLocks noGrp="1"/>
-          </p:cNvSpPr>
-          <p:nvPr/>
-        </p:nvSpPr>
-        <p:spPr>
-          <a:xfrm>
-            <a:off x="8572500" y="1847850"/>
-            <a:ext cx="2857500" cy="3371850"/>
-          </a:xfrm>
-          <a:prstGeom prst="roundRect">
-            <a:avLst>
-              <a:gd name="adj" fmla="val 2667"/>
-            </a:avLst>
-          </a:prstGeom>
-          <a:solidFill>
-            <a:srgbClr val="EAF5FB"/>
-          </a:solidFill>
-          <a:ln w="9525">
-            <a:solidFill>
-              <a:srgbClr val="3D8DFF"/>
-            </a:solidFill>
-            <a:prstDash val="solid"/>
-          </a:ln>
-        </p:spPr>
-        <p:txBody>
-          <a:bodyPr/>
-          <a:lstStyle/>
-          <a:p>
-            <a:endParaRPr lang="en-US"/>
-          </a:p>
-        </p:txBody>
-      </p:sp>
-      <p:sp>
-        <p:nvSpPr>
-          <p:cNvPr id="8" name="Rectangle 7">
-            <a:extLst>
-              <a:ext uri="{FF2B5EF4-FFF2-40B4-BE49-F238E27FC236}">
-                <a16:creationId xmlns:a16="http://schemas.microsoft.com/office/drawing/2014/main" id="{2711C4FE-BB95-49F0-875A-79973572DB57}"/>
-              </a:ext>
-            </a:extLst>
-          </p:cNvPr>
-          <p:cNvSpPr>
-            <a:spLocks noGrp="1"/>
-          </p:cNvSpPr>
-          <p:nvPr/>
-        </p:nvSpPr>
-        <p:spPr>
-          <a:xfrm>
-            <a:off x="8839200" y="2152650"/>
-            <a:ext cx="2324100" cy="323850"/>
+          <p:cNvPr id="10" name="Rectangle 9">
+            <a:extLst>
+              <a:ext uri="{FF2B5EF4-FFF2-40B4-BE49-F238E27FC236}">
+                <a16:creationId xmlns:a16="http://schemas.microsoft.com/office/drawing/2014/main" id="{96D81758-CD88-4EF5-A7F6-B3CD03B93DBF}"/>
+              </a:ext>
+            </a:extLst>
+          </p:cNvPr>
+          <p:cNvSpPr>
+            <a:spLocks noGrp="1"/>
+          </p:cNvSpPr>
+          <p:nvPr/>
+        </p:nvSpPr>
+        <p:spPr>
+          <a:xfrm>
+            <a:off x="8572500" y="3238500"/>
+            <a:ext cx="2540000" cy="508000"/>
           </a:xfrm>
           <a:prstGeom prst="rect">
             <a:avLst/>
@@ -2613,9 +2571,9 @@
           <a:lstStyle/>
           <a:p>
             <a:pPr algn="l">
-              <a:defRPr sz="1650" b="1">
-                <a:solidFill>
-                  <a:srgbClr val="000000"/>
+              <a:defRPr sz="1050" b="0">
+                <a:solidFill>
+                  <a:srgbClr val="59616B"/>
                 </a:solidFill>
                 <a:latin typeface="Helvetica Neue"/>
                 <a:ea typeface="Helvetica Neue"/>
@@ -2623,155 +2581,19 @@
               </a:defRPr>
             </a:pPr>
             <a:r>
-              <a:rPr lang="en-US" sz="1650" b="1">
-                <a:solidFill>
-                  <a:srgbClr val="000000"/>
+              <a:rPr lang="en-US" sz="1100" b="0">
+                <a:solidFill>
+                  <a:srgbClr val="80726B"/>
                 </a:solidFill>
                 <a:latin typeface="Helvetica Neue"/>
                 <a:ea typeface="Helvetica Neue"/>
                 <a:cs typeface="Helvetica Neue"/>
               </a:rPr>
-              <a:t>Step 5 — Per-run touch check</a:t>
-            </a:r>
-            <a:endParaRPr sz="1650" b="1">
+              <a:t>Detail shown inside the map. Hover or click another process to compare.</a:t>
+            </a:r>
+            <a:endParaRPr sz="1100" b="0">
               <a:solidFill>
-                <a:srgbClr val="000000"/>
-              </a:solidFill>
-              <a:latin typeface="Helvetica Neue"/>
-              <a:ea typeface="Helvetica Neue"/>
-              <a:cs typeface="Helvetica Neue"/>
-            </a:endParaRPr>
-          </a:p>
-        </p:txBody>
-      </p:sp>
-      <p:sp>
-        <p:nvSpPr>
-          <p:cNvPr id="9" name="Rectangle 8">
-            <a:extLst>
-              <a:ext uri="{FF2B5EF4-FFF2-40B4-BE49-F238E27FC236}">
-                <a16:creationId xmlns:a16="http://schemas.microsoft.com/office/drawing/2014/main" id="{D332E2B0-B79D-428E-A109-130D654AAF30}"/>
-              </a:ext>
-            </a:extLst>
-          </p:cNvPr>
-          <p:cNvSpPr>
-            <a:spLocks noGrp="1"/>
-          </p:cNvSpPr>
-          <p:nvPr/>
-        </p:nvSpPr>
-        <p:spPr>
-          <a:xfrm>
-            <a:off x="8839200" y="2724150"/>
-            <a:ext cx="2247900" cy="1981200"/>
-          </a:xfrm>
-          <a:prstGeom prst="rect">
-            <a:avLst/>
-          </a:prstGeom>
-          <a:noFill/>
-          <a:ln w="0">
-            <a:noFill/>
-            <a:prstDash val="solid"/>
-          </a:ln>
-        </p:spPr>
-        <p:txBody>
-          <a:bodyPr lIns="0" tIns="0" rIns="0" bIns="0" anchor="t">
-            <a:normAutofit/>
-          </a:bodyPr>
-          <a:lstStyle/>
-          <a:p>
-            <a:pPr algn="l">
-              <a:defRPr sz="1350" b="0">
-                <a:solidFill>
-                  <a:srgbClr val="000000"/>
-                </a:solidFill>
-                <a:latin typeface="Helvetica Neue"/>
-                <a:ea typeface="Helvetica Neue"/>
-                <a:cs typeface="Helvetica Neue"/>
-              </a:defRPr>
-            </a:pPr>
-            <a:r>
-              <a:rPr lang="en-US" sz="1350" b="0">
-                <a:solidFill>
-                  <a:srgbClr val="000000"/>
-                </a:solidFill>
-                <a:latin typeface="Helvetica Neue"/>
-                <a:ea typeface="Helvetica Neue"/>
-                <a:cs typeface="Helvetica Neue"/>
-              </a:rPr>
-              <a:t>M3
-Pro Micro seeks down until the load cell reaches the contact threshold.
-M5
-The pen releases, then receives a bounded clearance pulse.
-Failure to touch, release, or clear stops the run.</a:t>
-            </a:r>
-            <a:endParaRPr sz="1350" b="0">
-              <a:solidFill>
-                <a:srgbClr val="000000"/>
-              </a:solidFill>
-              <a:latin typeface="Helvetica Neue"/>
-              <a:ea typeface="Helvetica Neue"/>
-              <a:cs typeface="Helvetica Neue"/>
-            </a:endParaRPr>
-          </a:p>
-        </p:txBody>
-      </p:sp>
-      <p:sp>
-        <p:nvSpPr>
-          <p:cNvPr id="10" name="Rectangle 9">
-            <a:extLst>
-              <a:ext uri="{FF2B5EF4-FFF2-40B4-BE49-F238E27FC236}">
-                <a16:creationId xmlns:a16="http://schemas.microsoft.com/office/drawing/2014/main" id="{96D81758-CD88-4EF5-A7F6-B3CD03B93DBF}"/>
-              </a:ext>
-            </a:extLst>
-          </p:cNvPr>
-          <p:cNvSpPr>
-            <a:spLocks noGrp="1"/>
-          </p:cNvSpPr>
-          <p:nvPr/>
-        </p:nvSpPr>
-        <p:spPr>
-          <a:xfrm>
-            <a:off x="8572500" y="5448300"/>
-            <a:ext cx="2857500" cy="457200"/>
-          </a:xfrm>
-          <a:prstGeom prst="rect">
-            <a:avLst/>
-          </a:prstGeom>
-          <a:noFill/>
-          <a:ln w="0">
-            <a:noFill/>
-            <a:prstDash val="solid"/>
-          </a:ln>
-        </p:spPr>
-        <p:txBody>
-          <a:bodyPr lIns="0" tIns="0" rIns="0" bIns="0" anchor="t">
-            <a:normAutofit/>
-          </a:bodyPr>
-          <a:lstStyle/>
-          <a:p>
-            <a:pPr algn="l">
-              <a:defRPr sz="1050" b="0">
-                <a:solidFill>
-                  <a:srgbClr val="59616B"/>
-                </a:solidFill>
-                <a:latin typeface="Helvetica Neue"/>
-                <a:ea typeface="Helvetica Neue"/>
-                <a:cs typeface="Helvetica Neue"/>
-              </a:defRPr>
-            </a:pPr>
-            <a:r>
-              <a:rPr lang="en-US" sz="1050" b="0">
-                <a:solidFill>
-                  <a:srgbClr val="59616B"/>
-                </a:solidFill>
-                <a:latin typeface="Helvetica Neue"/>
-                <a:ea typeface="Helvetica Neue"/>
-                <a:cs typeface="Helvetica Neue"/>
-              </a:rPr>
-              <a:t>Hover or click another process in the map, or click BACK to return to the overview.</a:t>
-            </a:r>
-            <a:endParaRPr sz="1050" b="0">
-              <a:solidFill>
-                <a:srgbClr val="59616B"/>
+                <a:srgbClr val="80726B"/>
               </a:solidFill>
               <a:latin typeface="Helvetica Neue"/>
               <a:ea typeface="Helvetica Neue"/>
@@ -3316,6 +3138,145 @@
           <a:p>
             <a:pPr algn="ctr"/>
             <a:endParaRPr lang="en-US"/>
+          </a:p>
+        </p:txBody>
+      </p:sp>
+      <p:sp>
+        <p:nvSpPr>
+          <p:cNvPr id="20" name="Matching P100 Map Detail Background">
+            <a:extLst>
+              <a:ext uri="{FF2B5EF4-FFF2-40B4-BE49-F238E27FC236}">
+                <a16:creationId xmlns:a16="http://schemas.microsoft.com/office/drawing/2014/main" id="{89FE897F-04BC-FA43-95EF-FD5AA8ADA80D}"/>
+              </a:ext>
+            </a:extLst>
+          </p:cNvPr>
+          <p:cNvSpPr/>
+          <p:nvPr/>
+        </p:nvSpPr>
+        <p:spPr>
+          <a:xfrm>
+            <a:off x="4953000" y="2552700"/>
+            <a:ext cx="2159000" cy="1574800"/>
+          </a:xfrm>
+          <a:prstGeom prst="rect">
+            <a:avLst/>
+          </a:prstGeom>
+          <a:solidFill>
+            <a:srgbClr val="2B251F"/>
+          </a:solidFill>
+          <a:ln w="8890">
+            <a:solidFill>
+              <a:srgbClr val="6E6052"/>
+            </a:solidFill>
+          </a:ln>
+        </p:spPr>
+        <p:style>
+          <a:lnRef idx="2">
+            <a:schemeClr val="accent1">
+              <a:shade val="15000"/>
+            </a:schemeClr>
+          </a:lnRef>
+          <a:fillRef idx="1">
+            <a:schemeClr val="accent1"/>
+          </a:fillRef>
+          <a:effectRef idx="0">
+            <a:schemeClr val="accent1"/>
+          </a:effectRef>
+          <a:fontRef idx="minor">
+            <a:schemeClr val="lt1"/>
+          </a:fontRef>
+        </p:style>
+        <p:txBody>
+          <a:bodyPr rtlCol="0" anchor="ctr"/>
+          <a:lstStyle/>
+          <a:p>
+            <a:pPr algn="ctr"/>
+            <a:endParaRPr lang="en-US"/>
+          </a:p>
+        </p:txBody>
+      </p:sp>
+      <p:sp>
+        <p:nvSpPr>
+          <p:cNvPr id="21" name="Matching P100 Map Detail Title">
+            <a:extLst>
+              <a:ext uri="{FF2B5EF4-FFF2-40B4-BE49-F238E27FC236}">
+                <a16:creationId xmlns:a16="http://schemas.microsoft.com/office/drawing/2014/main" id="{52103310-A1E3-00CA-D853-899611B9D158}"/>
+              </a:ext>
+            </a:extLst>
+          </p:cNvPr>
+          <p:cNvSpPr txBox="1"/>
+          <p:nvPr/>
+        </p:nvSpPr>
+        <p:spPr>
+          <a:xfrm>
+            <a:off x="5067300" y="2667000"/>
+            <a:ext cx="1930400" cy="115416"/>
+          </a:xfrm>
+          <a:prstGeom prst="rect">
+            <a:avLst/>
+          </a:prstGeom>
+          <a:noFill/>
+        </p:spPr>
+        <p:txBody>
+          <a:bodyPr vert="horz" lIns="0" tIns="0" rIns="0" bIns="0" rtlCol="0">
+            <a:spAutoFit/>
+          </a:bodyPr>
+          <a:lstStyle/>
+          <a:p>
+            <a:r>
+              <a:rPr lang="en-US" sz="750" b="1">
+                <a:solidFill>
+                  <a:srgbClr val="FFCC66"/>
+                </a:solidFill>
+                <a:latin typeface="Aptos" panose="020B0004020202020204" pitchFamily="34" charset="0"/>
+              </a:rPr>
+              <a:t>5. Per-run touch check</a:t>
+            </a:r>
+          </a:p>
+        </p:txBody>
+      </p:sp>
+      <p:sp>
+        <p:nvSpPr>
+          <p:cNvPr id="22" name="Matching P100 Map Detail Body">
+            <a:extLst>
+              <a:ext uri="{FF2B5EF4-FFF2-40B4-BE49-F238E27FC236}">
+                <a16:creationId xmlns:a16="http://schemas.microsoft.com/office/drawing/2014/main" id="{CA9E2D01-1BF7-F06A-80BF-59E1B3A5FA6D}"/>
+              </a:ext>
+            </a:extLst>
+          </p:cNvPr>
+          <p:cNvSpPr txBox="1"/>
+          <p:nvPr/>
+        </p:nvSpPr>
+        <p:spPr>
+          <a:xfrm>
+            <a:off x="5067300" y="2870200"/>
+            <a:ext cx="1930400" cy="787908"/>
+          </a:xfrm>
+          <a:prstGeom prst="rect">
+            <a:avLst/>
+          </a:prstGeom>
+          <a:noFill/>
+        </p:spPr>
+        <p:txBody>
+          <a:bodyPr vert="horz" lIns="0" tIns="0" rIns="0" bIns="0" rtlCol="0">
+            <a:spAutoFit/>
+          </a:bodyPr>
+          <a:lstStyle/>
+          <a:p>
+            <a:r>
+              <a:rPr lang="en-US" sz="640">
+                <a:solidFill>
+                  <a:srgbClr val="F7F4F0"/>
+                </a:solidFill>
+                <a:latin typeface="Aptos" panose="020B0004020202020204" pitchFamily="34" charset="0"/>
+              </a:rPr>
+              <a:t>M3
+Seek down to the load-cell contact threshold.
+M5
+Release, then make a bounded clearance pulse.
+Abort
+Fail to touch, release, or clear.</a:t>
+            </a:r>
           </a:p>
         </p:txBody>
       </p:sp>
@@ -3653,64 +3614,22 @@
       </p:pic>
       <p:sp>
         <p:nvSpPr>
-          <p:cNvPr id="7" name="Rectangle: Rounded Corners 6">
-            <a:extLst>
-              <a:ext uri="{FF2B5EF4-FFF2-40B4-BE49-F238E27FC236}">
-                <a16:creationId xmlns:a16="http://schemas.microsoft.com/office/drawing/2014/main" id="{288213A0-7735-4712-A466-0BAF35E8CDFE}"/>
-              </a:ext>
-            </a:extLst>
-          </p:cNvPr>
-          <p:cNvSpPr>
-            <a:spLocks noGrp="1"/>
-          </p:cNvSpPr>
-          <p:nvPr/>
-        </p:nvSpPr>
-        <p:spPr>
-          <a:xfrm>
-            <a:off x="8572500" y="1847850"/>
-            <a:ext cx="2857500" cy="3371850"/>
-          </a:xfrm>
-          <a:prstGeom prst="roundRect">
-            <a:avLst>
-              <a:gd name="adj" fmla="val 2667"/>
-            </a:avLst>
-          </a:prstGeom>
-          <a:solidFill>
-            <a:srgbClr val="EAF5FB"/>
-          </a:solidFill>
-          <a:ln w="9525">
-            <a:solidFill>
-              <a:srgbClr val="3D8DFF"/>
-            </a:solidFill>
-            <a:prstDash val="solid"/>
-          </a:ln>
-        </p:spPr>
-        <p:txBody>
-          <a:bodyPr/>
-          <a:lstStyle/>
-          <a:p>
-            <a:endParaRPr lang="en-US"/>
-          </a:p>
-        </p:txBody>
-      </p:sp>
-      <p:sp>
-        <p:nvSpPr>
-          <p:cNvPr id="8" name="Rectangle 7">
-            <a:extLst>
-              <a:ext uri="{FF2B5EF4-FFF2-40B4-BE49-F238E27FC236}">
-                <a16:creationId xmlns:a16="http://schemas.microsoft.com/office/drawing/2014/main" id="{2711C4FE-BB95-49F0-875A-79973572DB57}"/>
-              </a:ext>
-            </a:extLst>
-          </p:cNvPr>
-          <p:cNvSpPr>
-            <a:spLocks noGrp="1"/>
-          </p:cNvSpPr>
-          <p:nvPr/>
-        </p:nvSpPr>
-        <p:spPr>
-          <a:xfrm>
-            <a:off x="8839200" y="2152650"/>
-            <a:ext cx="2324100" cy="323850"/>
+          <p:cNvPr id="10" name="Rectangle 9">
+            <a:extLst>
+              <a:ext uri="{FF2B5EF4-FFF2-40B4-BE49-F238E27FC236}">
+                <a16:creationId xmlns:a16="http://schemas.microsoft.com/office/drawing/2014/main" id="{96D81758-CD88-4EF5-A7F6-B3CD03B93DBF}"/>
+              </a:ext>
+            </a:extLst>
+          </p:cNvPr>
+          <p:cNvSpPr>
+            <a:spLocks noGrp="1"/>
+          </p:cNvSpPr>
+          <p:nvPr/>
+        </p:nvSpPr>
+        <p:spPr>
+          <a:xfrm>
+            <a:off x="8572500" y="3238500"/>
+            <a:ext cx="2540000" cy="508000"/>
           </a:xfrm>
           <a:prstGeom prst="rect">
             <a:avLst/>
@@ -3728,9 +3647,9 @@
           <a:lstStyle/>
           <a:p>
             <a:pPr algn="l">
-              <a:defRPr sz="1650" b="1">
-                <a:solidFill>
-                  <a:srgbClr val="000000"/>
+              <a:defRPr sz="1050" b="0">
+                <a:solidFill>
+                  <a:srgbClr val="59616B"/>
                 </a:solidFill>
                 <a:latin typeface="Helvetica Neue"/>
                 <a:ea typeface="Helvetica Neue"/>
@@ -3738,154 +3657,19 @@
               </a:defRPr>
             </a:pPr>
             <a:r>
-              <a:rPr lang="en-US" sz="1650" b="1">
-                <a:solidFill>
-                  <a:srgbClr val="000000"/>
+              <a:rPr lang="en-US" sz="1100" b="0">
+                <a:solidFill>
+                  <a:srgbClr val="80726B"/>
                 </a:solidFill>
                 <a:latin typeface="Helvetica Neue"/>
                 <a:ea typeface="Helvetica Neue"/>
                 <a:cs typeface="Helvetica Neue"/>
               </a:rPr>
-              <a:t>Step 6 — Ready state</a:t>
-            </a:r>
-            <a:endParaRPr sz="1650" b="1">
+              <a:t>Detail shown inside the map. Hover or click another process to compare.</a:t>
+            </a:r>
+            <a:endParaRPr sz="1100" b="0">
               <a:solidFill>
-                <a:srgbClr val="000000"/>
-              </a:solidFill>
-              <a:latin typeface="Helvetica Neue"/>
-              <a:ea typeface="Helvetica Neue"/>
-              <a:cs typeface="Helvetica Neue"/>
-            </a:endParaRPr>
-          </a:p>
-        </p:txBody>
-      </p:sp>
-      <p:sp>
-        <p:nvSpPr>
-          <p:cNvPr id="9" name="Rectangle 8">
-            <a:extLst>
-              <a:ext uri="{FF2B5EF4-FFF2-40B4-BE49-F238E27FC236}">
-                <a16:creationId xmlns:a16="http://schemas.microsoft.com/office/drawing/2014/main" id="{D332E2B0-B79D-428E-A109-130D654AAF30}"/>
-              </a:ext>
-            </a:extLst>
-          </p:cNvPr>
-          <p:cNvSpPr>
-            <a:spLocks noGrp="1"/>
-          </p:cNvSpPr>
-          <p:nvPr/>
-        </p:nvSpPr>
-        <p:spPr>
-          <a:xfrm>
-            <a:off x="8839200" y="2724150"/>
-            <a:ext cx="2247900" cy="1981200"/>
-          </a:xfrm>
-          <a:prstGeom prst="rect">
-            <a:avLst/>
-          </a:prstGeom>
-          <a:noFill/>
-          <a:ln w="0">
-            <a:noFill/>
-            <a:prstDash val="solid"/>
-          </a:ln>
-        </p:spPr>
-        <p:txBody>
-          <a:bodyPr lIns="0" tIns="0" rIns="0" bIns="0" anchor="t">
-            <a:normAutofit/>
-          </a:bodyPr>
-          <a:lstStyle/>
-          <a:p>
-            <a:pPr algn="l">
-              <a:defRPr sz="1350" b="0">
-                <a:solidFill>
-                  <a:srgbClr val="000000"/>
-                </a:solidFill>
-                <a:latin typeface="Helvetica Neue"/>
-                <a:ea typeface="Helvetica Neue"/>
-                <a:cs typeface="Helvetica Neue"/>
-              </a:defRPr>
-            </a:pPr>
-            <a:r>
-              <a:rPr lang="en-US" sz="1350" b="0">
-                <a:solidFill>
-                  <a:srgbClr val="000000"/>
-                </a:solidFill>
-                <a:latin typeface="Helvetica Neue"/>
-                <a:ea typeface="Helvetica Neue"/>
-                <a:cs typeface="Helvetica Neue"/>
-              </a:rPr>
-              <a:t>Ready condition
-G54 is registered and the pen is clear of the paper.
-ioSender may stream the drawing.
-M3 writes; M5 releases and travels without reaching GP2.</a:t>
-            </a:r>
-            <a:endParaRPr sz="1350" b="0">
-              <a:solidFill>
-                <a:srgbClr val="000000"/>
-              </a:solidFill>
-              <a:latin typeface="Helvetica Neue"/>
-              <a:ea typeface="Helvetica Neue"/>
-              <a:cs typeface="Helvetica Neue"/>
-            </a:endParaRPr>
-          </a:p>
-        </p:txBody>
-      </p:sp>
-      <p:sp>
-        <p:nvSpPr>
-          <p:cNvPr id="10" name="Rectangle 9">
-            <a:extLst>
-              <a:ext uri="{FF2B5EF4-FFF2-40B4-BE49-F238E27FC236}">
-                <a16:creationId xmlns:a16="http://schemas.microsoft.com/office/drawing/2014/main" id="{96D81758-CD88-4EF5-A7F6-B3CD03B93DBF}"/>
-              </a:ext>
-            </a:extLst>
-          </p:cNvPr>
-          <p:cNvSpPr>
-            <a:spLocks noGrp="1"/>
-          </p:cNvSpPr>
-          <p:nvPr/>
-        </p:nvSpPr>
-        <p:spPr>
-          <a:xfrm>
-            <a:off x="8572500" y="5448300"/>
-            <a:ext cx="2857500" cy="457200"/>
-          </a:xfrm>
-          <a:prstGeom prst="rect">
-            <a:avLst/>
-          </a:prstGeom>
-          <a:noFill/>
-          <a:ln w="0">
-            <a:noFill/>
-            <a:prstDash val="solid"/>
-          </a:ln>
-        </p:spPr>
-        <p:txBody>
-          <a:bodyPr lIns="0" tIns="0" rIns="0" bIns="0" anchor="t">
-            <a:normAutofit/>
-          </a:bodyPr>
-          <a:lstStyle/>
-          <a:p>
-            <a:pPr algn="l">
-              <a:defRPr sz="1050" b="0">
-                <a:solidFill>
-                  <a:srgbClr val="59616B"/>
-                </a:solidFill>
-                <a:latin typeface="Helvetica Neue"/>
-                <a:ea typeface="Helvetica Neue"/>
-                <a:cs typeface="Helvetica Neue"/>
-              </a:defRPr>
-            </a:pPr>
-            <a:r>
-              <a:rPr lang="en-US" sz="1050" b="0">
-                <a:solidFill>
-                  <a:srgbClr val="59616B"/>
-                </a:solidFill>
-                <a:latin typeface="Helvetica Neue"/>
-                <a:ea typeface="Helvetica Neue"/>
-                <a:cs typeface="Helvetica Neue"/>
-              </a:rPr>
-              <a:t>Hover or click another process in the map, or click BACK to return to the overview.</a:t>
-            </a:r>
-            <a:endParaRPr sz="1050" b="0">
-              <a:solidFill>
-                <a:srgbClr val="59616B"/>
+                <a:srgbClr val="80726B"/>
               </a:solidFill>
               <a:latin typeface="Helvetica Neue"/>
               <a:ea typeface="Helvetica Neue"/>
@@ -4430,6 +4214,144 @@
           <a:p>
             <a:pPr algn="ctr"/>
             <a:endParaRPr lang="en-US"/>
+          </a:p>
+        </p:txBody>
+      </p:sp>
+      <p:sp>
+        <p:nvSpPr>
+          <p:cNvPr id="20" name="Matching P100 Map Detail Background">
+            <a:extLst>
+              <a:ext uri="{FF2B5EF4-FFF2-40B4-BE49-F238E27FC236}">
+                <a16:creationId xmlns:a16="http://schemas.microsoft.com/office/drawing/2014/main" id="{96A6C59A-8EFD-8E9A-98CA-807B25989EF4}"/>
+              </a:ext>
+            </a:extLst>
+          </p:cNvPr>
+          <p:cNvSpPr/>
+          <p:nvPr/>
+        </p:nvSpPr>
+        <p:spPr>
+          <a:xfrm>
+            <a:off x="4953000" y="2552700"/>
+            <a:ext cx="2159000" cy="1574800"/>
+          </a:xfrm>
+          <a:prstGeom prst="rect">
+            <a:avLst/>
+          </a:prstGeom>
+          <a:solidFill>
+            <a:srgbClr val="2B251F"/>
+          </a:solidFill>
+          <a:ln w="8890">
+            <a:solidFill>
+              <a:srgbClr val="6E6052"/>
+            </a:solidFill>
+          </a:ln>
+        </p:spPr>
+        <p:style>
+          <a:lnRef idx="2">
+            <a:schemeClr val="accent1">
+              <a:shade val="15000"/>
+            </a:schemeClr>
+          </a:lnRef>
+          <a:fillRef idx="1">
+            <a:schemeClr val="accent1"/>
+          </a:fillRef>
+          <a:effectRef idx="0">
+            <a:schemeClr val="accent1"/>
+          </a:effectRef>
+          <a:fontRef idx="minor">
+            <a:schemeClr val="lt1"/>
+          </a:fontRef>
+        </p:style>
+        <p:txBody>
+          <a:bodyPr rtlCol="0" anchor="ctr"/>
+          <a:lstStyle/>
+          <a:p>
+            <a:pPr algn="ctr"/>
+            <a:endParaRPr lang="en-US"/>
+          </a:p>
+        </p:txBody>
+      </p:sp>
+      <p:sp>
+        <p:nvSpPr>
+          <p:cNvPr id="21" name="Matching P100 Map Detail Title">
+            <a:extLst>
+              <a:ext uri="{FF2B5EF4-FFF2-40B4-BE49-F238E27FC236}">
+                <a16:creationId xmlns:a16="http://schemas.microsoft.com/office/drawing/2014/main" id="{79B1B7FA-F6B4-12FF-24AF-F35EF601677B}"/>
+              </a:ext>
+            </a:extLst>
+          </p:cNvPr>
+          <p:cNvSpPr txBox="1"/>
+          <p:nvPr/>
+        </p:nvSpPr>
+        <p:spPr>
+          <a:xfrm>
+            <a:off x="5067300" y="2667000"/>
+            <a:ext cx="1930400" cy="115416"/>
+          </a:xfrm>
+          <a:prstGeom prst="rect">
+            <a:avLst/>
+          </a:prstGeom>
+          <a:noFill/>
+        </p:spPr>
+        <p:txBody>
+          <a:bodyPr vert="horz" lIns="0" tIns="0" rIns="0" bIns="0" rtlCol="0">
+            <a:spAutoFit/>
+          </a:bodyPr>
+          <a:lstStyle/>
+          <a:p>
+            <a:r>
+              <a:rPr lang="en-US" sz="750" b="1">
+                <a:solidFill>
+                  <a:srgbClr val="FFCC66"/>
+                </a:solidFill>
+                <a:latin typeface="Aptos" panose="020B0004020202020204" pitchFamily="34" charset="0"/>
+              </a:rPr>
+              <a:t>6. Ready state</a:t>
+            </a:r>
+          </a:p>
+        </p:txBody>
+      </p:sp>
+      <p:sp>
+        <p:nvSpPr>
+          <p:cNvPr id="22" name="Matching P100 Map Detail Body">
+            <a:extLst>
+              <a:ext uri="{FF2B5EF4-FFF2-40B4-BE49-F238E27FC236}">
+                <a16:creationId xmlns:a16="http://schemas.microsoft.com/office/drawing/2014/main" id="{FC948654-D1C0-901A-42AD-B9C9346D71C8}"/>
+              </a:ext>
+            </a:extLst>
+          </p:cNvPr>
+          <p:cNvSpPr txBox="1"/>
+          <p:nvPr/>
+        </p:nvSpPr>
+        <p:spPr>
+          <a:xfrm>
+            <a:off x="5067300" y="2870200"/>
+            <a:ext cx="1930400" cy="689420"/>
+          </a:xfrm>
+          <a:prstGeom prst="rect">
+            <a:avLst/>
+          </a:prstGeom>
+          <a:noFill/>
+        </p:spPr>
+        <p:txBody>
+          <a:bodyPr vert="horz" lIns="0" tIns="0" rIns="0" bIns="0" rtlCol="0">
+            <a:spAutoFit/>
+          </a:bodyPr>
+          <a:lstStyle/>
+          <a:p>
+            <a:r>
+              <a:rPr lang="en-US" sz="640">
+                <a:solidFill>
+                  <a:srgbClr val="F7F4F0"/>
+                </a:solidFill>
+                <a:latin typeface="Aptos" panose="020B0004020202020204" pitchFamily="34" charset="0"/>
+              </a:rPr>
+              <a:t>Ready
+G54 registered; pen clear of paper.
+Drawing
+M3 writes. M5 releases and travels.
+GP2 is not used for each lift.</a:t>
+            </a:r>
           </a:p>
         </p:txBody>
       </p:sp>
@@ -12642,64 +12564,22 @@
       </p:pic>
       <p:sp>
         <p:nvSpPr>
-          <p:cNvPr id="7" name="Rectangle: Rounded Corners 6">
-            <a:extLst>
-              <a:ext uri="{FF2B5EF4-FFF2-40B4-BE49-F238E27FC236}">
-                <a16:creationId xmlns:a16="http://schemas.microsoft.com/office/drawing/2014/main" id="{288213A0-7735-4712-A466-0BAF35E8CDFE}"/>
-              </a:ext>
-            </a:extLst>
-          </p:cNvPr>
-          <p:cNvSpPr>
-            <a:spLocks noGrp="1"/>
-          </p:cNvSpPr>
-          <p:nvPr/>
-        </p:nvSpPr>
-        <p:spPr>
-          <a:xfrm>
-            <a:off x="8572500" y="1847850"/>
-            <a:ext cx="2857500" cy="3371850"/>
-          </a:xfrm>
-          <a:prstGeom prst="roundRect">
-            <a:avLst>
-              <a:gd name="adj" fmla="val 2667"/>
-            </a:avLst>
-          </a:prstGeom>
-          <a:solidFill>
-            <a:srgbClr val="EAF5FB"/>
-          </a:solidFill>
-          <a:ln w="9525">
-            <a:solidFill>
-              <a:srgbClr val="3D8DFF"/>
-            </a:solidFill>
-            <a:prstDash val="solid"/>
-          </a:ln>
-        </p:spPr>
-        <p:txBody>
-          <a:bodyPr/>
-          <a:lstStyle/>
-          <a:p>
-            <a:endParaRPr lang="en-US"/>
-          </a:p>
-        </p:txBody>
-      </p:sp>
-      <p:sp>
-        <p:nvSpPr>
-          <p:cNvPr id="8" name="Rectangle 7">
-            <a:extLst>
-              <a:ext uri="{FF2B5EF4-FFF2-40B4-BE49-F238E27FC236}">
-                <a16:creationId xmlns:a16="http://schemas.microsoft.com/office/drawing/2014/main" id="{2711C4FE-BB95-49F0-875A-79973572DB57}"/>
-              </a:ext>
-            </a:extLst>
-          </p:cNvPr>
-          <p:cNvSpPr>
-            <a:spLocks noGrp="1"/>
-          </p:cNvSpPr>
-          <p:nvPr/>
-        </p:nvSpPr>
-        <p:spPr>
-          <a:xfrm>
-            <a:off x="8839200" y="2152650"/>
-            <a:ext cx="2324100" cy="323850"/>
+          <p:cNvPr id="10" name="Rectangle 9">
+            <a:extLst>
+              <a:ext uri="{FF2B5EF4-FFF2-40B4-BE49-F238E27FC236}">
+                <a16:creationId xmlns:a16="http://schemas.microsoft.com/office/drawing/2014/main" id="{96D81758-CD88-4EF5-A7F6-B3CD03B93DBF}"/>
+              </a:ext>
+            </a:extLst>
+          </p:cNvPr>
+          <p:cNvSpPr>
+            <a:spLocks noGrp="1"/>
+          </p:cNvSpPr>
+          <p:nvPr/>
+        </p:nvSpPr>
+        <p:spPr>
+          <a:xfrm>
+            <a:off x="8572500" y="3238500"/>
+            <a:ext cx="2540000" cy="508000"/>
           </a:xfrm>
           <a:prstGeom prst="rect">
             <a:avLst/>
@@ -12717,9 +12597,9 @@
           <a:lstStyle/>
           <a:p>
             <a:pPr algn="l">
-              <a:defRPr sz="1650" b="1">
-                <a:solidFill>
-                  <a:srgbClr val="000000"/>
+              <a:defRPr sz="1050" b="0">
+                <a:solidFill>
+                  <a:srgbClr val="59616B"/>
                 </a:solidFill>
                 <a:latin typeface="Helvetica Neue"/>
                 <a:ea typeface="Helvetica Neue"/>
@@ -12727,155 +12607,19 @@
               </a:defRPr>
             </a:pPr>
             <a:r>
-              <a:rPr lang="en-US" sz="1650" b="1">
-                <a:solidFill>
-                  <a:srgbClr val="000000"/>
+              <a:rPr lang="en-US" sz="1100" b="0">
+                <a:solidFill>
+                  <a:srgbClr val="80726B"/>
                 </a:solidFill>
                 <a:latin typeface="Helvetica Neue"/>
                 <a:ea typeface="Helvetica Neue"/>
                 <a:cs typeface="Helvetica Neue"/>
               </a:rPr>
-              <a:t>Step 1 — Start command</a:t>
-            </a:r>
-            <a:endParaRPr sz="1650" b="1">
+              <a:t>Detail shown inside the map. Hover or click another process to compare.</a:t>
+            </a:r>
+            <a:endParaRPr sz="1100" b="0">
               <a:solidFill>
-                <a:srgbClr val="000000"/>
-              </a:solidFill>
-              <a:latin typeface="Helvetica Neue"/>
-              <a:ea typeface="Helvetica Neue"/>
-              <a:cs typeface="Helvetica Neue"/>
-            </a:endParaRPr>
-          </a:p>
-        </p:txBody>
-      </p:sp>
-      <p:sp>
-        <p:nvSpPr>
-          <p:cNvPr id="9" name="Rectangle 8">
-            <a:extLst>
-              <a:ext uri="{FF2B5EF4-FFF2-40B4-BE49-F238E27FC236}">
-                <a16:creationId xmlns:a16="http://schemas.microsoft.com/office/drawing/2014/main" id="{D332E2B0-B79D-428E-A109-130D654AAF30}"/>
-              </a:ext>
-            </a:extLst>
-          </p:cNvPr>
-          <p:cNvSpPr>
-            <a:spLocks noGrp="1"/>
-          </p:cNvSpPr>
-          <p:nvPr/>
-        </p:nvSpPr>
-        <p:spPr>
-          <a:xfrm>
-            <a:off x="8839200" y="2724150"/>
-            <a:ext cx="2247900" cy="1981200"/>
-          </a:xfrm>
-          <a:prstGeom prst="rect">
-            <a:avLst/>
-          </a:prstGeom>
-          <a:noFill/>
-          <a:ln w="0">
-            <a:noFill/>
-            <a:prstDash val="solid"/>
-          </a:ln>
-        </p:spPr>
-        <p:txBody>
-          <a:bodyPr lIns="0" tIns="0" rIns="0" bIns="0" anchor="t">
-            <a:normAutofit/>
-          </a:bodyPr>
-          <a:lstStyle/>
-          <a:p>
-            <a:pPr algn="l">
-              <a:defRPr sz="1350" b="0">
-                <a:solidFill>
-                  <a:srgbClr val="000000"/>
-                </a:solidFill>
-                <a:latin typeface="Helvetica Neue"/>
-                <a:ea typeface="Helvetica Neue"/>
-                <a:cs typeface="Helvetica Neue"/>
-              </a:defRPr>
-            </a:pPr>
-            <a:r>
-              <a:rPr lang="en-US" sz="1350" b="0">
-                <a:solidFill>
-                  <a:srgbClr val="000000"/>
-                </a:solidFill>
-                <a:latin typeface="Helvetica Neue"/>
-                <a:ea typeface="Helvetica Neue"/>
-                <a:cs typeface="Helvetica Neue"/>
-              </a:rPr>
-              <a:t>Command
-ioSender sends: G65 P100 Q0
-Decision owner
-RP23CNC / grblHAL starts P100 locally.
-No toolhead force samples leave the Pro Micro.</a:t>
-            </a:r>
-            <a:endParaRPr sz="1350" b="0">
-              <a:solidFill>
-                <a:srgbClr val="000000"/>
-              </a:solidFill>
-              <a:latin typeface="Helvetica Neue"/>
-              <a:ea typeface="Helvetica Neue"/>
-              <a:cs typeface="Helvetica Neue"/>
-            </a:endParaRPr>
-          </a:p>
-        </p:txBody>
-      </p:sp>
-      <p:sp>
-        <p:nvSpPr>
-          <p:cNvPr id="10" name="Rectangle 9">
-            <a:extLst>
-              <a:ext uri="{FF2B5EF4-FFF2-40B4-BE49-F238E27FC236}">
-                <a16:creationId xmlns:a16="http://schemas.microsoft.com/office/drawing/2014/main" id="{96D81758-CD88-4EF5-A7F6-B3CD03B93DBF}"/>
-              </a:ext>
-            </a:extLst>
-          </p:cNvPr>
-          <p:cNvSpPr>
-            <a:spLocks noGrp="1"/>
-          </p:cNvSpPr>
-          <p:nvPr/>
-        </p:nvSpPr>
-        <p:spPr>
-          <a:xfrm>
-            <a:off x="8572500" y="5448300"/>
-            <a:ext cx="2857500" cy="457200"/>
-          </a:xfrm>
-          <a:prstGeom prst="rect">
-            <a:avLst/>
-          </a:prstGeom>
-          <a:noFill/>
-          <a:ln w="0">
-            <a:noFill/>
-            <a:prstDash val="solid"/>
-          </a:ln>
-        </p:spPr>
-        <p:txBody>
-          <a:bodyPr lIns="0" tIns="0" rIns="0" bIns="0" anchor="t">
-            <a:normAutofit/>
-          </a:bodyPr>
-          <a:lstStyle/>
-          <a:p>
-            <a:pPr algn="l">
-              <a:defRPr sz="1050" b="0">
-                <a:solidFill>
-                  <a:srgbClr val="59616B"/>
-                </a:solidFill>
-                <a:latin typeface="Helvetica Neue"/>
-                <a:ea typeface="Helvetica Neue"/>
-                <a:cs typeface="Helvetica Neue"/>
-              </a:defRPr>
-            </a:pPr>
-            <a:r>
-              <a:rPr lang="en-US" sz="1050" b="0">
-                <a:solidFill>
-                  <a:srgbClr val="59616B"/>
-                </a:solidFill>
-                <a:latin typeface="Helvetica Neue"/>
-                <a:ea typeface="Helvetica Neue"/>
-                <a:cs typeface="Helvetica Neue"/>
-              </a:rPr>
-              <a:t>Hover or click another process in the map, or click BACK to return to the overview.</a:t>
-            </a:r>
-            <a:endParaRPr sz="1050" b="0">
-              <a:solidFill>
-                <a:srgbClr val="59616B"/>
+                <a:srgbClr val="80726B"/>
               </a:solidFill>
               <a:latin typeface="Helvetica Neue"/>
               <a:ea typeface="Helvetica Neue"/>
@@ -13420,6 +13164,145 @@
           <a:p>
             <a:pPr algn="ctr"/>
             <a:endParaRPr lang="en-US"/>
+          </a:p>
+        </p:txBody>
+      </p:sp>
+      <p:sp>
+        <p:nvSpPr>
+          <p:cNvPr id="20" name="Matching P100 Map Detail Background">
+            <a:extLst>
+              <a:ext uri="{FF2B5EF4-FFF2-40B4-BE49-F238E27FC236}">
+                <a16:creationId xmlns:a16="http://schemas.microsoft.com/office/drawing/2014/main" id="{5CEF202E-B754-A271-22D6-351167702F2F}"/>
+              </a:ext>
+            </a:extLst>
+          </p:cNvPr>
+          <p:cNvSpPr/>
+          <p:nvPr/>
+        </p:nvSpPr>
+        <p:spPr>
+          <a:xfrm>
+            <a:off x="4953000" y="2552700"/>
+            <a:ext cx="2159000" cy="1574800"/>
+          </a:xfrm>
+          <a:prstGeom prst="rect">
+            <a:avLst/>
+          </a:prstGeom>
+          <a:solidFill>
+            <a:srgbClr val="2B251F"/>
+          </a:solidFill>
+          <a:ln w="8890">
+            <a:solidFill>
+              <a:srgbClr val="6E6052"/>
+            </a:solidFill>
+          </a:ln>
+        </p:spPr>
+        <p:style>
+          <a:lnRef idx="2">
+            <a:schemeClr val="accent1">
+              <a:shade val="15000"/>
+            </a:schemeClr>
+          </a:lnRef>
+          <a:fillRef idx="1">
+            <a:schemeClr val="accent1"/>
+          </a:fillRef>
+          <a:effectRef idx="0">
+            <a:schemeClr val="accent1"/>
+          </a:effectRef>
+          <a:fontRef idx="minor">
+            <a:schemeClr val="lt1"/>
+          </a:fontRef>
+        </p:style>
+        <p:txBody>
+          <a:bodyPr rtlCol="0" anchor="ctr"/>
+          <a:lstStyle/>
+          <a:p>
+            <a:pPr algn="ctr"/>
+            <a:endParaRPr lang="en-US"/>
+          </a:p>
+        </p:txBody>
+      </p:sp>
+      <p:sp>
+        <p:nvSpPr>
+          <p:cNvPr id="21" name="Matching P100 Map Detail Title">
+            <a:extLst>
+              <a:ext uri="{FF2B5EF4-FFF2-40B4-BE49-F238E27FC236}">
+                <a16:creationId xmlns:a16="http://schemas.microsoft.com/office/drawing/2014/main" id="{AD756550-ED54-A3C6-39A3-0CF332046ED4}"/>
+              </a:ext>
+            </a:extLst>
+          </p:cNvPr>
+          <p:cNvSpPr txBox="1"/>
+          <p:nvPr/>
+        </p:nvSpPr>
+        <p:spPr>
+          <a:xfrm>
+            <a:off x="5067300" y="2667000"/>
+            <a:ext cx="1930400" cy="115416"/>
+          </a:xfrm>
+          <a:prstGeom prst="rect">
+            <a:avLst/>
+          </a:prstGeom>
+          <a:noFill/>
+        </p:spPr>
+        <p:txBody>
+          <a:bodyPr vert="horz" lIns="0" tIns="0" rIns="0" bIns="0" rtlCol="0">
+            <a:spAutoFit/>
+          </a:bodyPr>
+          <a:lstStyle/>
+          <a:p>
+            <a:r>
+              <a:rPr lang="en-US" sz="750" b="1">
+                <a:solidFill>
+                  <a:srgbClr val="FFCC66"/>
+                </a:solidFill>
+                <a:latin typeface="Aptos" panose="020B0004020202020204" pitchFamily="34" charset="0"/>
+              </a:rPr>
+              <a:t>1. Start command</a:t>
+            </a:r>
+          </a:p>
+        </p:txBody>
+      </p:sp>
+      <p:sp>
+        <p:nvSpPr>
+          <p:cNvPr id="22" name="Matching P100 Map Detail Body">
+            <a:extLst>
+              <a:ext uri="{FF2B5EF4-FFF2-40B4-BE49-F238E27FC236}">
+                <a16:creationId xmlns:a16="http://schemas.microsoft.com/office/drawing/2014/main" id="{8B807CB2-EC82-3A18-09AF-01ADA23DEF0C}"/>
+              </a:ext>
+            </a:extLst>
+          </p:cNvPr>
+          <p:cNvSpPr txBox="1"/>
+          <p:nvPr/>
+        </p:nvSpPr>
+        <p:spPr>
+          <a:xfrm>
+            <a:off x="5067300" y="2870200"/>
+            <a:ext cx="1930400" cy="886397"/>
+          </a:xfrm>
+          <a:prstGeom prst="rect">
+            <a:avLst/>
+          </a:prstGeom>
+          <a:noFill/>
+        </p:spPr>
+        <p:txBody>
+          <a:bodyPr vert="horz" lIns="0" tIns="0" rIns="0" bIns="0" rtlCol="0">
+            <a:spAutoFit/>
+          </a:bodyPr>
+          <a:lstStyle/>
+          <a:p>
+            <a:r>
+              <a:rPr lang="en-US" sz="640">
+                <a:solidFill>
+                  <a:srgbClr val="F7F4F0"/>
+                </a:solidFill>
+                <a:latin typeface="Aptos" panose="020B0004020202020204" pitchFamily="34" charset="0"/>
+              </a:rPr>
+              <a:t>Command
+ioSender → RP23CNC: G65 P100 Q0
+Decision owner
+RP23CNC / grblHAL starts P100 locally.
+Not moved
+HX711 force samples stay inside the Pro Micro toolhead.</a:t>
+            </a:r>
           </a:p>
         </p:txBody>
       </p:sp>
@@ -13757,64 +13640,22 @@
       </p:pic>
       <p:sp>
         <p:nvSpPr>
-          <p:cNvPr id="7" name="Rectangle: Rounded Corners 6">
-            <a:extLst>
-              <a:ext uri="{FF2B5EF4-FFF2-40B4-BE49-F238E27FC236}">
-                <a16:creationId xmlns:a16="http://schemas.microsoft.com/office/drawing/2014/main" id="{288213A0-7735-4712-A466-0BAF35E8CDFE}"/>
-              </a:ext>
-            </a:extLst>
-          </p:cNvPr>
-          <p:cNvSpPr>
-            <a:spLocks noGrp="1"/>
-          </p:cNvSpPr>
-          <p:nvPr/>
-        </p:nvSpPr>
-        <p:spPr>
-          <a:xfrm>
-            <a:off x="8572500" y="1847850"/>
-            <a:ext cx="2857500" cy="3371850"/>
-          </a:xfrm>
-          <a:prstGeom prst="roundRect">
-            <a:avLst>
-              <a:gd name="adj" fmla="val 2667"/>
-            </a:avLst>
-          </a:prstGeom>
-          <a:solidFill>
-            <a:srgbClr val="EAF5FB"/>
-          </a:solidFill>
-          <a:ln w="9525">
-            <a:solidFill>
-              <a:srgbClr val="3D8DFF"/>
-            </a:solidFill>
-            <a:prstDash val="solid"/>
-          </a:ln>
-        </p:spPr>
-        <p:txBody>
-          <a:bodyPr/>
-          <a:lstStyle/>
-          <a:p>
-            <a:endParaRPr lang="en-US"/>
-          </a:p>
-        </p:txBody>
-      </p:sp>
-      <p:sp>
-        <p:nvSpPr>
-          <p:cNvPr id="8" name="Rectangle 7">
-            <a:extLst>
-              <a:ext uri="{FF2B5EF4-FFF2-40B4-BE49-F238E27FC236}">
-                <a16:creationId xmlns:a16="http://schemas.microsoft.com/office/drawing/2014/main" id="{2711C4FE-BB95-49F0-875A-79973572DB57}"/>
-              </a:ext>
-            </a:extLst>
-          </p:cNvPr>
-          <p:cNvSpPr>
-            <a:spLocks noGrp="1"/>
-          </p:cNvSpPr>
-          <p:nvPr/>
-        </p:nvSpPr>
-        <p:spPr>
-          <a:xfrm>
-            <a:off x="8839200" y="2152650"/>
-            <a:ext cx="2324100" cy="323850"/>
+          <p:cNvPr id="10" name="Rectangle 9">
+            <a:extLst>
+              <a:ext uri="{FF2B5EF4-FFF2-40B4-BE49-F238E27FC236}">
+                <a16:creationId xmlns:a16="http://schemas.microsoft.com/office/drawing/2014/main" id="{96D81758-CD88-4EF5-A7F6-B3CD03B93DBF}"/>
+              </a:ext>
+            </a:extLst>
+          </p:cNvPr>
+          <p:cNvSpPr>
+            <a:spLocks noGrp="1"/>
+          </p:cNvSpPr>
+          <p:nvPr/>
+        </p:nvSpPr>
+        <p:spPr>
+          <a:xfrm>
+            <a:off x="8572500" y="3238500"/>
+            <a:ext cx="2540000" cy="508000"/>
           </a:xfrm>
           <a:prstGeom prst="rect">
             <a:avLst/>
@@ -13832,9 +13673,9 @@
           <a:lstStyle/>
           <a:p>
             <a:pPr algn="l">
-              <a:defRPr sz="1650" b="1">
-                <a:solidFill>
-                  <a:srgbClr val="000000"/>
+              <a:defRPr sz="1050" b="0">
+                <a:solidFill>
+                  <a:srgbClr val="59616B"/>
                 </a:solidFill>
                 <a:latin typeface="Helvetica Neue"/>
                 <a:ea typeface="Helvetica Neue"/>
@@ -13842,156 +13683,19 @@
               </a:defRPr>
             </a:pPr>
             <a:r>
-              <a:rPr lang="en-US" sz="1650" b="1">
-                <a:solidFill>
-                  <a:srgbClr val="000000"/>
+              <a:rPr lang="en-US" sz="1100" b="0">
+                <a:solidFill>
+                  <a:srgbClr val="80726B"/>
                 </a:solidFill>
                 <a:latin typeface="Helvetica Neue"/>
                 <a:ea typeface="Helvetica Neue"/>
                 <a:cs typeface="Helvetica Neue"/>
               </a:rPr>
-              <a:t>Step 2 — Toolhead home</a:t>
-            </a:r>
-            <a:endParaRPr sz="1650" b="1">
+              <a:t>Detail shown inside the map. Hover or click another process to compare.</a:t>
+            </a:r>
+            <a:endParaRPr sz="1100" b="0">
               <a:solidFill>
-                <a:srgbClr val="000000"/>
-              </a:solidFill>
-              <a:latin typeface="Helvetica Neue"/>
-              <a:ea typeface="Helvetica Neue"/>
-              <a:cs typeface="Helvetica Neue"/>
-            </a:endParaRPr>
-          </a:p>
-        </p:txBody>
-      </p:sp>
-      <p:sp>
-        <p:nvSpPr>
-          <p:cNvPr id="9" name="Rectangle 8">
-            <a:extLst>
-              <a:ext uri="{FF2B5EF4-FFF2-40B4-BE49-F238E27FC236}">
-                <a16:creationId xmlns:a16="http://schemas.microsoft.com/office/drawing/2014/main" id="{D332E2B0-B79D-428E-A109-130D654AAF30}"/>
-              </a:ext>
-            </a:extLst>
-          </p:cNvPr>
-          <p:cNvSpPr>
-            <a:spLocks noGrp="1"/>
-          </p:cNvSpPr>
-          <p:nvPr/>
-        </p:nvSpPr>
-        <p:spPr>
-          <a:xfrm>
-            <a:off x="8839200" y="2724150"/>
-            <a:ext cx="2247900" cy="1981200"/>
-          </a:xfrm>
-          <a:prstGeom prst="rect">
-            <a:avLst/>
-          </a:prstGeom>
-          <a:noFill/>
-          <a:ln w="0">
-            <a:noFill/>
-            <a:prstDash val="solid"/>
-          </a:ln>
-        </p:spPr>
-        <p:txBody>
-          <a:bodyPr lIns="0" tIns="0" rIns="0" bIns="0" anchor="t">
-            <a:normAutofit/>
-          </a:bodyPr>
-          <a:lstStyle/>
-          <a:p>
-            <a:pPr algn="l">
-              <a:defRPr sz="1350" b="0">
-                <a:solidFill>
-                  <a:srgbClr val="000000"/>
-                </a:solidFill>
-                <a:latin typeface="Helvetica Neue"/>
-                <a:ea typeface="Helvetica Neue"/>
-                <a:cs typeface="Helvetica Neue"/>
-              </a:defRPr>
-            </a:pPr>
-            <a:r>
-              <a:rPr lang="en-US" sz="1350" b="0">
-                <a:solidFill>
-                  <a:srgbClr val="000000"/>
-                </a:solidFill>
-                <a:latin typeface="Helvetica Neue"/>
-                <a:ea typeface="Helvetica Neue"/>
-                <a:cs typeface="Helvetica Neue"/>
-              </a:rPr>
-              <a:t>Request
-P100 asserts the existing GP28 request.
-Pro Micro action
-N20 retracts until GP2 confirms LIFT_HOME.
-Reply
-GP27 returns ready or a timeout becomes a fault.</a:t>
-            </a:r>
-            <a:endParaRPr sz="1350" b="0">
-              <a:solidFill>
-                <a:srgbClr val="000000"/>
-              </a:solidFill>
-              <a:latin typeface="Helvetica Neue"/>
-              <a:ea typeface="Helvetica Neue"/>
-              <a:cs typeface="Helvetica Neue"/>
-            </a:endParaRPr>
-          </a:p>
-        </p:txBody>
-      </p:sp>
-      <p:sp>
-        <p:nvSpPr>
-          <p:cNvPr id="10" name="Rectangle 9">
-            <a:extLst>
-              <a:ext uri="{FF2B5EF4-FFF2-40B4-BE49-F238E27FC236}">
-                <a16:creationId xmlns:a16="http://schemas.microsoft.com/office/drawing/2014/main" id="{96D81758-CD88-4EF5-A7F6-B3CD03B93DBF}"/>
-              </a:ext>
-            </a:extLst>
-          </p:cNvPr>
-          <p:cNvSpPr>
-            <a:spLocks noGrp="1"/>
-          </p:cNvSpPr>
-          <p:nvPr/>
-        </p:nvSpPr>
-        <p:spPr>
-          <a:xfrm>
-            <a:off x="8572500" y="5448300"/>
-            <a:ext cx="2857500" cy="457200"/>
-          </a:xfrm>
-          <a:prstGeom prst="rect">
-            <a:avLst/>
-          </a:prstGeom>
-          <a:noFill/>
-          <a:ln w="0">
-            <a:noFill/>
-            <a:prstDash val="solid"/>
-          </a:ln>
-        </p:spPr>
-        <p:txBody>
-          <a:bodyPr lIns="0" tIns="0" rIns="0" bIns="0" anchor="t">
-            <a:normAutofit/>
-          </a:bodyPr>
-          <a:lstStyle/>
-          <a:p>
-            <a:pPr algn="l">
-              <a:defRPr sz="1050" b="0">
-                <a:solidFill>
-                  <a:srgbClr val="59616B"/>
-                </a:solidFill>
-                <a:latin typeface="Helvetica Neue"/>
-                <a:ea typeface="Helvetica Neue"/>
-                <a:cs typeface="Helvetica Neue"/>
-              </a:defRPr>
-            </a:pPr>
-            <a:r>
-              <a:rPr lang="en-US" sz="1050" b="0">
-                <a:solidFill>
-                  <a:srgbClr val="59616B"/>
-                </a:solidFill>
-                <a:latin typeface="Helvetica Neue"/>
-                <a:ea typeface="Helvetica Neue"/>
-                <a:cs typeface="Helvetica Neue"/>
-              </a:rPr>
-              <a:t>Hover or click another process in the map, or click BACK to return to the overview.</a:t>
-            </a:r>
-            <a:endParaRPr sz="1050" b="0">
-              <a:solidFill>
-                <a:srgbClr val="59616B"/>
+                <a:srgbClr val="80726B"/>
               </a:solidFill>
               <a:latin typeface="Helvetica Neue"/>
               <a:ea typeface="Helvetica Neue"/>
@@ -14536,6 +14240,145 @@
           <a:p>
             <a:pPr algn="ctr"/>
             <a:endParaRPr lang="en-US"/>
+          </a:p>
+        </p:txBody>
+      </p:sp>
+      <p:sp>
+        <p:nvSpPr>
+          <p:cNvPr id="20" name="Matching P100 Map Detail Background">
+            <a:extLst>
+              <a:ext uri="{FF2B5EF4-FFF2-40B4-BE49-F238E27FC236}">
+                <a16:creationId xmlns:a16="http://schemas.microsoft.com/office/drawing/2014/main" id="{DB4135CC-F384-E5B7-5CBA-F519475E9B21}"/>
+              </a:ext>
+            </a:extLst>
+          </p:cNvPr>
+          <p:cNvSpPr/>
+          <p:nvPr/>
+        </p:nvSpPr>
+        <p:spPr>
+          <a:xfrm>
+            <a:off x="4953000" y="2552700"/>
+            <a:ext cx="2159000" cy="1574800"/>
+          </a:xfrm>
+          <a:prstGeom prst="rect">
+            <a:avLst/>
+          </a:prstGeom>
+          <a:solidFill>
+            <a:srgbClr val="2B251F"/>
+          </a:solidFill>
+          <a:ln w="8890">
+            <a:solidFill>
+              <a:srgbClr val="6E6052"/>
+            </a:solidFill>
+          </a:ln>
+        </p:spPr>
+        <p:style>
+          <a:lnRef idx="2">
+            <a:schemeClr val="accent1">
+              <a:shade val="15000"/>
+            </a:schemeClr>
+          </a:lnRef>
+          <a:fillRef idx="1">
+            <a:schemeClr val="accent1"/>
+          </a:fillRef>
+          <a:effectRef idx="0">
+            <a:schemeClr val="accent1"/>
+          </a:effectRef>
+          <a:fontRef idx="minor">
+            <a:schemeClr val="lt1"/>
+          </a:fontRef>
+        </p:style>
+        <p:txBody>
+          <a:bodyPr rtlCol="0" anchor="ctr"/>
+          <a:lstStyle/>
+          <a:p>
+            <a:pPr algn="ctr"/>
+            <a:endParaRPr lang="en-US"/>
+          </a:p>
+        </p:txBody>
+      </p:sp>
+      <p:sp>
+        <p:nvSpPr>
+          <p:cNvPr id="21" name="Matching P100 Map Detail Title">
+            <a:extLst>
+              <a:ext uri="{FF2B5EF4-FFF2-40B4-BE49-F238E27FC236}">
+                <a16:creationId xmlns:a16="http://schemas.microsoft.com/office/drawing/2014/main" id="{8344B0EB-E729-240C-B272-5DC27A7A0657}"/>
+              </a:ext>
+            </a:extLst>
+          </p:cNvPr>
+          <p:cNvSpPr txBox="1"/>
+          <p:nvPr/>
+        </p:nvSpPr>
+        <p:spPr>
+          <a:xfrm>
+            <a:off x="5067300" y="2667000"/>
+            <a:ext cx="1930400" cy="115416"/>
+          </a:xfrm>
+          <a:prstGeom prst="rect">
+            <a:avLst/>
+          </a:prstGeom>
+          <a:noFill/>
+        </p:spPr>
+        <p:txBody>
+          <a:bodyPr vert="horz" lIns="0" tIns="0" rIns="0" bIns="0" rtlCol="0">
+            <a:spAutoFit/>
+          </a:bodyPr>
+          <a:lstStyle/>
+          <a:p>
+            <a:r>
+              <a:rPr lang="en-US" sz="750" b="1">
+                <a:solidFill>
+                  <a:srgbClr val="FFCC66"/>
+                </a:solidFill>
+                <a:latin typeface="Aptos" panose="020B0004020202020204" pitchFamily="34" charset="0"/>
+              </a:rPr>
+              <a:t>2. Toolhead home</a:t>
+            </a:r>
+          </a:p>
+        </p:txBody>
+      </p:sp>
+      <p:sp>
+        <p:nvSpPr>
+          <p:cNvPr id="22" name="Matching P100 Map Detail Body">
+            <a:extLst>
+              <a:ext uri="{FF2B5EF4-FFF2-40B4-BE49-F238E27FC236}">
+                <a16:creationId xmlns:a16="http://schemas.microsoft.com/office/drawing/2014/main" id="{8382FCCD-CCED-A0F4-474A-19C33B23658D}"/>
+              </a:ext>
+            </a:extLst>
+          </p:cNvPr>
+          <p:cNvSpPr txBox="1"/>
+          <p:nvPr/>
+        </p:nvSpPr>
+        <p:spPr>
+          <a:xfrm>
+            <a:off x="5067300" y="2870200"/>
+            <a:ext cx="1930400" cy="787908"/>
+          </a:xfrm>
+          <a:prstGeom prst="rect">
+            <a:avLst/>
+          </a:prstGeom>
+          <a:noFill/>
+        </p:spPr>
+        <p:txBody>
+          <a:bodyPr vert="horz" lIns="0" tIns="0" rIns="0" bIns="0" rtlCol="0">
+            <a:spAutoFit/>
+          </a:bodyPr>
+          <a:lstStyle/>
+          <a:p>
+            <a:r>
+              <a:rPr lang="en-US" sz="640">
+                <a:solidFill>
+                  <a:srgbClr val="F7F4F0"/>
+                </a:solidFill>
+                <a:latin typeface="Aptos" panose="020B0004020202020204" pitchFamily="34" charset="0"/>
+              </a:rPr>
+              <a:t>Request
+P100 asserts GP28.
+Pro Micro action
+N20 retracts until GP2 confirms LIFT_HOME.
+Reply
+GP27 ready, or a timeout becomes a fault.</a:t>
+            </a:r>
           </a:p>
         </p:txBody>
       </p:sp>
@@ -14873,64 +14716,22 @@
       </p:pic>
       <p:sp>
         <p:nvSpPr>
-          <p:cNvPr id="7" name="Rectangle: Rounded Corners 6">
-            <a:extLst>
-              <a:ext uri="{FF2B5EF4-FFF2-40B4-BE49-F238E27FC236}">
-                <a16:creationId xmlns:a16="http://schemas.microsoft.com/office/drawing/2014/main" id="{288213A0-7735-4712-A466-0BAF35E8CDFE}"/>
-              </a:ext>
-            </a:extLst>
-          </p:cNvPr>
-          <p:cNvSpPr>
-            <a:spLocks noGrp="1"/>
-          </p:cNvSpPr>
-          <p:nvPr/>
-        </p:nvSpPr>
-        <p:spPr>
-          <a:xfrm>
-            <a:off x="8572500" y="1847850"/>
-            <a:ext cx="2857500" cy="3371850"/>
-          </a:xfrm>
-          <a:prstGeom prst="roundRect">
-            <a:avLst>
-              <a:gd name="adj" fmla="val 2667"/>
-            </a:avLst>
-          </a:prstGeom>
-          <a:solidFill>
-            <a:srgbClr val="EAF5FB"/>
-          </a:solidFill>
-          <a:ln w="9525">
-            <a:solidFill>
-              <a:srgbClr val="3D8DFF"/>
-            </a:solidFill>
-            <a:prstDash val="solid"/>
-          </a:ln>
-        </p:spPr>
-        <p:txBody>
-          <a:bodyPr/>
-          <a:lstStyle/>
-          <a:p>
-            <a:endParaRPr lang="en-US"/>
-          </a:p>
-        </p:txBody>
-      </p:sp>
-      <p:sp>
-        <p:nvSpPr>
-          <p:cNvPr id="8" name="Rectangle 7">
-            <a:extLst>
-              <a:ext uri="{FF2B5EF4-FFF2-40B4-BE49-F238E27FC236}">
-                <a16:creationId xmlns:a16="http://schemas.microsoft.com/office/drawing/2014/main" id="{2711C4FE-BB95-49F0-875A-79973572DB57}"/>
-              </a:ext>
-            </a:extLst>
-          </p:cNvPr>
-          <p:cNvSpPr>
-            <a:spLocks noGrp="1"/>
-          </p:cNvSpPr>
-          <p:nvPr/>
-        </p:nvSpPr>
-        <p:spPr>
-          <a:xfrm>
-            <a:off x="8839200" y="2152650"/>
-            <a:ext cx="2324100" cy="323850"/>
+          <p:cNvPr id="10" name="Rectangle 9">
+            <a:extLst>
+              <a:ext uri="{FF2B5EF4-FFF2-40B4-BE49-F238E27FC236}">
+                <a16:creationId xmlns:a16="http://schemas.microsoft.com/office/drawing/2014/main" id="{96D81758-CD88-4EF5-A7F6-B3CD03B93DBF}"/>
+              </a:ext>
+            </a:extLst>
+          </p:cNvPr>
+          <p:cNvSpPr>
+            <a:spLocks noGrp="1"/>
+          </p:cNvSpPr>
+          <p:nvPr/>
+        </p:nvSpPr>
+        <p:spPr>
+          <a:xfrm>
+            <a:off x="8572500" y="3238500"/>
+            <a:ext cx="2540000" cy="508000"/>
           </a:xfrm>
           <a:prstGeom prst="rect">
             <a:avLst/>
@@ -14948,9 +14749,9 @@
           <a:lstStyle/>
           <a:p>
             <a:pPr algn="l">
-              <a:defRPr sz="1650" b="1">
-                <a:solidFill>
-                  <a:srgbClr val="000000"/>
+              <a:defRPr sz="1050" b="0">
+                <a:solidFill>
+                  <a:srgbClr val="59616B"/>
                 </a:solidFill>
                 <a:latin typeface="Helvetica Neue"/>
                 <a:ea typeface="Helvetica Neue"/>
@@ -14958,155 +14759,19 @@
               </a:defRPr>
             </a:pPr>
             <a:r>
-              <a:rPr lang="en-US" sz="1650" b="1">
-                <a:solidFill>
-                  <a:srgbClr val="000000"/>
+              <a:rPr lang="en-US" sz="1100" b="0">
+                <a:solidFill>
+                  <a:srgbClr val="80726B"/>
                 </a:solidFill>
                 <a:latin typeface="Helvetica Neue"/>
                 <a:ea typeface="Helvetica Neue"/>
                 <a:cs typeface="Helvetica Neue"/>
               </a:rPr>
-              <a:t>Step 3 — Machine home</a:t>
-            </a:r>
-            <a:endParaRPr sz="1650" b="1">
+              <a:t>Detail shown inside the map. Hover or click another process to compare.</a:t>
+            </a:r>
+            <a:endParaRPr sz="1100" b="0">
               <a:solidFill>
-                <a:srgbClr val="000000"/>
-              </a:solidFill>
-              <a:latin typeface="Helvetica Neue"/>
-              <a:ea typeface="Helvetica Neue"/>
-              <a:cs typeface="Helvetica Neue"/>
-            </a:endParaRPr>
-          </a:p>
-        </p:txBody>
-      </p:sp>
-      <p:sp>
-        <p:nvSpPr>
-          <p:cNvPr id="9" name="Rectangle 8">
-            <a:extLst>
-              <a:ext uri="{FF2B5EF4-FFF2-40B4-BE49-F238E27FC236}">
-                <a16:creationId xmlns:a16="http://schemas.microsoft.com/office/drawing/2014/main" id="{D332E2B0-B79D-428E-A109-130D654AAF30}"/>
-              </a:ext>
-            </a:extLst>
-          </p:cNvPr>
-          <p:cNvSpPr>
-            <a:spLocks noGrp="1"/>
-          </p:cNvSpPr>
-          <p:nvPr/>
-        </p:nvSpPr>
-        <p:spPr>
-          <a:xfrm>
-            <a:off x="8839200" y="2724150"/>
-            <a:ext cx="2247900" cy="1981200"/>
-          </a:xfrm>
-          <a:prstGeom prst="rect">
-            <a:avLst/>
-          </a:prstGeom>
-          <a:noFill/>
-          <a:ln w="0">
-            <a:noFill/>
-            <a:prstDash val="solid"/>
-          </a:ln>
-        </p:spPr>
-        <p:txBody>
-          <a:bodyPr lIns="0" tIns="0" rIns="0" bIns="0" anchor="t">
-            <a:normAutofit/>
-          </a:bodyPr>
-          <a:lstStyle/>
-          <a:p>
-            <a:pPr algn="l">
-              <a:defRPr sz="1350" b="0">
-                <a:solidFill>
-                  <a:srgbClr val="000000"/>
-                </a:solidFill>
-                <a:latin typeface="Helvetica Neue"/>
-                <a:ea typeface="Helvetica Neue"/>
-                <a:cs typeface="Helvetica Neue"/>
-              </a:defRPr>
-            </a:pPr>
-            <a:r>
-              <a:rPr lang="en-US" sz="1350" b="0">
-                <a:solidFill>
-                  <a:srgbClr val="000000"/>
-                </a:solidFill>
-                <a:latin typeface="Helvetica Neue"/>
-                <a:ea typeface="Helvetica Neue"/>
-                <a:cs typeface="Helvetica Neue"/>
-              </a:rPr>
-              <a:t>Command
-RP23CNC runs the normal X/Y home sequence.
-Result
-Physical X/Y switches establish gantry coordinates.
-The toolhead stays at its safe LIFT_HOME state.</a:t>
-            </a:r>
-            <a:endParaRPr sz="1350" b="0">
-              <a:solidFill>
-                <a:srgbClr val="000000"/>
-              </a:solidFill>
-              <a:latin typeface="Helvetica Neue"/>
-              <a:ea typeface="Helvetica Neue"/>
-              <a:cs typeface="Helvetica Neue"/>
-            </a:endParaRPr>
-          </a:p>
-        </p:txBody>
-      </p:sp>
-      <p:sp>
-        <p:nvSpPr>
-          <p:cNvPr id="10" name="Rectangle 9">
-            <a:extLst>
-              <a:ext uri="{FF2B5EF4-FFF2-40B4-BE49-F238E27FC236}">
-                <a16:creationId xmlns:a16="http://schemas.microsoft.com/office/drawing/2014/main" id="{96D81758-CD88-4EF5-A7F6-B3CD03B93DBF}"/>
-              </a:ext>
-            </a:extLst>
-          </p:cNvPr>
-          <p:cNvSpPr>
-            <a:spLocks noGrp="1"/>
-          </p:cNvSpPr>
-          <p:nvPr/>
-        </p:nvSpPr>
-        <p:spPr>
-          <a:xfrm>
-            <a:off x="8572500" y="5448300"/>
-            <a:ext cx="2857500" cy="457200"/>
-          </a:xfrm>
-          <a:prstGeom prst="rect">
-            <a:avLst/>
-          </a:prstGeom>
-          <a:noFill/>
-          <a:ln w="0">
-            <a:noFill/>
-            <a:prstDash val="solid"/>
-          </a:ln>
-        </p:spPr>
-        <p:txBody>
-          <a:bodyPr lIns="0" tIns="0" rIns="0" bIns="0" anchor="t">
-            <a:normAutofit/>
-          </a:bodyPr>
-          <a:lstStyle/>
-          <a:p>
-            <a:pPr algn="l">
-              <a:defRPr sz="1050" b="0">
-                <a:solidFill>
-                  <a:srgbClr val="59616B"/>
-                </a:solidFill>
-                <a:latin typeface="Helvetica Neue"/>
-                <a:ea typeface="Helvetica Neue"/>
-                <a:cs typeface="Helvetica Neue"/>
-              </a:defRPr>
-            </a:pPr>
-            <a:r>
-              <a:rPr lang="en-US" sz="1050" b="0">
-                <a:solidFill>
-                  <a:srgbClr val="59616B"/>
-                </a:solidFill>
-                <a:latin typeface="Helvetica Neue"/>
-                <a:ea typeface="Helvetica Neue"/>
-                <a:cs typeface="Helvetica Neue"/>
-              </a:rPr>
-              <a:t>Hover or click another process in the map, or click BACK to return to the overview.</a:t>
-            </a:r>
-            <a:endParaRPr sz="1050" b="0">
-              <a:solidFill>
-                <a:srgbClr val="59616B"/>
+                <a:srgbClr val="80726B"/>
               </a:solidFill>
               <a:latin typeface="Helvetica Neue"/>
               <a:ea typeface="Helvetica Neue"/>
@@ -15651,6 +15316,144 @@
           <a:p>
             <a:pPr algn="ctr"/>
             <a:endParaRPr lang="en-US"/>
+          </a:p>
+        </p:txBody>
+      </p:sp>
+      <p:sp>
+        <p:nvSpPr>
+          <p:cNvPr id="20" name="Matching P100 Map Detail Background">
+            <a:extLst>
+              <a:ext uri="{FF2B5EF4-FFF2-40B4-BE49-F238E27FC236}">
+                <a16:creationId xmlns:a16="http://schemas.microsoft.com/office/drawing/2014/main" id="{F716E644-4D7F-57F9-C447-5F26B4D7EA2B}"/>
+              </a:ext>
+            </a:extLst>
+          </p:cNvPr>
+          <p:cNvSpPr/>
+          <p:nvPr/>
+        </p:nvSpPr>
+        <p:spPr>
+          <a:xfrm>
+            <a:off x="4953000" y="2552700"/>
+            <a:ext cx="2159000" cy="1574800"/>
+          </a:xfrm>
+          <a:prstGeom prst="rect">
+            <a:avLst/>
+          </a:prstGeom>
+          <a:solidFill>
+            <a:srgbClr val="2B251F"/>
+          </a:solidFill>
+          <a:ln w="8890">
+            <a:solidFill>
+              <a:srgbClr val="6E6052"/>
+            </a:solidFill>
+          </a:ln>
+        </p:spPr>
+        <p:style>
+          <a:lnRef idx="2">
+            <a:schemeClr val="accent1">
+              <a:shade val="15000"/>
+            </a:schemeClr>
+          </a:lnRef>
+          <a:fillRef idx="1">
+            <a:schemeClr val="accent1"/>
+          </a:fillRef>
+          <a:effectRef idx="0">
+            <a:schemeClr val="accent1"/>
+          </a:effectRef>
+          <a:fontRef idx="minor">
+            <a:schemeClr val="lt1"/>
+          </a:fontRef>
+        </p:style>
+        <p:txBody>
+          <a:bodyPr rtlCol="0" anchor="ctr"/>
+          <a:lstStyle/>
+          <a:p>
+            <a:pPr algn="ctr"/>
+            <a:endParaRPr lang="en-US"/>
+          </a:p>
+        </p:txBody>
+      </p:sp>
+      <p:sp>
+        <p:nvSpPr>
+          <p:cNvPr id="21" name="Matching P100 Map Detail Title">
+            <a:extLst>
+              <a:ext uri="{FF2B5EF4-FFF2-40B4-BE49-F238E27FC236}">
+                <a16:creationId xmlns:a16="http://schemas.microsoft.com/office/drawing/2014/main" id="{44103440-044D-FE0D-28C4-DF8B7A91468B}"/>
+              </a:ext>
+            </a:extLst>
+          </p:cNvPr>
+          <p:cNvSpPr txBox="1"/>
+          <p:nvPr/>
+        </p:nvSpPr>
+        <p:spPr>
+          <a:xfrm>
+            <a:off x="5067300" y="2667000"/>
+            <a:ext cx="1930400" cy="115416"/>
+          </a:xfrm>
+          <a:prstGeom prst="rect">
+            <a:avLst/>
+          </a:prstGeom>
+          <a:noFill/>
+        </p:spPr>
+        <p:txBody>
+          <a:bodyPr vert="horz" lIns="0" tIns="0" rIns="0" bIns="0" rtlCol="0">
+            <a:spAutoFit/>
+          </a:bodyPr>
+          <a:lstStyle/>
+          <a:p>
+            <a:r>
+              <a:rPr lang="en-US" sz="750" b="1">
+                <a:solidFill>
+                  <a:srgbClr val="FFCC66"/>
+                </a:solidFill>
+                <a:latin typeface="Aptos" panose="020B0004020202020204" pitchFamily="34" charset="0"/>
+              </a:rPr>
+              <a:t>3. Machine home</a:t>
+            </a:r>
+          </a:p>
+        </p:txBody>
+      </p:sp>
+      <p:sp>
+        <p:nvSpPr>
+          <p:cNvPr id="22" name="Matching P100 Map Detail Body">
+            <a:extLst>
+              <a:ext uri="{FF2B5EF4-FFF2-40B4-BE49-F238E27FC236}">
+                <a16:creationId xmlns:a16="http://schemas.microsoft.com/office/drawing/2014/main" id="{3B504EB3-11C8-5707-6204-5B06E0033E18}"/>
+              </a:ext>
+            </a:extLst>
+          </p:cNvPr>
+          <p:cNvSpPr txBox="1"/>
+          <p:nvPr/>
+        </p:nvSpPr>
+        <p:spPr>
+          <a:xfrm>
+            <a:off x="5067300" y="2870200"/>
+            <a:ext cx="1930400" cy="689420"/>
+          </a:xfrm>
+          <a:prstGeom prst="rect">
+            <a:avLst/>
+          </a:prstGeom>
+          <a:noFill/>
+        </p:spPr>
+        <p:txBody>
+          <a:bodyPr vert="horz" lIns="0" tIns="0" rIns="0" bIns="0" rtlCol="0">
+            <a:spAutoFit/>
+          </a:bodyPr>
+          <a:lstStyle/>
+          <a:p>
+            <a:r>
+              <a:rPr lang="en-US" sz="640">
+                <a:solidFill>
+                  <a:srgbClr val="F7F4F0"/>
+                </a:solidFill>
+                <a:latin typeface="Aptos" panose="020B0004020202020204" pitchFamily="34" charset="0"/>
+              </a:rPr>
+              <a:t>Command
+RP23CNC runs .
+Result
+Physical X/Y switches establish gantry coordinates.
+Toolhead stays at LIFT_HOME.</a:t>
+            </a:r>
           </a:p>
         </p:txBody>
       </p:sp>
@@ -15988,64 +15791,22 @@
       </p:pic>
       <p:sp>
         <p:nvSpPr>
-          <p:cNvPr id="7" name="Rectangle: Rounded Corners 6">
-            <a:extLst>
-              <a:ext uri="{FF2B5EF4-FFF2-40B4-BE49-F238E27FC236}">
-                <a16:creationId xmlns:a16="http://schemas.microsoft.com/office/drawing/2014/main" id="{288213A0-7735-4712-A466-0BAF35E8CDFE}"/>
-              </a:ext>
-            </a:extLst>
-          </p:cNvPr>
-          <p:cNvSpPr>
-            <a:spLocks noGrp="1"/>
-          </p:cNvSpPr>
-          <p:nvPr/>
-        </p:nvSpPr>
-        <p:spPr>
-          <a:xfrm>
-            <a:off x="8572500" y="1847850"/>
-            <a:ext cx="2857500" cy="3371850"/>
-          </a:xfrm>
-          <a:prstGeom prst="roundRect">
-            <a:avLst>
-              <a:gd name="adj" fmla="val 2667"/>
-            </a:avLst>
-          </a:prstGeom>
-          <a:solidFill>
-            <a:srgbClr val="EAF5FB"/>
-          </a:solidFill>
-          <a:ln w="9525">
-            <a:solidFill>
-              <a:srgbClr val="3D8DFF"/>
-            </a:solidFill>
-            <a:prstDash val="solid"/>
-          </a:ln>
-        </p:spPr>
-        <p:txBody>
-          <a:bodyPr/>
-          <a:lstStyle/>
-          <a:p>
-            <a:endParaRPr lang="en-US"/>
-          </a:p>
-        </p:txBody>
-      </p:sp>
-      <p:sp>
-        <p:nvSpPr>
-          <p:cNvPr id="8" name="Rectangle 7">
-            <a:extLst>
-              <a:ext uri="{FF2B5EF4-FFF2-40B4-BE49-F238E27FC236}">
-                <a16:creationId xmlns:a16="http://schemas.microsoft.com/office/drawing/2014/main" id="{2711C4FE-BB95-49F0-875A-79973572DB57}"/>
-              </a:ext>
-            </a:extLst>
-          </p:cNvPr>
-          <p:cNvSpPr>
-            <a:spLocks noGrp="1"/>
-          </p:cNvSpPr>
-          <p:nvPr/>
-        </p:nvSpPr>
-        <p:spPr>
-          <a:xfrm>
-            <a:off x="8839200" y="2152650"/>
-            <a:ext cx="2324100" cy="323850"/>
+          <p:cNvPr id="10" name="Rectangle 9">
+            <a:extLst>
+              <a:ext uri="{FF2B5EF4-FFF2-40B4-BE49-F238E27FC236}">
+                <a16:creationId xmlns:a16="http://schemas.microsoft.com/office/drawing/2014/main" id="{96D81758-CD88-4EF5-A7F6-B3CD03B93DBF}"/>
+              </a:ext>
+            </a:extLst>
+          </p:cNvPr>
+          <p:cNvSpPr>
+            <a:spLocks noGrp="1"/>
+          </p:cNvSpPr>
+          <p:nvPr/>
+        </p:nvSpPr>
+        <p:spPr>
+          <a:xfrm>
+            <a:off x="8572500" y="3238500"/>
+            <a:ext cx="2540000" cy="508000"/>
           </a:xfrm>
           <a:prstGeom prst="rect">
             <a:avLst/>
@@ -16063,9 +15824,9 @@
           <a:lstStyle/>
           <a:p>
             <a:pPr algn="l">
-              <a:defRPr sz="1650" b="1">
-                <a:solidFill>
-                  <a:srgbClr val="000000"/>
+              <a:defRPr sz="1050" b="0">
+                <a:solidFill>
+                  <a:srgbClr val="59616B"/>
                 </a:solidFill>
                 <a:latin typeface="Helvetica Neue"/>
                 <a:ea typeface="Helvetica Neue"/>
@@ -16073,155 +15834,19 @@
               </a:defRPr>
             </a:pPr>
             <a:r>
-              <a:rPr lang="en-US" sz="1650" b="1">
-                <a:solidFill>
-                  <a:srgbClr val="000000"/>
+              <a:rPr lang="en-US" sz="1100" b="0">
+                <a:solidFill>
+                  <a:srgbClr val="80726B"/>
                 </a:solidFill>
                 <a:latin typeface="Helvetica Neue"/>
                 <a:ea typeface="Helvetica Neue"/>
                 <a:cs typeface="Helvetica Neue"/>
               </a:rPr>
-              <a:t>Step 4 — Magnetic registration</a:t>
-            </a:r>
-            <a:endParaRPr sz="1650" b="1">
+              <a:t>Detail shown inside the map. Hover or click another process to compare.</a:t>
+            </a:r>
+            <a:endParaRPr sz="1100" b="0">
               <a:solidFill>
-                <a:srgbClr val="000000"/>
-              </a:solidFill>
-              <a:latin typeface="Helvetica Neue"/>
-              <a:ea typeface="Helvetica Neue"/>
-              <a:cs typeface="Helvetica Neue"/>
-            </a:endParaRPr>
-          </a:p>
-        </p:txBody>
-      </p:sp>
-      <p:sp>
-        <p:nvSpPr>
-          <p:cNvPr id="9" name="Rectangle 8">
-            <a:extLst>
-              <a:ext uri="{FF2B5EF4-FFF2-40B4-BE49-F238E27FC236}">
-                <a16:creationId xmlns:a16="http://schemas.microsoft.com/office/drawing/2014/main" id="{D332E2B0-B79D-428E-A109-130D654AAF30}"/>
-              </a:ext>
-            </a:extLst>
-          </p:cNvPr>
-          <p:cNvSpPr>
-            <a:spLocks noGrp="1"/>
-          </p:cNvSpPr>
-          <p:nvPr/>
-        </p:nvSpPr>
-        <p:spPr>
-          <a:xfrm>
-            <a:off x="8839200" y="2724150"/>
-            <a:ext cx="2247900" cy="1981200"/>
-          </a:xfrm>
-          <a:prstGeom prst="rect">
-            <a:avLst/>
-          </a:prstGeom>
-          <a:noFill/>
-          <a:ln w="0">
-            <a:noFill/>
-            <a:prstDash val="solid"/>
-          </a:ln>
-        </p:spPr>
-        <p:txBody>
-          <a:bodyPr lIns="0" tIns="0" rIns="0" bIns="0" anchor="t">
-            <a:normAutofit/>
-          </a:bodyPr>
-          <a:lstStyle/>
-          <a:p>
-            <a:pPr algn="l">
-              <a:defRPr sz="1350" b="0">
-                <a:solidFill>
-                  <a:srgbClr val="000000"/>
-                </a:solidFill>
-                <a:latin typeface="Helvetica Neue"/>
-                <a:ea typeface="Helvetica Neue"/>
-                <a:cs typeface="Helvetica Neue"/>
-              </a:defRPr>
-            </a:pPr>
-            <a:r>
-              <a:rPr lang="en-US" sz="1350" b="0">
-                <a:solidFill>
-                  <a:srgbClr val="000000"/>
-                </a:solidFill>
-                <a:latin typeface="Helvetica Neue"/>
-                <a:ea typeface="Helvetica Neue"/>
-                <a:cs typeface="Helvetica Neue"/>
-              </a:rPr>
-              <a:t>Request / reply
-GP28 requests the scan; GP27 reports the magnetic result.
-Result
-Center magnet sets G54 X/Y zero.
-Outer magnet sets A zero.</a:t>
-            </a:r>
-            <a:endParaRPr sz="1350" b="0">
-              <a:solidFill>
-                <a:srgbClr val="000000"/>
-              </a:solidFill>
-              <a:latin typeface="Helvetica Neue"/>
-              <a:ea typeface="Helvetica Neue"/>
-              <a:cs typeface="Helvetica Neue"/>
-            </a:endParaRPr>
-          </a:p>
-        </p:txBody>
-      </p:sp>
-      <p:sp>
-        <p:nvSpPr>
-          <p:cNvPr id="10" name="Rectangle 9">
-            <a:extLst>
-              <a:ext uri="{FF2B5EF4-FFF2-40B4-BE49-F238E27FC236}">
-                <a16:creationId xmlns:a16="http://schemas.microsoft.com/office/drawing/2014/main" id="{96D81758-CD88-4EF5-A7F6-B3CD03B93DBF}"/>
-              </a:ext>
-            </a:extLst>
-          </p:cNvPr>
-          <p:cNvSpPr>
-            <a:spLocks noGrp="1"/>
-          </p:cNvSpPr>
-          <p:nvPr/>
-        </p:nvSpPr>
-        <p:spPr>
-          <a:xfrm>
-            <a:off x="8572500" y="5448300"/>
-            <a:ext cx="2857500" cy="457200"/>
-          </a:xfrm>
-          <a:prstGeom prst="rect">
-            <a:avLst/>
-          </a:prstGeom>
-          <a:noFill/>
-          <a:ln w="0">
-            <a:noFill/>
-            <a:prstDash val="solid"/>
-          </a:ln>
-        </p:spPr>
-        <p:txBody>
-          <a:bodyPr lIns="0" tIns="0" rIns="0" bIns="0" anchor="t">
-            <a:normAutofit/>
-          </a:bodyPr>
-          <a:lstStyle/>
-          <a:p>
-            <a:pPr algn="l">
-              <a:defRPr sz="1050" b="0">
-                <a:solidFill>
-                  <a:srgbClr val="59616B"/>
-                </a:solidFill>
-                <a:latin typeface="Helvetica Neue"/>
-                <a:ea typeface="Helvetica Neue"/>
-                <a:cs typeface="Helvetica Neue"/>
-              </a:defRPr>
-            </a:pPr>
-            <a:r>
-              <a:rPr lang="en-US" sz="1050" b="0">
-                <a:solidFill>
-                  <a:srgbClr val="59616B"/>
-                </a:solidFill>
-                <a:latin typeface="Helvetica Neue"/>
-                <a:ea typeface="Helvetica Neue"/>
-                <a:cs typeface="Helvetica Neue"/>
-              </a:rPr>
-              <a:t>Hover or click another process in the map, or click BACK to return to the overview.</a:t>
-            </a:r>
-            <a:endParaRPr sz="1050" b="0">
-              <a:solidFill>
-                <a:srgbClr val="59616B"/>
+                <a:srgbClr val="80726B"/>
               </a:solidFill>
               <a:latin typeface="Helvetica Neue"/>
               <a:ea typeface="Helvetica Neue"/>
@@ -16766,6 +16391,144 @@
           <a:p>
             <a:pPr algn="ctr"/>
             <a:endParaRPr lang="en-US"/>
+          </a:p>
+        </p:txBody>
+      </p:sp>
+      <p:sp>
+        <p:nvSpPr>
+          <p:cNvPr id="20" name="Matching P100 Map Detail Background">
+            <a:extLst>
+              <a:ext uri="{FF2B5EF4-FFF2-40B4-BE49-F238E27FC236}">
+                <a16:creationId xmlns:a16="http://schemas.microsoft.com/office/drawing/2014/main" id="{5F1B77DF-9D79-05EF-5F40-16D2A8667562}"/>
+              </a:ext>
+            </a:extLst>
+          </p:cNvPr>
+          <p:cNvSpPr/>
+          <p:nvPr/>
+        </p:nvSpPr>
+        <p:spPr>
+          <a:xfrm>
+            <a:off x="4953000" y="2552700"/>
+            <a:ext cx="2159000" cy="1574800"/>
+          </a:xfrm>
+          <a:prstGeom prst="rect">
+            <a:avLst/>
+          </a:prstGeom>
+          <a:solidFill>
+            <a:srgbClr val="2B251F"/>
+          </a:solidFill>
+          <a:ln w="8890">
+            <a:solidFill>
+              <a:srgbClr val="6E6052"/>
+            </a:solidFill>
+          </a:ln>
+        </p:spPr>
+        <p:style>
+          <a:lnRef idx="2">
+            <a:schemeClr val="accent1">
+              <a:shade val="15000"/>
+            </a:schemeClr>
+          </a:lnRef>
+          <a:fillRef idx="1">
+            <a:schemeClr val="accent1"/>
+          </a:fillRef>
+          <a:effectRef idx="0">
+            <a:schemeClr val="accent1"/>
+          </a:effectRef>
+          <a:fontRef idx="minor">
+            <a:schemeClr val="lt1"/>
+          </a:fontRef>
+        </p:style>
+        <p:txBody>
+          <a:bodyPr rtlCol="0" anchor="ctr"/>
+          <a:lstStyle/>
+          <a:p>
+            <a:pPr algn="ctr"/>
+            <a:endParaRPr lang="en-US"/>
+          </a:p>
+        </p:txBody>
+      </p:sp>
+      <p:sp>
+        <p:nvSpPr>
+          <p:cNvPr id="21" name="Matching P100 Map Detail Title">
+            <a:extLst>
+              <a:ext uri="{FF2B5EF4-FFF2-40B4-BE49-F238E27FC236}">
+                <a16:creationId xmlns:a16="http://schemas.microsoft.com/office/drawing/2014/main" id="{55434FDA-96C4-A8CC-98E6-504B3F8E5A5A}"/>
+              </a:ext>
+            </a:extLst>
+          </p:cNvPr>
+          <p:cNvSpPr txBox="1"/>
+          <p:nvPr/>
+        </p:nvSpPr>
+        <p:spPr>
+          <a:xfrm>
+            <a:off x="5067300" y="2667000"/>
+            <a:ext cx="1930400" cy="115416"/>
+          </a:xfrm>
+          <a:prstGeom prst="rect">
+            <a:avLst/>
+          </a:prstGeom>
+          <a:noFill/>
+        </p:spPr>
+        <p:txBody>
+          <a:bodyPr vert="horz" lIns="0" tIns="0" rIns="0" bIns="0" rtlCol="0">
+            <a:spAutoFit/>
+          </a:bodyPr>
+          <a:lstStyle/>
+          <a:p>
+            <a:r>
+              <a:rPr lang="en-US" sz="750" b="1">
+                <a:solidFill>
+                  <a:srgbClr val="FFCC66"/>
+                </a:solidFill>
+                <a:latin typeface="Aptos" panose="020B0004020202020204" pitchFamily="34" charset="0"/>
+              </a:rPr>
+              <a:t>4. Magnetic registration</a:t>
+            </a:r>
+          </a:p>
+        </p:txBody>
+      </p:sp>
+      <p:sp>
+        <p:nvSpPr>
+          <p:cNvPr id="22" name="Matching P100 Map Detail Body">
+            <a:extLst>
+              <a:ext uri="{FF2B5EF4-FFF2-40B4-BE49-F238E27FC236}">
+                <a16:creationId xmlns:a16="http://schemas.microsoft.com/office/drawing/2014/main" id="{156CB25D-77C0-DA0C-4FEB-87867AF2EDB9}"/>
+              </a:ext>
+            </a:extLst>
+          </p:cNvPr>
+          <p:cNvSpPr txBox="1"/>
+          <p:nvPr/>
+        </p:nvSpPr>
+        <p:spPr>
+          <a:xfrm>
+            <a:off x="5067300" y="2870200"/>
+            <a:ext cx="1930400" cy="590931"/>
+          </a:xfrm>
+          <a:prstGeom prst="rect">
+            <a:avLst/>
+          </a:prstGeom>
+          <a:noFill/>
+        </p:spPr>
+        <p:txBody>
+          <a:bodyPr vert="horz" lIns="0" tIns="0" rIns="0" bIns="0" rtlCol="0">
+            <a:spAutoFit/>
+          </a:bodyPr>
+          <a:lstStyle/>
+          <a:p>
+            <a:r>
+              <a:rPr lang="en-US" sz="640">
+                <a:solidFill>
+                  <a:srgbClr val="F7F4F0"/>
+                </a:solidFill>
+                <a:latin typeface="Aptos" panose="020B0004020202020204" pitchFamily="34" charset="0"/>
+              </a:rPr>
+              <a:t>Request / reply
+GP28 requests the scan; GP27 reports TMAG.
+Result
+Center magnet sets G54 X/Y zero.
+Outer magnet sets A zero.</a:t>
+            </a:r>
           </a:p>
         </p:txBody>
       </p:sp>

</xml_diff>

<commit_message>
docs: refresh summer presentation opening render
</commit_message>
<xml_diff>
--- a/docs/report/Theta_Pen_Plotter_Summer_Progress_Update.pptx
+++ b/docs/report/Theta_Pen_Plotter_Summer_Progress_Update.pptx
@@ -2124,28 +2124,6 @@
           </a:p>
         </p:txBody>
       </p:sp>
-      <p:pic>
-        <p:nvPicPr>
-          <p:cNvPr id="13" name="Picture 12"/>
-          <p:cNvPicPr>
-            <a:picLocks noChangeAspect="1"/>
-          </p:cNvPicPr>
-          <p:nvPr/>
-        </p:nvPicPr>
-        <p:blipFill>
-          <a:blip r:embed="rId3"/>
-          <a:stretch/>
-        </p:blipFill>
-        <p:spPr>
-          <a:xfrm>
-            <a:off x="6603919" y="552450"/>
-            <a:ext cx="4413411" cy="5334000"/>
-          </a:xfrm>
-          <a:prstGeom prst="rect">
-            <a:avLst/>
-          </a:prstGeom>
-        </p:spPr>
-      </p:pic>
       <p:sp>
         <p:nvSpPr>
           <p:cNvPr id="7" name="Rectangle 6">
@@ -2204,6 +2182,42 @@
           </a:p>
         </p:txBody>
       </p:sp>
+      <p:pic>
+        <p:nvPicPr>
+          <p:cNvPr id="9" name="Picture 12">
+            <a:extLst>
+              <a:ext uri="{FF2B5EF4-FFF2-40B4-BE49-F238E27FC236}">
+                <a16:creationId xmlns:a16="http://schemas.microsoft.com/office/drawing/2014/main" id="{0052B775-B4A3-8E7A-30E8-112F7D9C5314}"/>
+              </a:ext>
+            </a:extLst>
+          </p:cNvPr>
+          <p:cNvPicPr>
+            <a:picLocks/>
+          </p:cNvPicPr>
+          <p:nvPr/>
+        </p:nvPicPr>
+        <p:blipFill>
+          <a:blip r:embed="rId3">
+            <a:extLst>
+              <a:ext uri="{28A0092B-C50C-407E-A947-70E740481C1C}">
+                <a14:useLocalDpi xmlns:a14="http://schemas.microsoft.com/office/drawing/2010/main" val="0"/>
+              </a:ext>
+            </a:extLst>
+          </a:blip>
+          <a:stretch>
+            <a:fillRect/>
+          </a:stretch>
+        </p:blipFill>
+        <p:spPr>
+          <a:xfrm>
+            <a:off x="6882583" y="552450"/>
+            <a:ext cx="3856084" cy="5334000"/>
+          </a:xfrm>
+          <a:prstGeom prst="rect">
+            <a:avLst/>
+          </a:prstGeom>
+        </p:spPr>
+      </p:pic>
     </p:spTree>
     <p:extLst>
       <p:ext uri="{BB962C8B-B14F-4D97-AF65-F5344CB8AC3E}">
@@ -3807,7 +3821,7 @@
         </p:spPr>
         <p:txBody>
           <a:bodyPr lIns="0" tIns="0" rIns="0" bIns="0" anchor="t">
-            <a:normAutofit/>
+            <a:normAutofit fontScale="85000" lnSpcReduction="10000"/>
           </a:bodyPr>
           <a:lstStyle/>
           <a:p>
@@ -4345,7 +4359,7 @@
         </p:spPr>
         <p:txBody>
           <a:bodyPr lIns="0" tIns="0" rIns="0" bIns="0" anchor="t">
-            <a:normAutofit/>
+            <a:normAutofit lnSpcReduction="10000"/>
           </a:bodyPr>
           <a:lstStyle/>
           <a:p>
@@ -5504,7 +5518,7 @@
               </a:defRPr>
             </a:pPr>
             <a:r>
-              <a:rPr sz="1575" b="1">
+              <a:rPr sz="1575" b="1" dirty="0">
                 <a:solidFill>
                   <a:srgbClr val="000000"/>
                 </a:solidFill>
@@ -5512,7 +5526,7 @@
                 <a:ea typeface="Helvetica Neue"/>
                 <a:cs typeface="Helvetica Neue"/>
               </a:rPr>
-              <a:t>Check each writing tool</a:t>
+              <a:t>Check writing tool</a:t>
             </a:r>
           </a:p>
         </p:txBody>
@@ -5562,7 +5576,7 @@
               </a:defRPr>
             </a:pPr>
             <a:r>
-              <a:rPr sz="1200" b="0">
+              <a:rPr sz="1200" b="0" dirty="0">
                 <a:solidFill>
                   <a:srgbClr val="59616B"/>
                 </a:solidFill>
@@ -5570,8 +5584,27 @@
                 <a:ea typeface="Helvetica Neue"/>
                 <a:cs typeface="Helvetica Neue"/>
               </a:rPr>
-              <a:t>Touch and clear before every run; validate pens and pencils.</a:t>
-            </a:r>
+              <a:t>Touch and clear before every run; </a:t>
+            </a:r>
+            <a:r>
+              <a:rPr lang="en-US" sz="1200" b="0" dirty="0">
+                <a:solidFill>
+                  <a:srgbClr val="59616B"/>
+                </a:solidFill>
+                <a:latin typeface="Helvetica Neue"/>
+                <a:ea typeface="Helvetica Neue"/>
+                <a:cs typeface="Helvetica Neue"/>
+              </a:rPr>
+              <a:t>works with pens or pencils.</a:t>
+            </a:r>
+            <a:endParaRPr sz="1200" b="0" dirty="0">
+              <a:solidFill>
+                <a:srgbClr val="59616B"/>
+              </a:solidFill>
+              <a:latin typeface="Helvetica Neue"/>
+              <a:ea typeface="Helvetica Neue"/>
+              <a:cs typeface="Helvetica Neue"/>
+            </a:endParaRPr>
           </a:p>
         </p:txBody>
       </p:sp>
@@ -5687,7 +5720,7 @@
         </p:spPr>
         <p:txBody>
           <a:bodyPr lIns="0" tIns="0" rIns="0" bIns="0" anchor="t">
-            <a:normAutofit fontScale="64653"/>
+            <a:normAutofit fontScale="64653" lnSpcReduction="10000"/>
           </a:bodyPr>
           <a:lstStyle/>
           <a:p>
@@ -5943,7 +5976,7 @@
         </p:spPr>
         <p:txBody>
           <a:bodyPr lIns="0" tIns="0" rIns="0" bIns="0" anchor="t">
-            <a:normAutofit fontScale="60185"/>
+            <a:normAutofit fontScale="67685" lnSpcReduction="10000"/>
           </a:bodyPr>
           <a:lstStyle/>
           <a:p>
@@ -6117,7 +6150,7 @@
         </p:spPr>
         <p:txBody>
           <a:bodyPr lIns="0" tIns="0" rIns="0" bIns="0" anchor="t">
-            <a:normAutofit fontScale="83333"/>
+            <a:normAutofit fontScale="90833" lnSpcReduction="10000"/>
           </a:bodyPr>
           <a:lstStyle/>
           <a:p>
@@ -6286,7 +6319,7 @@
               </a:defRPr>
             </a:pPr>
             <a:r>
-              <a:rPr sz="2700" b="1" dirty="0">
+              <a:rPr lang="en-US" sz="2700" b="1" dirty="0">
                 <a:solidFill>
                   <a:srgbClr val="000000"/>
                 </a:solidFill>
@@ -6294,8 +6327,16 @@
                 <a:ea typeface="Helvetica Neue"/>
                 <a:cs typeface="Helvetica Neue"/>
               </a:rPr>
-              <a:t>The project now has a testable machine architecture—not just a concept</a:t>
-            </a:r>
+              <a:t>Mechanical portion built, wiring in progress</a:t>
+            </a:r>
+            <a:endParaRPr sz="2700" b="1" dirty="0">
+              <a:solidFill>
+                <a:srgbClr val="000000"/>
+              </a:solidFill>
+              <a:latin typeface="Helvetica Neue"/>
+              <a:ea typeface="Helvetica Neue"/>
+              <a:cs typeface="Helvetica Neue"/>
+            </a:endParaRPr>
           </a:p>
         </p:txBody>
       </p:sp>
@@ -6647,7 +6688,9 @@
           </a:bodyPr>
           <a:lstStyle/>
           <a:p>
-            <a:pPr algn="l">
+            <a:pPr marL="285750" indent="-285750" algn="l">
+              <a:buFont typeface="Arial" panose="020B0604020202020204" pitchFamily="34" charset="0"/>
+              <a:buChar char="•"/>
               <a:defRPr sz="1425" b="0">
                 <a:solidFill>
                   <a:srgbClr val="59616B"/>
@@ -6658,7 +6701,7 @@
               </a:defRPr>
             </a:pPr>
             <a:r>
-              <a:rPr sz="1425" b="0">
+              <a:rPr sz="1425" b="0" dirty="0">
                 <a:solidFill>
                   <a:srgbClr val="59616B"/>
                 </a:solidFill>
@@ -6666,7 +6709,194 @@
                 <a:ea typeface="Helvetica Neue"/>
                 <a:cs typeface="Helvetica Neue"/>
               </a:rPr>
-              <a:t>Guided pen carriage, N20 lead-screw actuator, spring compliance, load-cell force path, and printed mounting concepts.</a:t>
+              <a:t>Guided pen carriage</a:t>
+            </a:r>
+            <a:endParaRPr lang="en-US" sz="1425" dirty="0">
+              <a:solidFill>
+                <a:srgbClr val="59616B"/>
+              </a:solidFill>
+              <a:latin typeface="Helvetica Neue"/>
+              <a:ea typeface="Helvetica Neue"/>
+              <a:cs typeface="Helvetica Neue"/>
+            </a:endParaRPr>
+          </a:p>
+          <a:p>
+            <a:pPr marL="285750" indent="-285750" algn="l">
+              <a:buFont typeface="Arial" panose="020B0604020202020204" pitchFamily="34" charset="0"/>
+              <a:buChar char="•"/>
+              <a:defRPr sz="1425" b="0">
+                <a:solidFill>
+                  <a:srgbClr val="59616B"/>
+                </a:solidFill>
+                <a:latin typeface="Helvetica Neue"/>
+                <a:ea typeface="Helvetica Neue"/>
+                <a:cs typeface="Helvetica Neue"/>
+              </a:defRPr>
+            </a:pPr>
+            <a:r>
+              <a:rPr sz="1425" b="0" dirty="0">
+                <a:solidFill>
+                  <a:srgbClr val="59616B"/>
+                </a:solidFill>
+                <a:latin typeface="Helvetica Neue"/>
+                <a:ea typeface="Helvetica Neue"/>
+                <a:cs typeface="Helvetica Neue"/>
+              </a:rPr>
+              <a:t>N20 lead-screw actuator</a:t>
+            </a:r>
+            <a:endParaRPr lang="en-US" sz="1425" dirty="0">
+              <a:solidFill>
+                <a:srgbClr val="59616B"/>
+              </a:solidFill>
+              <a:latin typeface="Helvetica Neue"/>
+              <a:ea typeface="Helvetica Neue"/>
+              <a:cs typeface="Helvetica Neue"/>
+            </a:endParaRPr>
+          </a:p>
+          <a:p>
+            <a:pPr marL="285750" indent="-285750" algn="l">
+              <a:buFont typeface="Arial" panose="020B0604020202020204" pitchFamily="34" charset="0"/>
+              <a:buChar char="•"/>
+              <a:defRPr sz="1425" b="0">
+                <a:solidFill>
+                  <a:srgbClr val="59616B"/>
+                </a:solidFill>
+                <a:latin typeface="Helvetica Neue"/>
+                <a:ea typeface="Helvetica Neue"/>
+                <a:cs typeface="Helvetica Neue"/>
+              </a:defRPr>
+            </a:pPr>
+            <a:r>
+              <a:rPr lang="en-US" sz="1425" b="0" dirty="0">
+                <a:solidFill>
+                  <a:srgbClr val="59616B"/>
+                </a:solidFill>
+                <a:latin typeface="Helvetica Neue"/>
+                <a:ea typeface="Helvetica Neue"/>
+                <a:cs typeface="Helvetica Neue"/>
+              </a:rPr>
+              <a:t>S</a:t>
+            </a:r>
+            <a:r>
+              <a:rPr sz="1425" b="0" dirty="0">
+                <a:solidFill>
+                  <a:srgbClr val="59616B"/>
+                </a:solidFill>
+                <a:latin typeface="Helvetica Neue"/>
+                <a:ea typeface="Helvetica Neue"/>
+                <a:cs typeface="Helvetica Neue"/>
+              </a:rPr>
+              <a:t>pring compliance</a:t>
+            </a:r>
+            <a:endParaRPr lang="en-US" sz="1425" dirty="0">
+              <a:solidFill>
+                <a:srgbClr val="59616B"/>
+              </a:solidFill>
+              <a:latin typeface="Helvetica Neue"/>
+              <a:ea typeface="Helvetica Neue"/>
+              <a:cs typeface="Helvetica Neue"/>
+            </a:endParaRPr>
+          </a:p>
+          <a:p>
+            <a:pPr marL="285750" indent="-285750" algn="l">
+              <a:buFont typeface="Arial" panose="020B0604020202020204" pitchFamily="34" charset="0"/>
+              <a:buChar char="•"/>
+              <a:defRPr sz="1425" b="0">
+                <a:solidFill>
+                  <a:srgbClr val="59616B"/>
+                </a:solidFill>
+                <a:latin typeface="Helvetica Neue"/>
+                <a:ea typeface="Helvetica Neue"/>
+                <a:cs typeface="Helvetica Neue"/>
+              </a:defRPr>
+            </a:pPr>
+            <a:r>
+              <a:rPr lang="en-US" sz="1425" b="0" dirty="0">
+                <a:solidFill>
+                  <a:srgbClr val="59616B"/>
+                </a:solidFill>
+                <a:latin typeface="Helvetica Neue"/>
+                <a:ea typeface="Helvetica Neue"/>
+                <a:cs typeface="Helvetica Neue"/>
+              </a:rPr>
+              <a:t>L</a:t>
+            </a:r>
+            <a:r>
+              <a:rPr sz="1425" b="0" dirty="0">
+                <a:solidFill>
+                  <a:srgbClr val="59616B"/>
+                </a:solidFill>
+                <a:latin typeface="Helvetica Neue"/>
+                <a:ea typeface="Helvetica Neue"/>
+                <a:cs typeface="Helvetica Neue"/>
+              </a:rPr>
+              <a:t>oad</a:t>
+            </a:r>
+            <a:r>
+              <a:rPr lang="en-US" sz="1425" dirty="0">
+                <a:solidFill>
+                  <a:srgbClr val="59616B"/>
+                </a:solidFill>
+                <a:latin typeface="Helvetica Neue"/>
+                <a:ea typeface="Helvetica Neue"/>
+                <a:cs typeface="Helvetica Neue"/>
+              </a:rPr>
+              <a:t>-</a:t>
+            </a:r>
+            <a:r>
+              <a:rPr sz="1425" b="0" dirty="0">
+                <a:solidFill>
+                  <a:srgbClr val="59616B"/>
+                </a:solidFill>
+                <a:latin typeface="Helvetica Neue"/>
+                <a:ea typeface="Helvetica Neue"/>
+                <a:cs typeface="Helvetica Neue"/>
+              </a:rPr>
+              <a:t>cell force path</a:t>
+            </a:r>
+            <a:endParaRPr lang="en-US" sz="1425" b="0" dirty="0">
+              <a:solidFill>
+                <a:srgbClr val="59616B"/>
+              </a:solidFill>
+              <a:latin typeface="Helvetica Neue"/>
+              <a:ea typeface="Helvetica Neue"/>
+              <a:cs typeface="Helvetica Neue"/>
+            </a:endParaRPr>
+          </a:p>
+          <a:p>
+            <a:pPr marL="285750" indent="-285750" algn="l">
+              <a:buFont typeface="Arial" panose="020B0604020202020204" pitchFamily="34" charset="0"/>
+              <a:buChar char="•"/>
+              <a:defRPr sz="1425" b="0">
+                <a:solidFill>
+                  <a:srgbClr val="59616B"/>
+                </a:solidFill>
+                <a:latin typeface="Helvetica Neue"/>
+                <a:ea typeface="Helvetica Neue"/>
+                <a:cs typeface="Helvetica Neue"/>
+              </a:defRPr>
+            </a:pPr>
+            <a:r>
+              <a:rPr lang="en-US" sz="1425" dirty="0">
+                <a:solidFill>
+                  <a:srgbClr val="59616B"/>
+                </a:solidFill>
+                <a:latin typeface="Helvetica Neue"/>
+                <a:ea typeface="Helvetica Neue"/>
+                <a:cs typeface="Helvetica Neue"/>
+              </a:rPr>
+              <a:t>P</a:t>
+            </a:r>
+            <a:r>
+              <a:rPr sz="1425" b="0" dirty="0">
+                <a:solidFill>
+                  <a:srgbClr val="59616B"/>
+                </a:solidFill>
+                <a:latin typeface="Helvetica Neue"/>
+                <a:ea typeface="Helvetica Neue"/>
+                <a:cs typeface="Helvetica Neue"/>
+              </a:rPr>
+              <a:t>rinted mounting concepts.</a:t>
             </a:r>
           </a:p>
         </p:txBody>
@@ -6816,7 +7046,7 @@
               </a:defRPr>
             </a:pPr>
             <a:r>
-              <a:rPr sz="2025" b="1">
+              <a:rPr lang="en-US" sz="2025" b="1" dirty="0">
                 <a:solidFill>
                   <a:srgbClr val="000000"/>
                 </a:solidFill>
@@ -6824,8 +7054,16 @@
                 <a:ea typeface="Helvetica Neue"/>
                 <a:cs typeface="Helvetica Neue"/>
               </a:rPr>
-              <a:t>Defined ownership</a:t>
-            </a:r>
+              <a:t>Ownership definitions</a:t>
+            </a:r>
+            <a:endParaRPr sz="2025" b="1" dirty="0">
+              <a:solidFill>
+                <a:srgbClr val="000000"/>
+              </a:solidFill>
+              <a:latin typeface="Helvetica Neue"/>
+              <a:ea typeface="Helvetica Neue"/>
+              <a:cs typeface="Helvetica Neue"/>
+            </a:endParaRPr>
           </a:p>
         </p:txBody>
       </p:sp>
@@ -6859,11 +7097,13 @@
         </p:spPr>
         <p:txBody>
           <a:bodyPr lIns="0" tIns="0" rIns="0" bIns="0" anchor="t">
-            <a:normAutofit/>
+            <a:normAutofit lnSpcReduction="10000"/>
           </a:bodyPr>
           <a:lstStyle/>
           <a:p>
-            <a:pPr algn="l">
+            <a:pPr marL="285750" indent="-285750" algn="l">
+              <a:buFont typeface="Arial" panose="020B0604020202020204" pitchFamily="34" charset="0"/>
+              <a:buChar char="•"/>
               <a:defRPr sz="1425" b="0">
                 <a:solidFill>
                   <a:srgbClr val="59616B"/>
@@ -6874,7 +7114,7 @@
               </a:defRPr>
             </a:pPr>
             <a:r>
-              <a:rPr sz="1425" b="0">
+              <a:rPr sz="1425" b="0" dirty="0">
                 <a:solidFill>
                   <a:srgbClr val="59616B"/>
                 </a:solidFill>
@@ -6882,7 +7122,84 @@
                 <a:ea typeface="Helvetica Neue"/>
                 <a:cs typeface="Helvetica Neue"/>
               </a:rPr>
-              <a:t>RP23CNC owns X/Y/A motion and registration. The Pro Micro owns N20 motion, force sensing, and toolhead safety.</a:t>
+              <a:t>RP23CNC owns X/Y/A motion </a:t>
+            </a:r>
+            <a:r>
+              <a:rPr lang="en-US" sz="1425" b="0" dirty="0">
+                <a:solidFill>
+                  <a:srgbClr val="59616B"/>
+                </a:solidFill>
+                <a:latin typeface="Helvetica Neue"/>
+                <a:ea typeface="Helvetica Neue"/>
+                <a:cs typeface="Helvetica Neue"/>
+              </a:rPr>
+              <a:t>orchestration</a:t>
+            </a:r>
+            <a:r>
+              <a:rPr sz="1425" b="0" dirty="0">
+                <a:solidFill>
+                  <a:srgbClr val="59616B"/>
+                </a:solidFill>
+                <a:latin typeface="Helvetica Neue"/>
+                <a:ea typeface="Helvetica Neue"/>
+                <a:cs typeface="Helvetica Neue"/>
+              </a:rPr>
+              <a:t>. </a:t>
+            </a:r>
+            <a:endParaRPr lang="en-US" sz="1425" b="0" dirty="0">
+              <a:solidFill>
+                <a:srgbClr val="59616B"/>
+              </a:solidFill>
+              <a:latin typeface="Helvetica Neue"/>
+              <a:ea typeface="Helvetica Neue"/>
+              <a:cs typeface="Helvetica Neue"/>
+            </a:endParaRPr>
+          </a:p>
+          <a:p>
+            <a:pPr marL="285750" indent="-285750" algn="l">
+              <a:buFont typeface="Arial" panose="020B0604020202020204" pitchFamily="34" charset="0"/>
+              <a:buChar char="•"/>
+              <a:defRPr sz="1425" b="0">
+                <a:solidFill>
+                  <a:srgbClr val="59616B"/>
+                </a:solidFill>
+                <a:latin typeface="Helvetica Neue"/>
+                <a:ea typeface="Helvetica Neue"/>
+                <a:cs typeface="Helvetica Neue"/>
+              </a:defRPr>
+            </a:pPr>
+            <a:endParaRPr lang="en-US" sz="1425" b="0" dirty="0">
+              <a:solidFill>
+                <a:srgbClr val="59616B"/>
+              </a:solidFill>
+              <a:latin typeface="Helvetica Neue"/>
+              <a:ea typeface="Helvetica Neue"/>
+              <a:cs typeface="Helvetica Neue"/>
+            </a:endParaRPr>
+          </a:p>
+          <a:p>
+            <a:pPr marL="285750" indent="-285750" algn="l">
+              <a:buFont typeface="Arial" panose="020B0604020202020204" pitchFamily="34" charset="0"/>
+              <a:buChar char="•"/>
+              <a:defRPr sz="1425" b="0">
+                <a:solidFill>
+                  <a:srgbClr val="59616B"/>
+                </a:solidFill>
+                <a:latin typeface="Helvetica Neue"/>
+                <a:ea typeface="Helvetica Neue"/>
+                <a:cs typeface="Helvetica Neue"/>
+              </a:defRPr>
+            </a:pPr>
+            <a:r>
+              <a:rPr sz="1425" b="0" dirty="0">
+                <a:solidFill>
+                  <a:srgbClr val="59616B"/>
+                </a:solidFill>
+                <a:latin typeface="Helvetica Neue"/>
+                <a:ea typeface="Helvetica Neue"/>
+                <a:cs typeface="Helvetica Neue"/>
+              </a:rPr>
+              <a:t>Pro Micro owns N20 motion, force sensing and toolhead safety.</a:t>
             </a:r>
           </a:p>
         </p:txBody>
@@ -6903,7 +7220,7 @@
         </p:nvSpPr>
         <p:spPr>
           <a:xfrm>
-            <a:off x="7867650" y="1809750"/>
+            <a:off x="7858125" y="1809750"/>
             <a:ext cx="3333750" cy="3143250"/>
           </a:xfrm>
           <a:prstGeom prst="roundRect">
@@ -7032,7 +7349,7 @@
               </a:defRPr>
             </a:pPr>
             <a:r>
-              <a:rPr sz="2025" b="1">
+              <a:rPr sz="2025" b="1" dirty="0">
                 <a:solidFill>
                   <a:srgbClr val="000000"/>
                 </a:solidFill>
@@ -7040,8 +7357,27 @@
                 <a:ea typeface="Helvetica Neue"/>
                 <a:cs typeface="Helvetica Neue"/>
               </a:rPr>
-              <a:t>Planned with gates</a:t>
-            </a:r>
+              <a:t>Planne</a:t>
+            </a:r>
+            <a:r>
+              <a:rPr lang="en-US" sz="2025" b="1" dirty="0">
+                <a:solidFill>
+                  <a:srgbClr val="000000"/>
+                </a:solidFill>
+                <a:latin typeface="Helvetica Neue"/>
+                <a:ea typeface="Helvetica Neue"/>
+                <a:cs typeface="Helvetica Neue"/>
+              </a:rPr>
+              <a:t>d</a:t>
+            </a:r>
+            <a:endParaRPr sz="2025" b="1" dirty="0">
+              <a:solidFill>
+                <a:srgbClr val="000000"/>
+              </a:solidFill>
+              <a:latin typeface="Helvetica Neue"/>
+              <a:ea typeface="Helvetica Neue"/>
+              <a:cs typeface="Helvetica Neue"/>
+            </a:endParaRPr>
           </a:p>
         </p:txBody>
       </p:sp>
@@ -7075,7 +7411,7 @@
         </p:spPr>
         <p:txBody>
           <a:bodyPr lIns="0" tIns="0" rIns="0" bIns="0" anchor="t">
-            <a:normAutofit/>
+            <a:normAutofit fontScale="92500" lnSpcReduction="20000"/>
           </a:bodyPr>
           <a:lstStyle/>
           <a:p>
@@ -7090,7 +7426,7 @@
               </a:defRPr>
             </a:pPr>
             <a:r>
-              <a:rPr sz="1425" b="0">
+              <a:rPr lang="en-US" sz="1425" b="0" dirty="0">
                 <a:solidFill>
                   <a:srgbClr val="59616B"/>
                 </a:solidFill>
@@ -7098,8 +7434,248 @@
                 <a:ea typeface="Helvetica Neue"/>
                 <a:cs typeface="Helvetica Neue"/>
               </a:rPr>
-              <a:t>Named bench tests define force calibration, lift-home repeatability, M5 clearance, and interchangeable-tool checks.</a:t>
-            </a:r>
+              <a:t>Test definitions for:</a:t>
+            </a:r>
+          </a:p>
+          <a:p>
+            <a:pPr algn="l">
+              <a:defRPr sz="1425" b="0">
+                <a:solidFill>
+                  <a:srgbClr val="59616B"/>
+                </a:solidFill>
+                <a:latin typeface="Helvetica Neue"/>
+                <a:ea typeface="Helvetica Neue"/>
+                <a:cs typeface="Helvetica Neue"/>
+              </a:defRPr>
+            </a:pPr>
+            <a:endParaRPr lang="en-US" sz="1425" b="0" dirty="0">
+              <a:solidFill>
+                <a:srgbClr val="59616B"/>
+              </a:solidFill>
+              <a:latin typeface="Helvetica Neue"/>
+              <a:ea typeface="Helvetica Neue"/>
+              <a:cs typeface="Helvetica Neue"/>
+            </a:endParaRPr>
+          </a:p>
+          <a:p>
+            <a:pPr marL="285750" indent="-285750" algn="l">
+              <a:buFont typeface="Arial" panose="020B0604020202020204" pitchFamily="34" charset="0"/>
+              <a:buChar char="•"/>
+              <a:defRPr sz="1425" b="0">
+                <a:solidFill>
+                  <a:srgbClr val="59616B"/>
+                </a:solidFill>
+                <a:latin typeface="Helvetica Neue"/>
+                <a:ea typeface="Helvetica Neue"/>
+                <a:cs typeface="Helvetica Neue"/>
+              </a:defRPr>
+            </a:pPr>
+            <a:r>
+              <a:rPr lang="en-US" sz="1425" dirty="0">
+                <a:solidFill>
+                  <a:srgbClr val="59616B"/>
+                </a:solidFill>
+                <a:latin typeface="Helvetica Neue"/>
+                <a:ea typeface="Helvetica Neue"/>
+                <a:cs typeface="Helvetica Neue"/>
+              </a:rPr>
+              <a:t>F</a:t>
+            </a:r>
+            <a:r>
+              <a:rPr sz="1425" b="0" dirty="0">
+                <a:solidFill>
+                  <a:srgbClr val="59616B"/>
+                </a:solidFill>
+                <a:latin typeface="Helvetica Neue"/>
+                <a:ea typeface="Helvetica Neue"/>
+                <a:cs typeface="Helvetica Neue"/>
+              </a:rPr>
+              <a:t>orce calibration</a:t>
+            </a:r>
+            <a:endParaRPr lang="en-US" sz="1425" dirty="0">
+              <a:solidFill>
+                <a:srgbClr val="59616B"/>
+              </a:solidFill>
+              <a:latin typeface="Helvetica Neue"/>
+              <a:ea typeface="Helvetica Neue"/>
+              <a:cs typeface="Helvetica Neue"/>
+            </a:endParaRPr>
+          </a:p>
+          <a:p>
+            <a:pPr marL="285750" indent="-285750" algn="l">
+              <a:buFont typeface="Arial" panose="020B0604020202020204" pitchFamily="34" charset="0"/>
+              <a:buChar char="•"/>
+              <a:defRPr sz="1425" b="0">
+                <a:solidFill>
+                  <a:srgbClr val="59616B"/>
+                </a:solidFill>
+                <a:latin typeface="Helvetica Neue"/>
+                <a:ea typeface="Helvetica Neue"/>
+                <a:cs typeface="Helvetica Neue"/>
+              </a:defRPr>
+            </a:pPr>
+            <a:r>
+              <a:rPr lang="en-US" sz="1425" dirty="0">
+                <a:solidFill>
+                  <a:srgbClr val="59616B"/>
+                </a:solidFill>
+                <a:latin typeface="Helvetica Neue"/>
+                <a:ea typeface="Helvetica Neue"/>
+                <a:cs typeface="Helvetica Neue"/>
+              </a:rPr>
+              <a:t>L</a:t>
+            </a:r>
+            <a:r>
+              <a:rPr sz="1425" b="0" dirty="0">
+                <a:solidFill>
+                  <a:srgbClr val="59616B"/>
+                </a:solidFill>
+                <a:latin typeface="Helvetica Neue"/>
+                <a:ea typeface="Helvetica Neue"/>
+                <a:cs typeface="Helvetica Neue"/>
+              </a:rPr>
+              <a:t>ift</a:t>
+            </a:r>
+            <a:r>
+              <a:rPr lang="en-US" sz="1425" dirty="0">
+                <a:solidFill>
+                  <a:srgbClr val="59616B"/>
+                </a:solidFill>
+                <a:latin typeface="Helvetica Neue"/>
+                <a:ea typeface="Helvetica Neue"/>
+                <a:cs typeface="Helvetica Neue"/>
+              </a:rPr>
+              <a:t>-</a:t>
+            </a:r>
+            <a:r>
+              <a:rPr sz="1425" b="0" dirty="0">
+                <a:solidFill>
+                  <a:srgbClr val="59616B"/>
+                </a:solidFill>
+                <a:latin typeface="Helvetica Neue"/>
+                <a:ea typeface="Helvetica Neue"/>
+                <a:cs typeface="Helvetica Neue"/>
+              </a:rPr>
+              <a:t>home repeatability</a:t>
+            </a:r>
+            <a:endParaRPr lang="en-US" sz="1425" b="0" dirty="0">
+              <a:solidFill>
+                <a:srgbClr val="59616B"/>
+              </a:solidFill>
+              <a:latin typeface="Helvetica Neue"/>
+              <a:ea typeface="Helvetica Neue"/>
+              <a:cs typeface="Helvetica Neue"/>
+            </a:endParaRPr>
+          </a:p>
+          <a:p>
+            <a:pPr marL="285750" indent="-285750" algn="l">
+              <a:buFont typeface="Arial" panose="020B0604020202020204" pitchFamily="34" charset="0"/>
+              <a:buChar char="•"/>
+              <a:defRPr sz="1425" b="0">
+                <a:solidFill>
+                  <a:srgbClr val="59616B"/>
+                </a:solidFill>
+                <a:latin typeface="Helvetica Neue"/>
+                <a:ea typeface="Helvetica Neue"/>
+                <a:cs typeface="Helvetica Neue"/>
+              </a:defRPr>
+            </a:pPr>
+            <a:r>
+              <a:rPr sz="1425" b="0" dirty="0">
+                <a:solidFill>
+                  <a:srgbClr val="59616B"/>
+                </a:solidFill>
+                <a:latin typeface="Helvetica Neue"/>
+                <a:ea typeface="Helvetica Neue"/>
+                <a:cs typeface="Helvetica Neue"/>
+              </a:rPr>
+              <a:t>M5 clearance</a:t>
+            </a:r>
+            <a:endParaRPr lang="en-US" sz="1425" b="0" dirty="0">
+              <a:solidFill>
+                <a:srgbClr val="59616B"/>
+              </a:solidFill>
+              <a:latin typeface="Helvetica Neue"/>
+              <a:ea typeface="Helvetica Neue"/>
+              <a:cs typeface="Helvetica Neue"/>
+            </a:endParaRPr>
+          </a:p>
+          <a:p>
+            <a:pPr marL="285750" indent="-285750" algn="l">
+              <a:buFont typeface="Arial" panose="020B0604020202020204" pitchFamily="34" charset="0"/>
+              <a:buChar char="•"/>
+              <a:defRPr sz="1425" b="0">
+                <a:solidFill>
+                  <a:srgbClr val="59616B"/>
+                </a:solidFill>
+                <a:latin typeface="Helvetica Neue"/>
+                <a:ea typeface="Helvetica Neue"/>
+                <a:cs typeface="Helvetica Neue"/>
+              </a:defRPr>
+            </a:pPr>
+            <a:r>
+              <a:rPr lang="en-US" sz="1425" dirty="0">
+                <a:solidFill>
+                  <a:srgbClr val="59616B"/>
+                </a:solidFill>
+                <a:latin typeface="Helvetica Neue"/>
+                <a:ea typeface="Helvetica Neue"/>
+                <a:cs typeface="Helvetica Neue"/>
+              </a:rPr>
+              <a:t>I</a:t>
+            </a:r>
+            <a:r>
+              <a:rPr sz="1425" b="0" dirty="0">
+                <a:solidFill>
+                  <a:srgbClr val="59616B"/>
+                </a:solidFill>
+                <a:latin typeface="Helvetica Neue"/>
+                <a:ea typeface="Helvetica Neue"/>
+                <a:cs typeface="Helvetica Neue"/>
+              </a:rPr>
+              <a:t>nterchangeable-tool checks</a:t>
+            </a:r>
+            <a:endParaRPr lang="en-US" sz="1425" b="0" dirty="0">
+              <a:solidFill>
+                <a:srgbClr val="59616B"/>
+              </a:solidFill>
+              <a:latin typeface="Helvetica Neue"/>
+              <a:ea typeface="Helvetica Neue"/>
+              <a:cs typeface="Helvetica Neue"/>
+            </a:endParaRPr>
+          </a:p>
+          <a:p>
+            <a:pPr marL="285750" indent="-285750" algn="l">
+              <a:buFont typeface="Arial" panose="020B0604020202020204" pitchFamily="34" charset="0"/>
+              <a:buChar char="•"/>
+              <a:defRPr sz="1425" b="0">
+                <a:solidFill>
+                  <a:srgbClr val="59616B"/>
+                </a:solidFill>
+                <a:latin typeface="Helvetica Neue"/>
+                <a:ea typeface="Helvetica Neue"/>
+                <a:cs typeface="Helvetica Neue"/>
+              </a:defRPr>
+            </a:pPr>
+            <a:r>
+              <a:rPr lang="en-US" sz="1425" dirty="0">
+                <a:solidFill>
+                  <a:srgbClr val="59616B"/>
+                </a:solidFill>
+                <a:latin typeface="Helvetica Neue"/>
+                <a:ea typeface="Helvetica Neue"/>
+                <a:cs typeface="Helvetica Neue"/>
+              </a:rPr>
+              <a:t>Finish motor wiring</a:t>
+            </a:r>
+            <a:endParaRPr sz="1425" b="0" dirty="0">
+              <a:solidFill>
+                <a:srgbClr val="59616B"/>
+              </a:solidFill>
+              <a:latin typeface="Helvetica Neue"/>
+              <a:ea typeface="Helvetica Neue"/>
+              <a:cs typeface="Helvetica Neue"/>
+            </a:endParaRPr>
           </a:p>
         </p:txBody>
       </p:sp>
@@ -7148,7 +7724,7 @@
               </a:defRPr>
             </a:pPr>
             <a:r>
-              <a:rPr sz="1800" b="1">
+              <a:rPr lang="en-US" sz="1800" b="1" dirty="0">
                 <a:solidFill>
                   <a:srgbClr val="000000"/>
                 </a:solidFill>
@@ -7156,8 +7732,38 @@
                 <a:ea typeface="Helvetica Neue"/>
                 <a:cs typeface="Helvetica Neue"/>
               </a:rPr>
-              <a:t>Key point: progress is being documented as measured, test-gated behavior rather than assumed capability.</a:t>
-            </a:r>
+              <a:t>Progress </a:t>
+            </a:r>
+            <a:r>
+              <a:rPr sz="1800" b="1" dirty="0">
+                <a:solidFill>
+                  <a:srgbClr val="000000"/>
+                </a:solidFill>
+                <a:latin typeface="Helvetica Neue"/>
+                <a:ea typeface="Helvetica Neue"/>
+                <a:cs typeface="Helvetica Neue"/>
+              </a:rPr>
+              <a:t>is being documented as measured</a:t>
+            </a:r>
+            <a:r>
+              <a:rPr lang="en-US" sz="1800" b="1" dirty="0">
+                <a:solidFill>
+                  <a:srgbClr val="000000"/>
+                </a:solidFill>
+                <a:latin typeface="Helvetica Neue"/>
+                <a:ea typeface="Helvetica Neue"/>
+                <a:cs typeface="Helvetica Neue"/>
+              </a:rPr>
+              <a:t> tests</a:t>
+            </a:r>
+            <a:endParaRPr sz="1800" b="1" dirty="0">
+              <a:solidFill>
+                <a:srgbClr val="000000"/>
+              </a:solidFill>
+              <a:latin typeface="Helvetica Neue"/>
+              <a:ea typeface="Helvetica Neue"/>
+              <a:cs typeface="Helvetica Neue"/>
+            </a:endParaRPr>
           </a:p>
         </p:txBody>
       </p:sp>
@@ -7849,7 +8455,7 @@
         </p:nvSpPr>
         <p:spPr>
           <a:xfrm>
-            <a:off x="7086600" y="2476500"/>
+            <a:off x="7164777" y="2476500"/>
             <a:ext cx="1809750" cy="1619250"/>
           </a:xfrm>
           <a:prstGeom prst="roundRect">
@@ -7891,7 +8497,7 @@
         </p:nvSpPr>
         <p:spPr>
           <a:xfrm>
-            <a:off x="7258050" y="2724150"/>
+            <a:off x="7336227" y="2724150"/>
             <a:ext cx="1466850" cy="285750"/>
           </a:xfrm>
           <a:prstGeom prst="rect">
@@ -7905,7 +8511,7 @@
         </p:spPr>
         <p:txBody>
           <a:bodyPr lIns="0" tIns="0" rIns="0" bIns="0" anchor="t">
-            <a:normAutofit fontScale="90745"/>
+            <a:normAutofit fontScale="75745" lnSpcReduction="20000"/>
           </a:bodyPr>
           <a:lstStyle/>
           <a:p>
@@ -7949,7 +8555,7 @@
         </p:nvSpPr>
         <p:spPr>
           <a:xfrm>
-            <a:off x="7258050" y="3219450"/>
+            <a:off x="7336227" y="3219450"/>
             <a:ext cx="1466850" cy="666750"/>
           </a:xfrm>
           <a:prstGeom prst="rect">
@@ -8159,7 +8765,7 @@
               </a:defRPr>
             </a:pPr>
             <a:r>
-              <a:rPr sz="1200" b="0">
+              <a:rPr sz="1200" b="0" dirty="0">
                 <a:solidFill>
                   <a:srgbClr val="59616B"/>
                 </a:solidFill>
@@ -8182,7 +8788,7 @@
               </a:defRPr>
             </a:pPr>
             <a:r>
-              <a:rPr sz="1200" b="0">
+              <a:rPr sz="1200" b="0" dirty="0">
                 <a:solidFill>
                   <a:srgbClr val="59616B"/>
                 </a:solidFill>
@@ -8197,10 +8803,10 @@
       </p:sp>
       <p:sp>
         <p:nvSpPr>
-          <p:cNvPr id="18" name="Rectangle 17">
-            <a:extLst>
-              <a:ext uri="{FF2B5EF4-FFF2-40B4-BE49-F238E27FC236}">
-                <a16:creationId xmlns:a16="http://schemas.microsoft.com/office/drawing/2014/main" id="{E82F4AA5-48B0-424F-947B-4A3F28F2125D}"/>
+          <p:cNvPr id="19" name="Rectangle 18">
+            <a:extLst>
+              <a:ext uri="{FF2B5EF4-FFF2-40B4-BE49-F238E27FC236}">
+                <a16:creationId xmlns:a16="http://schemas.microsoft.com/office/drawing/2014/main" id="{12ADFD08-C19E-4DD4-B440-0EDCCE5E0062}"/>
               </a:ext>
             </a:extLst>
           </p:cNvPr>
@@ -8211,48 +8817,8 @@
         </p:nvSpPr>
         <p:spPr>
           <a:xfrm>
-            <a:off x="2209800" y="3067050"/>
-            <a:ext cx="876300" cy="28575"/>
-          </a:xfrm>
-          <a:prstGeom prst="rect">
-            <a:avLst/>
-          </a:prstGeom>
-          <a:solidFill>
-            <a:srgbClr val="3D8DFF"/>
-          </a:solidFill>
-          <a:ln w="0">
-            <a:solidFill>
-              <a:srgbClr val="3D8DFF"/>
-            </a:solidFill>
-            <a:prstDash val="solid"/>
-          </a:ln>
-        </p:spPr>
-        <p:txBody>
-          <a:bodyPr/>
-          <a:lstStyle/>
-          <a:p>
-            <a:endParaRPr lang="en-US"/>
-          </a:p>
-        </p:txBody>
-      </p:sp>
-      <p:sp>
-        <p:nvSpPr>
-          <p:cNvPr id="19" name="Rectangle 18">
-            <a:extLst>
-              <a:ext uri="{FF2B5EF4-FFF2-40B4-BE49-F238E27FC236}">
-                <a16:creationId xmlns:a16="http://schemas.microsoft.com/office/drawing/2014/main" id="{12ADFD08-C19E-4DD4-B440-0EDCCE5E0062}"/>
-              </a:ext>
-            </a:extLst>
-          </p:cNvPr>
-          <p:cNvSpPr>
-            <a:spLocks noGrp="1"/>
-          </p:cNvSpPr>
-          <p:nvPr/>
-        </p:nvSpPr>
-        <p:spPr>
-          <a:xfrm>
-            <a:off x="3105150" y="2933700"/>
-            <a:ext cx="209550" cy="247650"/>
+            <a:off x="2571750" y="2933700"/>
+            <a:ext cx="742950" cy="247650"/>
           </a:xfrm>
           <a:prstGeom prst="rect">
             <a:avLst/>
@@ -8265,7 +8831,7 @@
         </p:spPr>
         <p:txBody>
           <a:bodyPr lIns="0" tIns="0" rIns="0" bIns="0" anchor="t">
-            <a:normAutofit/>
+            <a:noAutofit/>
           </a:bodyPr>
           <a:lstStyle/>
           <a:p>
@@ -8280,7 +8846,7 @@
               </a:defRPr>
             </a:pPr>
             <a:r>
-              <a:rPr sz="1500" b="1">
+              <a:rPr sz="4000" b="1" dirty="0">
                 <a:solidFill>
                   <a:srgbClr val="3D8DFF"/>
                 </a:solidFill>
@@ -8309,7 +8875,7 @@
         </p:nvSpPr>
         <p:spPr>
           <a:xfrm>
-            <a:off x="2133600" y="2667000"/>
+            <a:off x="2245923" y="2667000"/>
             <a:ext cx="1066800" cy="171450"/>
           </a:xfrm>
           <a:prstGeom prst="rect">
@@ -8338,7 +8904,7 @@
               </a:defRPr>
             </a:pPr>
             <a:r>
-              <a:rPr sz="975" b="0">
+              <a:rPr sz="975" b="0" dirty="0">
                 <a:solidFill>
                   <a:srgbClr val="59616B"/>
                 </a:solidFill>
@@ -8353,10 +8919,10 @@
       </p:sp>
       <p:sp>
         <p:nvSpPr>
-          <p:cNvPr id="21" name="Rectangle 20">
-            <a:extLst>
-              <a:ext uri="{FF2B5EF4-FFF2-40B4-BE49-F238E27FC236}">
-                <a16:creationId xmlns:a16="http://schemas.microsoft.com/office/drawing/2014/main" id="{6E227CC2-7CF7-470A-978E-62CD81BF66E3}"/>
+          <p:cNvPr id="22" name="Rectangle 21">
+            <a:extLst>
+              <a:ext uri="{FF2B5EF4-FFF2-40B4-BE49-F238E27FC236}">
+                <a16:creationId xmlns:a16="http://schemas.microsoft.com/office/drawing/2014/main" id="{FB1625C7-F60D-4DBE-9478-34A2FA926DBF}"/>
               </a:ext>
             </a:extLst>
           </p:cNvPr>
@@ -8367,48 +8933,8 @@
         </p:nvSpPr>
         <p:spPr>
           <a:xfrm>
-            <a:off x="6515100" y="3067050"/>
-            <a:ext cx="381000" cy="28575"/>
-          </a:xfrm>
-          <a:prstGeom prst="rect">
-            <a:avLst/>
-          </a:prstGeom>
-          <a:solidFill>
-            <a:srgbClr val="3D8DFF"/>
-          </a:solidFill>
-          <a:ln w="0">
-            <a:solidFill>
-              <a:srgbClr val="3D8DFF"/>
-            </a:solidFill>
-            <a:prstDash val="solid"/>
-          </a:ln>
-        </p:spPr>
-        <p:txBody>
-          <a:bodyPr/>
-          <a:lstStyle/>
-          <a:p>
-            <a:endParaRPr lang="en-US"/>
-          </a:p>
-        </p:txBody>
-      </p:sp>
-      <p:sp>
-        <p:nvSpPr>
-          <p:cNvPr id="22" name="Rectangle 21">
-            <a:extLst>
-              <a:ext uri="{FF2B5EF4-FFF2-40B4-BE49-F238E27FC236}">
-                <a16:creationId xmlns:a16="http://schemas.microsoft.com/office/drawing/2014/main" id="{FB1625C7-F60D-4DBE-9478-34A2FA926DBF}"/>
-              </a:ext>
-            </a:extLst>
-          </p:cNvPr>
-          <p:cNvSpPr>
-            <a:spLocks noGrp="1"/>
-          </p:cNvSpPr>
-          <p:nvPr/>
-        </p:nvSpPr>
-        <p:spPr>
-          <a:xfrm>
-            <a:off x="6915150" y="2933700"/>
-            <a:ext cx="209550" cy="247650"/>
+            <a:off x="6515100" y="2914650"/>
+            <a:ext cx="456481" cy="247650"/>
           </a:xfrm>
           <a:prstGeom prst="rect">
             <a:avLst/>
@@ -8421,7 +8947,7 @@
         </p:spPr>
         <p:txBody>
           <a:bodyPr lIns="0" tIns="0" rIns="0" bIns="0" anchor="t">
-            <a:normAutofit/>
+            <a:noAutofit/>
           </a:bodyPr>
           <a:lstStyle/>
           <a:p>
@@ -8436,7 +8962,7 @@
               </a:defRPr>
             </a:pPr>
             <a:r>
-              <a:rPr sz="1500" b="1">
+              <a:rPr sz="4000" b="1" dirty="0">
                 <a:solidFill>
                   <a:srgbClr val="3D8DFF"/>
                 </a:solidFill>
@@ -8509,10 +9035,10 @@
       </p:sp>
       <p:sp>
         <p:nvSpPr>
-          <p:cNvPr id="24" name="Rectangle 23">
-            <a:extLst>
-              <a:ext uri="{FF2B5EF4-FFF2-40B4-BE49-F238E27FC236}">
-                <a16:creationId xmlns:a16="http://schemas.microsoft.com/office/drawing/2014/main" id="{DB0E7C54-3185-42B7-915D-99B59E0D99B6}"/>
+          <p:cNvPr id="25" name="Rectangle 24">
+            <a:extLst>
+              <a:ext uri="{FF2B5EF4-FFF2-40B4-BE49-F238E27FC236}">
+                <a16:creationId xmlns:a16="http://schemas.microsoft.com/office/drawing/2014/main" id="{979895A4-BAFC-4E3D-9428-DDF97F096842}"/>
               </a:ext>
             </a:extLst>
           </p:cNvPr>
@@ -8523,48 +9049,8 @@
         </p:nvSpPr>
         <p:spPr>
           <a:xfrm>
-            <a:off x="9067800" y="3067050"/>
-            <a:ext cx="876300" cy="28575"/>
-          </a:xfrm>
-          <a:prstGeom prst="rect">
-            <a:avLst/>
-          </a:prstGeom>
-          <a:solidFill>
-            <a:srgbClr val="3D8DFF"/>
-          </a:solidFill>
-          <a:ln w="0">
-            <a:solidFill>
-              <a:srgbClr val="3D8DFF"/>
-            </a:solidFill>
-            <a:prstDash val="solid"/>
-          </a:ln>
-        </p:spPr>
-        <p:txBody>
-          <a:bodyPr/>
-          <a:lstStyle/>
-          <a:p>
-            <a:endParaRPr lang="en-US"/>
-          </a:p>
-        </p:txBody>
-      </p:sp>
-      <p:sp>
-        <p:nvSpPr>
-          <p:cNvPr id="25" name="Rectangle 24">
-            <a:extLst>
-              <a:ext uri="{FF2B5EF4-FFF2-40B4-BE49-F238E27FC236}">
-                <a16:creationId xmlns:a16="http://schemas.microsoft.com/office/drawing/2014/main" id="{979895A4-BAFC-4E3D-9428-DDF97F096842}"/>
-              </a:ext>
-            </a:extLst>
-          </p:cNvPr>
-          <p:cNvSpPr>
-            <a:spLocks noGrp="1"/>
-          </p:cNvSpPr>
-          <p:nvPr/>
-        </p:nvSpPr>
-        <p:spPr>
-          <a:xfrm>
-            <a:off x="9963150" y="2933700"/>
-            <a:ext cx="209550" cy="247650"/>
+            <a:off x="9219481" y="2914650"/>
+            <a:ext cx="686519" cy="285749"/>
           </a:xfrm>
           <a:prstGeom prst="rect">
             <a:avLst/>
@@ -8577,7 +9063,7 @@
         </p:spPr>
         <p:txBody>
           <a:bodyPr lIns="0" tIns="0" rIns="0" bIns="0" anchor="t">
-            <a:normAutofit/>
+            <a:noAutofit/>
           </a:bodyPr>
           <a:lstStyle/>
           <a:p>
@@ -8592,7 +9078,7 @@
               </a:defRPr>
             </a:pPr>
             <a:r>
-              <a:rPr sz="1500" b="1">
+              <a:rPr sz="4000" b="1" dirty="0">
                 <a:solidFill>
                   <a:srgbClr val="3D8DFF"/>
                 </a:solidFill>
@@ -8665,86 +9151,6 @@
       </p:sp>
       <p:sp>
         <p:nvSpPr>
-          <p:cNvPr id="27" name="Rectangle 26">
-            <a:extLst>
-              <a:ext uri="{FF2B5EF4-FFF2-40B4-BE49-F238E27FC236}">
-                <a16:creationId xmlns:a16="http://schemas.microsoft.com/office/drawing/2014/main" id="{19B0D567-13C3-4904-8E80-3E47221EA51D}"/>
-              </a:ext>
-            </a:extLst>
-          </p:cNvPr>
-          <p:cNvSpPr>
-            <a:spLocks noGrp="1"/>
-          </p:cNvSpPr>
-          <p:nvPr/>
-        </p:nvSpPr>
-        <p:spPr>
-          <a:xfrm>
-            <a:off x="8001000" y="4476750"/>
-            <a:ext cx="28575" cy="742950"/>
-          </a:xfrm>
-          <a:prstGeom prst="rect">
-            <a:avLst/>
-          </a:prstGeom>
-          <a:solidFill>
-            <a:srgbClr val="23865B"/>
-          </a:solidFill>
-          <a:ln w="0">
-            <a:solidFill>
-              <a:srgbClr val="23865B"/>
-            </a:solidFill>
-            <a:prstDash val="solid"/>
-          </a:ln>
-        </p:spPr>
-        <p:txBody>
-          <a:bodyPr/>
-          <a:lstStyle/>
-          <a:p>
-            <a:endParaRPr lang="en-US"/>
-          </a:p>
-        </p:txBody>
-      </p:sp>
-      <p:sp>
-        <p:nvSpPr>
-          <p:cNvPr id="28" name="Rectangle 27">
-            <a:extLst>
-              <a:ext uri="{FF2B5EF4-FFF2-40B4-BE49-F238E27FC236}">
-                <a16:creationId xmlns:a16="http://schemas.microsoft.com/office/drawing/2014/main" id="{37EE0DE2-2193-4F59-8C27-772C482F9DA0}"/>
-              </a:ext>
-            </a:extLst>
-          </p:cNvPr>
-          <p:cNvSpPr>
-            <a:spLocks noGrp="1"/>
-          </p:cNvSpPr>
-          <p:nvPr/>
-        </p:nvSpPr>
-        <p:spPr>
-          <a:xfrm>
-            <a:off x="8001000" y="5200650"/>
-            <a:ext cx="3714750" cy="28575"/>
-          </a:xfrm>
-          <a:prstGeom prst="rect">
-            <a:avLst/>
-          </a:prstGeom>
-          <a:solidFill>
-            <a:srgbClr val="23865B"/>
-          </a:solidFill>
-          <a:ln w="0">
-            <a:solidFill>
-              <a:srgbClr val="23865B"/>
-            </a:solidFill>
-            <a:prstDash val="solid"/>
-          </a:ln>
-        </p:spPr>
-        <p:txBody>
-          <a:bodyPr/>
-          <a:lstStyle/>
-          <a:p>
-            <a:endParaRPr lang="en-US"/>
-          </a:p>
-        </p:txBody>
-      </p:sp>
-      <p:sp>
-        <p:nvSpPr>
           <p:cNvPr id="29" name="Rectangle 28">
             <a:extLst>
               <a:ext uri="{FF2B5EF4-FFF2-40B4-BE49-F238E27FC236}">
@@ -8787,20 +9193,582 @@
                 <a:cs typeface="Helvetica Neue"/>
               </a:defRPr>
             </a:pPr>
-            <a:r>
-              <a:rPr sz="1575" b="1">
-                <a:solidFill>
-                  <a:srgbClr val="23865B"/>
-                </a:solidFill>
-                <a:latin typeface="Helvetica Neue"/>
-                <a:ea typeface="Helvetica Neue"/>
-                <a:cs typeface="Helvetica Neue"/>
-              </a:rPr>
-              <a:t>Load-cell feedback stays local to the toolhead; it does not burden the motion controller.</a:t>
-            </a:r>
-          </a:p>
-        </p:txBody>
-      </p:sp>
+            <a:endParaRPr sz="1575" b="1" dirty="0">
+              <a:solidFill>
+                <a:srgbClr val="23865B"/>
+              </a:solidFill>
+              <a:latin typeface="Helvetica Neue"/>
+              <a:ea typeface="Helvetica Neue"/>
+              <a:cs typeface="Helvetica Neue"/>
+            </a:endParaRPr>
+          </a:p>
+        </p:txBody>
+      </p:sp>
+      <p:sp>
+        <p:nvSpPr>
+          <p:cNvPr id="31" name="TextBox 30">
+            <a:extLst>
+              <a:ext uri="{FF2B5EF4-FFF2-40B4-BE49-F238E27FC236}">
+                <a16:creationId xmlns:a16="http://schemas.microsoft.com/office/drawing/2014/main" id="{0D3A7BAC-054A-A2D9-FF0E-359B6DFC8D80}"/>
+              </a:ext>
+            </a:extLst>
+          </p:cNvPr>
+          <p:cNvSpPr txBox="1"/>
+          <p:nvPr/>
+        </p:nvSpPr>
+        <p:spPr>
+          <a:xfrm>
+            <a:off x="7538268" y="1589127"/>
+            <a:ext cx="2462982" cy="369332"/>
+          </a:xfrm>
+          <a:prstGeom prst="rect">
+            <a:avLst/>
+          </a:prstGeom>
+          <a:noFill/>
+        </p:spPr>
+        <p:txBody>
+          <a:bodyPr wrap="none" rtlCol="0">
+            <a:spAutoFit/>
+          </a:bodyPr>
+          <a:lstStyle/>
+          <a:p>
+            <a:r>
+              <a:rPr lang="en-US" dirty="0"/>
+              <a:t>Toolhead control system</a:t>
+            </a:r>
+          </a:p>
+        </p:txBody>
+      </p:sp>
+      <p:sp>
+        <p:nvSpPr>
+          <p:cNvPr id="32" name="TextBox 31">
+            <a:extLst>
+              <a:ext uri="{FF2B5EF4-FFF2-40B4-BE49-F238E27FC236}">
+                <a16:creationId xmlns:a16="http://schemas.microsoft.com/office/drawing/2014/main" id="{D4BD05B5-A0C4-0A1D-F899-0DB6AB6DB2DC}"/>
+              </a:ext>
+            </a:extLst>
+          </p:cNvPr>
+          <p:cNvSpPr txBox="1"/>
+          <p:nvPr/>
+        </p:nvSpPr>
+        <p:spPr>
+          <a:xfrm>
+            <a:off x="599103" y="1586984"/>
+            <a:ext cx="1610697" cy="369332"/>
+          </a:xfrm>
+          <a:prstGeom prst="rect">
+            <a:avLst/>
+          </a:prstGeom>
+          <a:noFill/>
+        </p:spPr>
+        <p:txBody>
+          <a:bodyPr wrap="none" rtlCol="0">
+            <a:spAutoFit/>
+          </a:bodyPr>
+          <a:lstStyle/>
+          <a:p>
+            <a:r>
+              <a:rPr lang="en-US" dirty="0" err="1"/>
+              <a:t>Gcode</a:t>
+            </a:r>
+            <a:r>
+              <a:rPr lang="en-US" dirty="0"/>
+              <a:t> creation</a:t>
+            </a:r>
+          </a:p>
+        </p:txBody>
+      </p:sp>
+      <p:sp>
+        <p:nvSpPr>
+          <p:cNvPr id="33" name="TextBox 32">
+            <a:extLst>
+              <a:ext uri="{FF2B5EF4-FFF2-40B4-BE49-F238E27FC236}">
+                <a16:creationId xmlns:a16="http://schemas.microsoft.com/office/drawing/2014/main" id="{9B8E5E04-7CB0-72FA-D318-4A55F9341DF2}"/>
+              </a:ext>
+            </a:extLst>
+          </p:cNvPr>
+          <p:cNvSpPr txBox="1"/>
+          <p:nvPr/>
+        </p:nvSpPr>
+        <p:spPr>
+          <a:xfrm>
+            <a:off x="4223089" y="1583293"/>
+            <a:ext cx="1269322" cy="369332"/>
+          </a:xfrm>
+          <a:prstGeom prst="rect">
+            <a:avLst/>
+          </a:prstGeom>
+          <a:noFill/>
+        </p:spPr>
+        <p:txBody>
+          <a:bodyPr wrap="none" rtlCol="0">
+            <a:spAutoFit/>
+          </a:bodyPr>
+          <a:lstStyle/>
+          <a:p>
+            <a:r>
+              <a:rPr lang="en-US" dirty="0"/>
+              <a:t>Movement </a:t>
+            </a:r>
+          </a:p>
+        </p:txBody>
+      </p:sp>
+      <p:cxnSp>
+        <p:nvCxnSpPr>
+          <p:cNvPr id="35" name="Straight Connector 34">
+            <a:extLst>
+              <a:ext uri="{FF2B5EF4-FFF2-40B4-BE49-F238E27FC236}">
+                <a16:creationId xmlns:a16="http://schemas.microsoft.com/office/drawing/2014/main" id="{E955FDB0-DDC8-C5C8-A8B8-08EB424FA541}"/>
+              </a:ext>
+            </a:extLst>
+          </p:cNvPr>
+          <p:cNvCxnSpPr>
+            <a:cxnSpLocks/>
+          </p:cNvCxnSpPr>
+          <p:nvPr/>
+        </p:nvCxnSpPr>
+        <p:spPr>
+          <a:xfrm flipV="1">
+            <a:off x="5650302" y="1767959"/>
+            <a:ext cx="1360098" cy="3691"/>
+          </a:xfrm>
+          <a:prstGeom prst="line">
+            <a:avLst/>
+          </a:prstGeom>
+        </p:spPr>
+        <p:style>
+          <a:lnRef idx="1">
+            <a:schemeClr val="accent1"/>
+          </a:lnRef>
+          <a:fillRef idx="0">
+            <a:schemeClr val="accent1"/>
+          </a:fillRef>
+          <a:effectRef idx="0">
+            <a:schemeClr val="accent1"/>
+          </a:effectRef>
+          <a:fontRef idx="minor">
+            <a:schemeClr val="tx1"/>
+          </a:fontRef>
+        </p:style>
+      </p:cxnSp>
+      <p:cxnSp>
+        <p:nvCxnSpPr>
+          <p:cNvPr id="38" name="Straight Connector 37">
+            <a:extLst>
+              <a:ext uri="{FF2B5EF4-FFF2-40B4-BE49-F238E27FC236}">
+                <a16:creationId xmlns:a16="http://schemas.microsoft.com/office/drawing/2014/main" id="{E357C412-84B9-6F1B-C162-0223C1FB42D1}"/>
+              </a:ext>
+            </a:extLst>
+          </p:cNvPr>
+          <p:cNvCxnSpPr>
+            <a:cxnSpLocks/>
+          </p:cNvCxnSpPr>
+          <p:nvPr/>
+        </p:nvCxnSpPr>
+        <p:spPr>
+          <a:xfrm>
+            <a:off x="7010400" y="1767959"/>
+            <a:ext cx="0" cy="518041"/>
+          </a:xfrm>
+          <a:prstGeom prst="line">
+            <a:avLst/>
+          </a:prstGeom>
+        </p:spPr>
+        <p:style>
+          <a:lnRef idx="1">
+            <a:schemeClr val="accent1"/>
+          </a:lnRef>
+          <a:fillRef idx="0">
+            <a:schemeClr val="accent1"/>
+          </a:fillRef>
+          <a:effectRef idx="0">
+            <a:schemeClr val="accent1"/>
+          </a:effectRef>
+          <a:fontRef idx="minor">
+            <a:schemeClr val="tx1"/>
+          </a:fontRef>
+        </p:style>
+      </p:cxnSp>
+      <p:cxnSp>
+        <p:nvCxnSpPr>
+          <p:cNvPr id="40" name="Straight Connector 39">
+            <a:extLst>
+              <a:ext uri="{FF2B5EF4-FFF2-40B4-BE49-F238E27FC236}">
+                <a16:creationId xmlns:a16="http://schemas.microsoft.com/office/drawing/2014/main" id="{E02FA32B-5236-35B6-6B7E-FE20E1817A37}"/>
+              </a:ext>
+            </a:extLst>
+          </p:cNvPr>
+          <p:cNvCxnSpPr>
+            <a:cxnSpLocks/>
+          </p:cNvCxnSpPr>
+          <p:nvPr/>
+        </p:nvCxnSpPr>
+        <p:spPr>
+          <a:xfrm>
+            <a:off x="3336625" y="1767959"/>
+            <a:ext cx="680049" cy="0"/>
+          </a:xfrm>
+          <a:prstGeom prst="line">
+            <a:avLst/>
+          </a:prstGeom>
+        </p:spPr>
+        <p:style>
+          <a:lnRef idx="1">
+            <a:schemeClr val="accent1"/>
+          </a:lnRef>
+          <a:fillRef idx="0">
+            <a:schemeClr val="accent1"/>
+          </a:fillRef>
+          <a:effectRef idx="0">
+            <a:schemeClr val="accent1"/>
+          </a:effectRef>
+          <a:fontRef idx="minor">
+            <a:schemeClr val="tx1"/>
+          </a:fontRef>
+        </p:style>
+      </p:cxnSp>
+      <p:cxnSp>
+        <p:nvCxnSpPr>
+          <p:cNvPr id="43" name="Straight Connector 42">
+            <a:extLst>
+              <a:ext uri="{FF2B5EF4-FFF2-40B4-BE49-F238E27FC236}">
+                <a16:creationId xmlns:a16="http://schemas.microsoft.com/office/drawing/2014/main" id="{29407F56-2D95-693D-921E-554F59250BA0}"/>
+              </a:ext>
+            </a:extLst>
+          </p:cNvPr>
+          <p:cNvCxnSpPr>
+            <a:cxnSpLocks/>
+          </p:cNvCxnSpPr>
+          <p:nvPr/>
+        </p:nvCxnSpPr>
+        <p:spPr>
+          <a:xfrm>
+            <a:off x="3345252" y="1767959"/>
+            <a:ext cx="0" cy="518041"/>
+          </a:xfrm>
+          <a:prstGeom prst="line">
+            <a:avLst/>
+          </a:prstGeom>
+        </p:spPr>
+        <p:style>
+          <a:lnRef idx="1">
+            <a:schemeClr val="accent1"/>
+          </a:lnRef>
+          <a:fillRef idx="0">
+            <a:schemeClr val="accent1"/>
+          </a:fillRef>
+          <a:effectRef idx="0">
+            <a:schemeClr val="accent1"/>
+          </a:effectRef>
+          <a:fontRef idx="minor">
+            <a:schemeClr val="tx1"/>
+          </a:fontRef>
+        </p:style>
+      </p:cxnSp>
+      <p:cxnSp>
+        <p:nvCxnSpPr>
+          <p:cNvPr id="44" name="Straight Connector 43">
+            <a:extLst>
+              <a:ext uri="{FF2B5EF4-FFF2-40B4-BE49-F238E27FC236}">
+                <a16:creationId xmlns:a16="http://schemas.microsoft.com/office/drawing/2014/main" id="{7BA17C8C-D580-937E-19C0-082D6F033052}"/>
+              </a:ext>
+            </a:extLst>
+          </p:cNvPr>
+          <p:cNvCxnSpPr>
+            <a:cxnSpLocks/>
+          </p:cNvCxnSpPr>
+          <p:nvPr/>
+        </p:nvCxnSpPr>
+        <p:spPr>
+          <a:xfrm>
+            <a:off x="7142851" y="1767959"/>
+            <a:ext cx="310372" cy="0"/>
+          </a:xfrm>
+          <a:prstGeom prst="line">
+            <a:avLst/>
+          </a:prstGeom>
+        </p:spPr>
+        <p:style>
+          <a:lnRef idx="1">
+            <a:schemeClr val="accent1"/>
+          </a:lnRef>
+          <a:fillRef idx="0">
+            <a:schemeClr val="accent1"/>
+          </a:fillRef>
+          <a:effectRef idx="0">
+            <a:schemeClr val="accent1"/>
+          </a:effectRef>
+          <a:fontRef idx="minor">
+            <a:schemeClr val="tx1"/>
+          </a:fontRef>
+        </p:style>
+      </p:cxnSp>
+      <p:cxnSp>
+        <p:nvCxnSpPr>
+          <p:cNvPr id="45" name="Straight Connector 44">
+            <a:extLst>
+              <a:ext uri="{FF2B5EF4-FFF2-40B4-BE49-F238E27FC236}">
+                <a16:creationId xmlns:a16="http://schemas.microsoft.com/office/drawing/2014/main" id="{575A4A5E-9B01-71CE-F590-571AC4A58CDC}"/>
+              </a:ext>
+            </a:extLst>
+          </p:cNvPr>
+          <p:cNvCxnSpPr>
+            <a:cxnSpLocks/>
+          </p:cNvCxnSpPr>
+          <p:nvPr/>
+        </p:nvCxnSpPr>
+        <p:spPr>
+          <a:xfrm>
+            <a:off x="7151478" y="1767959"/>
+            <a:ext cx="0" cy="518041"/>
+          </a:xfrm>
+          <a:prstGeom prst="line">
+            <a:avLst/>
+          </a:prstGeom>
+        </p:spPr>
+        <p:style>
+          <a:lnRef idx="1">
+            <a:schemeClr val="accent1"/>
+          </a:lnRef>
+          <a:fillRef idx="0">
+            <a:schemeClr val="accent1"/>
+          </a:fillRef>
+          <a:effectRef idx="0">
+            <a:schemeClr val="accent1"/>
+          </a:effectRef>
+          <a:fontRef idx="minor">
+            <a:schemeClr val="tx1"/>
+          </a:fontRef>
+        </p:style>
+      </p:cxnSp>
+      <p:cxnSp>
+        <p:nvCxnSpPr>
+          <p:cNvPr id="47" name="Straight Connector 46">
+            <a:extLst>
+              <a:ext uri="{FF2B5EF4-FFF2-40B4-BE49-F238E27FC236}">
+                <a16:creationId xmlns:a16="http://schemas.microsoft.com/office/drawing/2014/main" id="{BFFC8D22-746A-CE42-186B-8EA1FBE3DE00}"/>
+              </a:ext>
+            </a:extLst>
+          </p:cNvPr>
+          <p:cNvCxnSpPr>
+            <a:cxnSpLocks/>
+          </p:cNvCxnSpPr>
+          <p:nvPr/>
+        </p:nvCxnSpPr>
+        <p:spPr>
+          <a:xfrm>
+            <a:off x="10086295" y="1764268"/>
+            <a:ext cx="1696130" cy="0"/>
+          </a:xfrm>
+          <a:prstGeom prst="line">
+            <a:avLst/>
+          </a:prstGeom>
+        </p:spPr>
+        <p:style>
+          <a:lnRef idx="1">
+            <a:schemeClr val="accent1"/>
+          </a:lnRef>
+          <a:fillRef idx="0">
+            <a:schemeClr val="accent1"/>
+          </a:fillRef>
+          <a:effectRef idx="0">
+            <a:schemeClr val="accent1"/>
+          </a:effectRef>
+          <a:fontRef idx="minor">
+            <a:schemeClr val="tx1"/>
+          </a:fontRef>
+        </p:style>
+      </p:cxnSp>
+      <p:cxnSp>
+        <p:nvCxnSpPr>
+          <p:cNvPr id="48" name="Straight Connector 47">
+            <a:extLst>
+              <a:ext uri="{FF2B5EF4-FFF2-40B4-BE49-F238E27FC236}">
+                <a16:creationId xmlns:a16="http://schemas.microsoft.com/office/drawing/2014/main" id="{30B1708B-7705-026C-BE7C-93FF0AB8FE31}"/>
+              </a:ext>
+            </a:extLst>
+          </p:cNvPr>
+          <p:cNvCxnSpPr>
+            <a:cxnSpLocks/>
+          </p:cNvCxnSpPr>
+          <p:nvPr/>
+        </p:nvCxnSpPr>
+        <p:spPr>
+          <a:xfrm>
+            <a:off x="11782425" y="1764268"/>
+            <a:ext cx="0" cy="518041"/>
+          </a:xfrm>
+          <a:prstGeom prst="line">
+            <a:avLst/>
+          </a:prstGeom>
+        </p:spPr>
+        <p:style>
+          <a:lnRef idx="1">
+            <a:schemeClr val="accent1"/>
+          </a:lnRef>
+          <a:fillRef idx="0">
+            <a:schemeClr val="accent1"/>
+          </a:fillRef>
+          <a:effectRef idx="0">
+            <a:schemeClr val="accent1"/>
+          </a:effectRef>
+          <a:fontRef idx="minor">
+            <a:schemeClr val="tx1"/>
+          </a:fontRef>
+        </p:style>
+      </p:cxnSp>
+      <p:cxnSp>
+        <p:nvCxnSpPr>
+          <p:cNvPr id="50" name="Straight Connector 49">
+            <a:extLst>
+              <a:ext uri="{FF2B5EF4-FFF2-40B4-BE49-F238E27FC236}">
+                <a16:creationId xmlns:a16="http://schemas.microsoft.com/office/drawing/2014/main" id="{72A3932B-CCA3-5A25-A68A-B951A027AF50}"/>
+              </a:ext>
+            </a:extLst>
+          </p:cNvPr>
+          <p:cNvCxnSpPr>
+            <a:cxnSpLocks/>
+          </p:cNvCxnSpPr>
+          <p:nvPr/>
+        </p:nvCxnSpPr>
+        <p:spPr>
+          <a:xfrm>
+            <a:off x="213144" y="1764268"/>
+            <a:ext cx="295814" cy="7382"/>
+          </a:xfrm>
+          <a:prstGeom prst="line">
+            <a:avLst/>
+          </a:prstGeom>
+        </p:spPr>
+        <p:style>
+          <a:lnRef idx="1">
+            <a:schemeClr val="accent1"/>
+          </a:lnRef>
+          <a:fillRef idx="0">
+            <a:schemeClr val="accent1"/>
+          </a:fillRef>
+          <a:effectRef idx="0">
+            <a:schemeClr val="accent1"/>
+          </a:effectRef>
+          <a:fontRef idx="minor">
+            <a:schemeClr val="tx1"/>
+          </a:fontRef>
+        </p:style>
+      </p:cxnSp>
+      <p:cxnSp>
+        <p:nvCxnSpPr>
+          <p:cNvPr id="51" name="Straight Connector 50">
+            <a:extLst>
+              <a:ext uri="{FF2B5EF4-FFF2-40B4-BE49-F238E27FC236}">
+                <a16:creationId xmlns:a16="http://schemas.microsoft.com/office/drawing/2014/main" id="{1BEFD1C8-ED86-36D3-4E2D-0E0F131FF231}"/>
+              </a:ext>
+            </a:extLst>
+          </p:cNvPr>
+          <p:cNvCxnSpPr>
+            <a:cxnSpLocks/>
+          </p:cNvCxnSpPr>
+          <p:nvPr/>
+        </p:nvCxnSpPr>
+        <p:spPr>
+          <a:xfrm>
+            <a:off x="221771" y="1764268"/>
+            <a:ext cx="0" cy="518041"/>
+          </a:xfrm>
+          <a:prstGeom prst="line">
+            <a:avLst/>
+          </a:prstGeom>
+        </p:spPr>
+        <p:style>
+          <a:lnRef idx="1">
+            <a:schemeClr val="accent1"/>
+          </a:lnRef>
+          <a:fillRef idx="0">
+            <a:schemeClr val="accent1"/>
+          </a:fillRef>
+          <a:effectRef idx="0">
+            <a:schemeClr val="accent1"/>
+          </a:effectRef>
+          <a:fontRef idx="minor">
+            <a:schemeClr val="tx1"/>
+          </a:fontRef>
+        </p:style>
+      </p:cxnSp>
+      <p:cxnSp>
+        <p:nvCxnSpPr>
+          <p:cNvPr id="53" name="Straight Connector 52">
+            <a:extLst>
+              <a:ext uri="{FF2B5EF4-FFF2-40B4-BE49-F238E27FC236}">
+                <a16:creationId xmlns:a16="http://schemas.microsoft.com/office/drawing/2014/main" id="{0685462D-C93E-8BA5-1982-DF52469C66EC}"/>
+              </a:ext>
+            </a:extLst>
+          </p:cNvPr>
+          <p:cNvCxnSpPr>
+            <a:cxnSpLocks/>
+          </p:cNvCxnSpPr>
+          <p:nvPr/>
+        </p:nvCxnSpPr>
+        <p:spPr>
+          <a:xfrm>
+            <a:off x="2290133" y="1764268"/>
+            <a:ext cx="813989" cy="0"/>
+          </a:xfrm>
+          <a:prstGeom prst="line">
+            <a:avLst/>
+          </a:prstGeom>
+        </p:spPr>
+        <p:style>
+          <a:lnRef idx="1">
+            <a:schemeClr val="accent1"/>
+          </a:lnRef>
+          <a:fillRef idx="0">
+            <a:schemeClr val="accent1"/>
+          </a:fillRef>
+          <a:effectRef idx="0">
+            <a:schemeClr val="accent1"/>
+          </a:effectRef>
+          <a:fontRef idx="minor">
+            <a:schemeClr val="tx1"/>
+          </a:fontRef>
+        </p:style>
+      </p:cxnSp>
+      <p:cxnSp>
+        <p:nvCxnSpPr>
+          <p:cNvPr id="54" name="Straight Connector 53">
+            <a:extLst>
+              <a:ext uri="{FF2B5EF4-FFF2-40B4-BE49-F238E27FC236}">
+                <a16:creationId xmlns:a16="http://schemas.microsoft.com/office/drawing/2014/main" id="{6EAE1648-79C4-BEBA-4B8F-734B2A7B3DC6}"/>
+              </a:ext>
+            </a:extLst>
+          </p:cNvPr>
+          <p:cNvCxnSpPr>
+            <a:cxnSpLocks/>
+          </p:cNvCxnSpPr>
+          <p:nvPr/>
+        </p:nvCxnSpPr>
+        <p:spPr>
+          <a:xfrm>
+            <a:off x="3104122" y="1764268"/>
+            <a:ext cx="0" cy="518041"/>
+          </a:xfrm>
+          <a:prstGeom prst="line">
+            <a:avLst/>
+          </a:prstGeom>
+        </p:spPr>
+        <p:style>
+          <a:lnRef idx="1">
+            <a:schemeClr val="accent1"/>
+          </a:lnRef>
+          <a:fillRef idx="0">
+            <a:schemeClr val="accent1"/>
+          </a:fillRef>
+          <a:effectRef idx="0">
+            <a:schemeClr val="accent1"/>
+          </a:effectRef>
+          <a:fontRef idx="minor">
+            <a:schemeClr val="tx1"/>
+          </a:fontRef>
+        </p:style>
+      </p:cxnSp>
     </p:spTree>
     <p:extLst>
       <p:ext uri="{BB962C8B-B14F-4D97-AF65-F5344CB8AC3E}">
@@ -8927,7 +9895,7 @@
         </p:spPr>
         <p:txBody>
           <a:bodyPr lIns="0" tIns="0" rIns="0" bIns="0" anchor="t">
-            <a:normAutofit fontScale="90443"/>
+            <a:normAutofit fontScale="90443" lnSpcReduction="20000"/>
           </a:bodyPr>
           <a:lstStyle/>
           <a:p>
@@ -8942,7 +9910,7 @@
               </a:defRPr>
             </a:pPr>
             <a:r>
-              <a:rPr sz="2700" b="1">
+              <a:rPr sz="2700" b="1" dirty="0">
                 <a:solidFill>
                   <a:srgbClr val="000000"/>
                 </a:solidFill>
@@ -8950,8 +9918,27 @@
                 <a:ea typeface="Helvetica Neue"/>
                 <a:cs typeface="Helvetica Neue"/>
               </a:rPr>
-              <a:t>Homing establishes two different references: machine position and toolhead safety</a:t>
-            </a:r>
+              <a:t>Homing establishes two different references: machine position and toolhead </a:t>
+            </a:r>
+            <a:r>
+              <a:rPr lang="en-US" sz="2700" b="1" dirty="0">
+                <a:solidFill>
+                  <a:srgbClr val="000000"/>
+                </a:solidFill>
+                <a:latin typeface="Helvetica Neue"/>
+                <a:ea typeface="Helvetica Neue"/>
+                <a:cs typeface="Helvetica Neue"/>
+              </a:rPr>
+              <a:t>touch calibration</a:t>
+            </a:r>
+            <a:endParaRPr sz="2700" b="1" dirty="0">
+              <a:solidFill>
+                <a:srgbClr val="000000"/>
+              </a:solidFill>
+              <a:latin typeface="Helvetica Neue"/>
+              <a:ea typeface="Helvetica Neue"/>
+              <a:cs typeface="Helvetica Neue"/>
+            </a:endParaRPr>
           </a:p>
         </p:txBody>
       </p:sp>
@@ -9256,7 +10243,7 @@
               </a:defRPr>
             </a:pPr>
             <a:r>
-              <a:rPr sz="1425" b="1">
+              <a:rPr sz="1425" b="1" dirty="0">
                 <a:solidFill>
                   <a:srgbClr val="000000"/>
                 </a:solidFill>
@@ -9515,7 +10502,7 @@
         </p:spPr>
         <p:txBody>
           <a:bodyPr lIns="0" tIns="0" rIns="0" bIns="0" anchor="t">
-            <a:normAutofit/>
+            <a:normAutofit lnSpcReduction="10000"/>
           </a:bodyPr>
           <a:lstStyle/>
           <a:p>
@@ -9530,7 +10517,7 @@
               </a:defRPr>
             </a:pPr>
             <a:r>
-              <a:rPr sz="1425" b="1">
+              <a:rPr sz="1425" b="1" dirty="0">
                 <a:solidFill>
                   <a:srgbClr val="000000"/>
                 </a:solidFill>
@@ -9538,8 +10525,49 @@
                 <a:ea typeface="Helvetica Neue"/>
                 <a:cs typeface="Helvetica Neue"/>
               </a:rPr>
-              <a:t>Pro Micro verifies GP2 switch</a:t>
-            </a:r>
+              <a:t>Pro Micro verifies </a:t>
+            </a:r>
+            <a:r>
+              <a:rPr lang="en-US" sz="1425" b="1" dirty="0">
+                <a:solidFill>
+                  <a:srgbClr val="000000"/>
+                </a:solidFill>
+                <a:latin typeface="Helvetica Neue"/>
+                <a:ea typeface="Helvetica Neue"/>
+                <a:cs typeface="Helvetica Neue"/>
+              </a:rPr>
+              <a:t>toolhead</a:t>
+            </a:r>
+            <a:r>
+              <a:rPr sz="1425" b="1" dirty="0">
+                <a:solidFill>
+                  <a:srgbClr val="000000"/>
+                </a:solidFill>
+                <a:latin typeface="Helvetica Neue"/>
+                <a:ea typeface="Helvetica Neue"/>
+                <a:cs typeface="Helvetica Neue"/>
+              </a:rPr>
+              <a:t> switch</a:t>
+            </a:r>
+            <a:r>
+              <a:rPr lang="en-US" sz="1425" b="1" dirty="0">
+                <a:solidFill>
+                  <a:srgbClr val="000000"/>
+                </a:solidFill>
+                <a:latin typeface="Helvetica Neue"/>
+                <a:ea typeface="Helvetica Neue"/>
+                <a:cs typeface="Helvetica Neue"/>
+              </a:rPr>
+              <a:t> trigger</a:t>
+            </a:r>
+            <a:endParaRPr sz="1425" b="1" dirty="0">
+              <a:solidFill>
+                <a:srgbClr val="000000"/>
+              </a:solidFill>
+              <a:latin typeface="Helvetica Neue"/>
+              <a:ea typeface="Helvetica Neue"/>
+              <a:cs typeface="Helvetica Neue"/>
+            </a:endParaRPr>
           </a:p>
         </p:txBody>
       </p:sp>
@@ -9804,7 +10832,7 @@
               </a:defRPr>
             </a:pPr>
             <a:r>
-              <a:rPr sz="1425" b="1">
+              <a:rPr sz="1425" b="1" dirty="0">
                 <a:solidFill>
                   <a:srgbClr val="000000"/>
                 </a:solidFill>
@@ -10468,7 +11496,7 @@
               </a:defRPr>
             </a:pPr>
             <a:r>
-              <a:rPr sz="1650" b="1">
+              <a:rPr sz="1650" b="1" dirty="0">
                 <a:solidFill>
                   <a:srgbClr val="000000"/>
                 </a:solidFill>
@@ -10476,7 +11504,29 @@
                 <a:ea typeface="Helvetica Neue"/>
                 <a:cs typeface="Helvetica Neue"/>
               </a:rPr>
-              <a:t>The GP2 switch remains local to the Pro Micro; the existing GP28/GP27 pair lets P100 receive the result without another RP23CNC pin.</a:t>
+              <a:t>The </a:t>
+            </a:r>
+            <a:r>
+              <a:rPr lang="en-US" sz="1650" b="1" dirty="0">
+                <a:solidFill>
+                  <a:srgbClr val="000000"/>
+                </a:solidFill>
+                <a:latin typeface="Helvetica Neue"/>
+                <a:ea typeface="Helvetica Neue"/>
+                <a:cs typeface="Helvetica Neue"/>
+              </a:rPr>
+              <a:t>toolhead</a:t>
+            </a:r>
+            <a:r>
+              <a:rPr sz="1650" b="1" dirty="0">
+                <a:solidFill>
+                  <a:srgbClr val="000000"/>
+                </a:solidFill>
+                <a:latin typeface="Helvetica Neue"/>
+                <a:ea typeface="Helvetica Neue"/>
+                <a:cs typeface="Helvetica Neue"/>
+              </a:rPr>
+              <a:t> switch remains local to the Pro Micro; the existing GP28/GP27 pair lets P100 receive the result without another RP23CNC pin.</a:t>
             </a:r>
           </a:p>
         </p:txBody>

</xml_diff>

<commit_message>
docs: make opening slide full bleed
</commit_message>
<xml_diff>
--- a/docs/report/Theta_Pen_Plotter_Summer_Progress_Update.pptx
+++ b/docs/report/Theta_Pen_Plotter_Summer_Progress_Update.pptx
@@ -1824,210 +1824,6 @@
       </p:grpSpPr>
       <p:sp>
         <p:nvSpPr>
-          <p:cNvPr id="8" name="Rectangle 7">
-            <a:extLst>
-              <a:ext uri="{FF2B5EF4-FFF2-40B4-BE49-F238E27FC236}">
-                <a16:creationId xmlns:a16="http://schemas.microsoft.com/office/drawing/2014/main" id="{7A7D2EF2-BFA3-4766-B942-23E570E48309}"/>
-              </a:ext>
-            </a:extLst>
-          </p:cNvPr>
-          <p:cNvSpPr>
-            <a:spLocks noGrp="1"/>
-          </p:cNvSpPr>
-          <p:nvPr/>
-        </p:nvSpPr>
-        <p:spPr>
-          <a:xfrm>
-            <a:off x="400050" y="419100"/>
-            <a:ext cx="4953000" cy="266700"/>
-          </a:xfrm>
-          <a:prstGeom prst="rect">
-            <a:avLst/>
-          </a:prstGeom>
-          <a:noFill/>
-          <a:ln w="0">
-            <a:noFill/>
-            <a:prstDash val="solid"/>
-          </a:ln>
-        </p:spPr>
-        <p:txBody>
-          <a:bodyPr lIns="0" tIns="0" rIns="0" bIns="0" anchor="t">
-            <a:normAutofit/>
-          </a:bodyPr>
-          <a:lstStyle/>
-          <a:p>
-            <a:pPr algn="l">
-              <a:defRPr sz="1200" b="1">
-                <a:solidFill>
-                  <a:srgbClr val="3D8DFF"/>
-                </a:solidFill>
-                <a:latin typeface="Helvetica Neue"/>
-                <a:ea typeface="Helvetica Neue"/>
-                <a:cs typeface="Helvetica Neue"/>
-              </a:defRPr>
-            </a:pPr>
-            <a:r>
-              <a:rPr sz="1200" b="1">
-                <a:solidFill>
-                  <a:srgbClr val="3D8DFF"/>
-                </a:solidFill>
-                <a:latin typeface="Helvetica Neue"/>
-                <a:ea typeface="Helvetica Neue"/>
-                <a:cs typeface="Helvetica Neue"/>
-              </a:rPr>
-              <a:t>SUMMER PROGRESS UPDATE</a:t>
-            </a:r>
-          </a:p>
-        </p:txBody>
-      </p:sp>
-      <p:sp>
-        <p:nvSpPr>
-          <p:cNvPr id="2" name="Rectangle 1">
-            <a:extLst>
-              <a:ext uri="{FF2B5EF4-FFF2-40B4-BE49-F238E27FC236}">
-                <a16:creationId xmlns:a16="http://schemas.microsoft.com/office/drawing/2014/main" id="{6C209B30-5687-4D31-B45B-B18289FD1874}"/>
-              </a:ext>
-            </a:extLst>
-          </p:cNvPr>
-          <p:cNvSpPr>
-            <a:spLocks noGrp="1"/>
-          </p:cNvSpPr>
-          <p:nvPr/>
-        </p:nvSpPr>
-        <p:spPr>
-          <a:xfrm>
-            <a:off x="400050" y="1104900"/>
-            <a:ext cx="5334000" cy="1066800"/>
-          </a:xfrm>
-          <a:prstGeom prst="rect">
-            <a:avLst/>
-          </a:prstGeom>
-          <a:noFill/>
-          <a:ln w="0">
-            <a:noFill/>
-            <a:prstDash val="solid"/>
-          </a:ln>
-        </p:spPr>
-        <p:txBody>
-          <a:bodyPr lIns="0" tIns="0" rIns="0" bIns="0" anchor="t">
-            <a:normAutofit fontScale="85000" lnSpcReduction="10000"/>
-          </a:bodyPr>
-          <a:lstStyle/>
-          <a:p>
-            <a:pPr algn="l">
-              <a:defRPr sz="4800" b="1">
-                <a:solidFill>
-                  <a:srgbClr val="000000"/>
-                </a:solidFill>
-                <a:latin typeface="Helvetica Neue"/>
-                <a:ea typeface="Helvetica Neue"/>
-                <a:cs typeface="Helvetica Neue"/>
-              </a:defRPr>
-            </a:pPr>
-            <a:r>
-              <a:rPr lang="en-US" sz="4800" b="1" dirty="0">
-                <a:solidFill>
-                  <a:srgbClr val="000000"/>
-                </a:solidFill>
-                <a:latin typeface="Helvetica Neue"/>
-                <a:ea typeface="Helvetica Neue"/>
-                <a:cs typeface="Helvetica Neue"/>
-              </a:rPr>
-              <a:t>XY </a:t>
-            </a:r>
-            <a:r>
-              <a:rPr sz="4800" b="1" dirty="0">
-                <a:solidFill>
-                  <a:srgbClr val="000000"/>
-                </a:solidFill>
-                <a:latin typeface="Helvetica Neue"/>
-                <a:ea typeface="Helvetica Neue"/>
-                <a:cs typeface="Helvetica Neue"/>
-              </a:rPr>
-              <a:t>Theta Pen Plotter</a:t>
-            </a:r>
-          </a:p>
-        </p:txBody>
-      </p:sp>
-      <p:sp>
-        <p:nvSpPr>
-          <p:cNvPr id="3" name="Rectangle 2">
-            <a:extLst>
-              <a:ext uri="{FF2B5EF4-FFF2-40B4-BE49-F238E27FC236}">
-                <a16:creationId xmlns:a16="http://schemas.microsoft.com/office/drawing/2014/main" id="{D7D776E8-8ED9-48FA-BCA2-259250FFD263}"/>
-              </a:ext>
-            </a:extLst>
-          </p:cNvPr>
-          <p:cNvSpPr>
-            <a:spLocks noGrp="1"/>
-          </p:cNvSpPr>
-          <p:nvPr/>
-        </p:nvSpPr>
-        <p:spPr>
-          <a:xfrm>
-            <a:off x="400050" y="2438400"/>
-            <a:ext cx="4953000" cy="1104900"/>
-          </a:xfrm>
-          <a:prstGeom prst="rect">
-            <a:avLst/>
-          </a:prstGeom>
-          <a:noFill/>
-          <a:ln w="0">
-            <a:noFill/>
-            <a:prstDash val="solid"/>
-          </a:ln>
-        </p:spPr>
-        <p:txBody>
-          <a:bodyPr lIns="0" tIns="0" rIns="0" bIns="0" anchor="t">
-            <a:normAutofit/>
-          </a:bodyPr>
-          <a:lstStyle/>
-          <a:p>
-            <a:pPr algn="l">
-              <a:defRPr sz="2025" b="0">
-                <a:solidFill>
-                  <a:srgbClr val="59616B"/>
-                </a:solidFill>
-                <a:latin typeface="Helvetica Neue"/>
-                <a:ea typeface="Helvetica Neue"/>
-                <a:cs typeface="Helvetica Neue"/>
-              </a:defRPr>
-            </a:pPr>
-            <a:r>
-              <a:rPr lang="en-US" sz="2025" b="0" dirty="0">
-                <a:solidFill>
-                  <a:srgbClr val="59616B"/>
-                </a:solidFill>
-                <a:latin typeface="Helvetica Neue"/>
-                <a:ea typeface="Helvetica Neue"/>
-                <a:cs typeface="Helvetica Neue"/>
-              </a:rPr>
-              <a:t>Path to </a:t>
-            </a:r>
-            <a:r>
-              <a:rPr lang="en-US" sz="2025" b="0" dirty="0" err="1">
-                <a:solidFill>
-                  <a:srgbClr val="59616B"/>
-                </a:solidFill>
-                <a:latin typeface="Helvetica Neue"/>
-                <a:ea typeface="Helvetica Neue"/>
-                <a:cs typeface="Helvetica Neue"/>
-              </a:rPr>
-              <a:t>commisioning</a:t>
-            </a:r>
-            <a:endParaRPr sz="2025" b="0" dirty="0">
-              <a:solidFill>
-                <a:srgbClr val="59616B"/>
-              </a:solidFill>
-              <a:latin typeface="Helvetica Neue"/>
-              <a:ea typeface="Helvetica Neue"/>
-              <a:cs typeface="Helvetica Neue"/>
-            </a:endParaRPr>
-          </a:p>
-        </p:txBody>
-      </p:sp>
-      <p:sp>
-        <p:nvSpPr>
           <p:cNvPr id="4" name="Rectangle 3">
             <a:extLst>
               <a:ext uri="{FF2B5EF4-FFF2-40B4-BE49-F238E27FC236}">
@@ -2066,128 +1862,12 @@
           </a:p>
         </p:txBody>
       </p:sp>
-      <p:sp>
-        <p:nvSpPr>
-          <p:cNvPr id="5" name="Rectangle 4">
-            <a:extLst>
-              <a:ext uri="{FF2B5EF4-FFF2-40B4-BE49-F238E27FC236}">
-                <a16:creationId xmlns:a16="http://schemas.microsoft.com/office/drawing/2014/main" id="{FD70773F-8C93-41F1-9E9B-6EE3F437BD4A}"/>
-              </a:ext>
-            </a:extLst>
-          </p:cNvPr>
-          <p:cNvSpPr>
-            <a:spLocks noGrp="1"/>
-          </p:cNvSpPr>
-          <p:nvPr/>
-        </p:nvSpPr>
-        <p:spPr>
-          <a:xfrm>
-            <a:off x="400050" y="4171950"/>
-            <a:ext cx="4762500" cy="266700"/>
-          </a:xfrm>
-          <a:prstGeom prst="rect">
-            <a:avLst/>
-          </a:prstGeom>
-          <a:noFill/>
-          <a:ln w="0">
-            <a:noFill/>
-            <a:prstDash val="solid"/>
-          </a:ln>
-        </p:spPr>
-        <p:txBody>
-          <a:bodyPr lIns="0" tIns="0" rIns="0" bIns="0" anchor="t">
-            <a:normAutofit/>
-          </a:bodyPr>
-          <a:lstStyle/>
-          <a:p>
-            <a:pPr algn="l">
-              <a:defRPr sz="1350" b="0">
-                <a:solidFill>
-                  <a:srgbClr val="000000"/>
-                </a:solidFill>
-                <a:latin typeface="Helvetica Neue"/>
-                <a:ea typeface="Helvetica Neue"/>
-                <a:cs typeface="Helvetica Neue"/>
-              </a:defRPr>
-            </a:pPr>
-            <a:r>
-              <a:rPr sz="1350" b="0">
-                <a:solidFill>
-                  <a:srgbClr val="000000"/>
-                </a:solidFill>
-                <a:latin typeface="Helvetica Neue"/>
-                <a:ea typeface="Helvetica Neue"/>
-                <a:cs typeface="Helvetica Neue"/>
-              </a:rPr>
-              <a:t>Course progress update  •  September 2026</a:t>
-            </a:r>
-          </a:p>
-        </p:txBody>
-      </p:sp>
-      <p:sp>
-        <p:nvSpPr>
-          <p:cNvPr id="7" name="Rectangle 6">
-            <a:extLst>
-              <a:ext uri="{FF2B5EF4-FFF2-40B4-BE49-F238E27FC236}">
-                <a16:creationId xmlns:a16="http://schemas.microsoft.com/office/drawing/2014/main" id="{105FB2DD-B9EE-4E50-ACD4-DD43F4B76831}"/>
-              </a:ext>
-            </a:extLst>
-          </p:cNvPr>
-          <p:cNvSpPr>
-            <a:spLocks noGrp="1"/>
-          </p:cNvSpPr>
-          <p:nvPr/>
-        </p:nvSpPr>
-        <p:spPr>
-          <a:xfrm>
-            <a:off x="6191250" y="5829300"/>
-            <a:ext cx="5238750" cy="342900"/>
-          </a:xfrm>
-          <a:prstGeom prst="rect">
-            <a:avLst/>
-          </a:prstGeom>
-          <a:noFill/>
-          <a:ln w="0">
-            <a:noFill/>
-            <a:prstDash val="solid"/>
-          </a:ln>
-        </p:spPr>
-        <p:txBody>
-          <a:bodyPr lIns="0" tIns="0" rIns="0" bIns="0" anchor="t">
-            <a:normAutofit/>
-          </a:bodyPr>
-          <a:lstStyle/>
-          <a:p>
-            <a:pPr algn="l">
-              <a:defRPr sz="1050" b="0">
-                <a:solidFill>
-                  <a:srgbClr val="59616B"/>
-                </a:solidFill>
-                <a:latin typeface="Helvetica Neue"/>
-                <a:ea typeface="Helvetica Neue"/>
-                <a:cs typeface="Helvetica Neue"/>
-              </a:defRPr>
-            </a:pPr>
-            <a:r>
-              <a:rPr sz="1050" b="0">
-                <a:solidFill>
-                  <a:srgbClr val="59616B"/>
-                </a:solidFill>
-                <a:latin typeface="Helvetica Neue"/>
-                <a:ea typeface="Helvetica Neue"/>
-                <a:cs typeface="Helvetica Neue"/>
-              </a:rPr>
-              <a:t>The toolhead combines an N20 lead-screw actuator, spring compliance, load cell, and guided pen carriage.</a:t>
-            </a:r>
-          </a:p>
-        </p:txBody>
-      </p:sp>
       <p:pic>
         <p:nvPicPr>
-          <p:cNvPr id="9" name="Picture 12">
-            <a:extLst>
-              <a:ext uri="{FF2B5EF4-FFF2-40B4-BE49-F238E27FC236}">
-                <a16:creationId xmlns:a16="http://schemas.microsoft.com/office/drawing/2014/main" id="{0052B775-B4A3-8E7A-30E8-112F7D9C5314}"/>
+          <p:cNvPr id="10" name="Opening Toolhead Full Bleed">
+            <a:extLst>
+              <a:ext uri="{FF2B5EF4-FFF2-40B4-BE49-F238E27FC236}">
+                <a16:creationId xmlns:a16="http://schemas.microsoft.com/office/drawing/2014/main" id="{DA8C5DBD-3C34-FC5A-DF05-78EDD8B1E610}"/>
               </a:ext>
             </a:extLst>
           </p:cNvPr>
@@ -2204,20 +1884,475 @@
               </a:ext>
             </a:extLst>
           </a:blip>
+          <a:srcRect t="4477" b="4477"/>
           <a:stretch>
             <a:fillRect/>
           </a:stretch>
         </p:blipFill>
         <p:spPr>
           <a:xfrm>
-            <a:off x="6882583" y="552450"/>
-            <a:ext cx="3856084" cy="5334000"/>
+            <a:off x="0" y="307031"/>
+            <a:ext cx="12192000" cy="6243938"/>
           </a:xfrm>
           <a:prstGeom prst="rect">
             <a:avLst/>
           </a:prstGeom>
         </p:spPr>
       </p:pic>
+      <p:sp>
+        <p:nvSpPr>
+          <p:cNvPr id="11" name="Opening Title Readability Panel">
+            <a:extLst>
+              <a:ext uri="{FF2B5EF4-FFF2-40B4-BE49-F238E27FC236}">
+                <a16:creationId xmlns:a16="http://schemas.microsoft.com/office/drawing/2014/main" id="{395FC5DE-808B-9D4B-47B9-D54C0F32F3AD}"/>
+              </a:ext>
+            </a:extLst>
+          </p:cNvPr>
+          <p:cNvSpPr/>
+          <p:nvPr/>
+        </p:nvSpPr>
+        <p:spPr>
+          <a:xfrm>
+            <a:off x="0" y="0"/>
+            <a:ext cx="6667500" cy="6858000"/>
+          </a:xfrm>
+          <a:prstGeom prst="rect">
+            <a:avLst/>
+          </a:prstGeom>
+          <a:solidFill>
+            <a:srgbClr val="081420">
+              <a:alpha val="82000"/>
+            </a:srgbClr>
+          </a:solidFill>
+          <a:ln w="19050">
+            <a:noFill/>
+            <a:prstDash val="solid"/>
+          </a:ln>
+          <a:effectLst/>
+          <a:extLst>
+            <a:ext uri="{91240B29-F687-4F45-9708-019B960494DF}">
+              <a14:hiddenLine xmlns:a14="http://schemas.microsoft.com/office/drawing/2010/main" w="19050">
+                <a:solidFill>
+                  <a:schemeClr val="accent1">
+                    <a:shade val="15000"/>
+                  </a:schemeClr>
+                </a:solidFill>
+                <a:prstDash val="solid"/>
+              </a14:hiddenLine>
+            </a:ext>
+          </a:extLst>
+        </p:spPr>
+        <p:style>
+          <a:lnRef idx="2">
+            <a:schemeClr val="accent1">
+              <a:shade val="15000"/>
+            </a:schemeClr>
+          </a:lnRef>
+          <a:fillRef idx="1">
+            <a:schemeClr val="accent1"/>
+          </a:fillRef>
+          <a:effectRef idx="0">
+            <a:schemeClr val="accent1"/>
+          </a:effectRef>
+          <a:fontRef idx="minor">
+            <a:schemeClr val="lt1"/>
+          </a:fontRef>
+        </p:style>
+        <p:txBody>
+          <a:bodyPr rtlCol="0" anchor="ctr"/>
+          <a:lstStyle/>
+          <a:p>
+            <a:pPr algn="ctr"/>
+            <a:endParaRPr lang="en-US"/>
+          </a:p>
+        </p:txBody>
+      </p:sp>
+      <p:sp>
+        <p:nvSpPr>
+          <p:cNvPr id="8" name="Rectangle 7">
+            <a:extLst>
+              <a:ext uri="{FF2B5EF4-FFF2-40B4-BE49-F238E27FC236}">
+                <a16:creationId xmlns:a16="http://schemas.microsoft.com/office/drawing/2014/main" id="{7A7D2EF2-BFA3-4766-B942-23E570E48309}"/>
+              </a:ext>
+            </a:extLst>
+          </p:cNvPr>
+          <p:cNvSpPr>
+            <a:spLocks noGrp="1"/>
+          </p:cNvSpPr>
+          <p:nvPr/>
+        </p:nvSpPr>
+        <p:spPr>
+          <a:xfrm>
+            <a:off x="609600" y="482600"/>
+            <a:ext cx="5334000" cy="304800"/>
+          </a:xfrm>
+          <a:prstGeom prst="rect">
+            <a:avLst/>
+          </a:prstGeom>
+          <a:noFill/>
+          <a:ln w="0">
+            <a:noFill/>
+            <a:prstDash val="solid"/>
+          </a:ln>
+        </p:spPr>
+        <p:txBody>
+          <a:bodyPr wrap="square" lIns="0" tIns="0" rIns="0" bIns="0" anchor="t">
+            <a:normAutofit/>
+          </a:bodyPr>
+          <a:lstStyle/>
+          <a:p>
+            <a:pPr algn="l">
+              <a:defRPr sz="1200" b="1">
+                <a:solidFill>
+                  <a:srgbClr val="3D8DFF"/>
+                </a:solidFill>
+                <a:latin typeface="Helvetica Neue"/>
+                <a:ea typeface="Helvetica Neue"/>
+                <a:cs typeface="Helvetica Neue"/>
+              </a:defRPr>
+            </a:pPr>
+            <a:r>
+              <a:rPr sz="1700" b="1">
+                <a:solidFill>
+                  <a:srgbClr val="71B4FF"/>
+                </a:solidFill>
+                <a:latin typeface="Aptos" panose="020B0004020202020204" pitchFamily="34" charset="0"/>
+                <a:ea typeface="Helvetica Neue"/>
+                <a:cs typeface="Helvetica Neue"/>
+              </a:rPr>
+              <a:t>SUMMER PROGRESS UPDATE</a:t>
+            </a:r>
+          </a:p>
+        </p:txBody>
+      </p:sp>
+      <p:sp>
+        <p:nvSpPr>
+          <p:cNvPr id="2" name="Rectangle 1">
+            <a:extLst>
+              <a:ext uri="{FF2B5EF4-FFF2-40B4-BE49-F238E27FC236}">
+                <a16:creationId xmlns:a16="http://schemas.microsoft.com/office/drawing/2014/main" id="{6C209B30-5687-4D31-B45B-B18289FD1874}"/>
+              </a:ext>
+            </a:extLst>
+          </p:cNvPr>
+          <p:cNvSpPr>
+            <a:spLocks noGrp="1"/>
+          </p:cNvSpPr>
+          <p:nvPr/>
+        </p:nvSpPr>
+        <p:spPr>
+          <a:xfrm>
+            <a:off x="609600" y="1333500"/>
+            <a:ext cx="5588000" cy="889000"/>
+          </a:xfrm>
+          <a:prstGeom prst="rect">
+            <a:avLst/>
+          </a:prstGeom>
+          <a:noFill/>
+          <a:ln w="0">
+            <a:noFill/>
+            <a:prstDash val="solid"/>
+          </a:ln>
+        </p:spPr>
+        <p:txBody>
+          <a:bodyPr wrap="square" lIns="0" tIns="0" rIns="0" bIns="0" anchor="t">
+            <a:normAutofit fontScale="85000" lnSpcReduction="10000"/>
+          </a:bodyPr>
+          <a:lstStyle/>
+          <a:p>
+            <a:pPr algn="l">
+              <a:defRPr sz="4800" b="1">
+                <a:solidFill>
+                  <a:srgbClr val="000000"/>
+                </a:solidFill>
+                <a:latin typeface="Helvetica Neue"/>
+                <a:ea typeface="Helvetica Neue"/>
+                <a:cs typeface="Helvetica Neue"/>
+              </a:defRPr>
+            </a:pPr>
+            <a:r>
+              <a:rPr lang="en-US" sz="3400" b="1" dirty="0">
+                <a:solidFill>
+                  <a:srgbClr val="FFFFFF"/>
+                </a:solidFill>
+                <a:latin typeface="Aptos" panose="020B0004020202020204" pitchFamily="34" charset="0"/>
+                <a:ea typeface="Helvetica Neue"/>
+                <a:cs typeface="Helvetica Neue"/>
+              </a:rPr>
+              <a:t>XY </a:t>
+            </a:r>
+            <a:r>
+              <a:rPr sz="3400" b="1" dirty="0">
+                <a:solidFill>
+                  <a:srgbClr val="FFFFFF"/>
+                </a:solidFill>
+                <a:latin typeface="Aptos" panose="020B0004020202020204" pitchFamily="34" charset="0"/>
+                <a:ea typeface="Helvetica Neue"/>
+                <a:cs typeface="Helvetica Neue"/>
+              </a:rPr>
+              <a:t>Theta Pen Plotter</a:t>
+            </a:r>
+          </a:p>
+        </p:txBody>
+      </p:sp>
+      <p:sp>
+        <p:nvSpPr>
+          <p:cNvPr id="3" name="Rectangle 2">
+            <a:extLst>
+              <a:ext uri="{FF2B5EF4-FFF2-40B4-BE49-F238E27FC236}">
+                <a16:creationId xmlns:a16="http://schemas.microsoft.com/office/drawing/2014/main" id="{D7D776E8-8ED9-48FA-BCA2-259250FFD263}"/>
+              </a:ext>
+            </a:extLst>
+          </p:cNvPr>
+          <p:cNvSpPr>
+            <a:spLocks noGrp="1"/>
+          </p:cNvSpPr>
+          <p:nvPr/>
+        </p:nvSpPr>
+        <p:spPr>
+          <a:xfrm>
+            <a:off x="609600" y="2794000"/>
+            <a:ext cx="5461000" cy="533400"/>
+          </a:xfrm>
+          <a:prstGeom prst="rect">
+            <a:avLst/>
+          </a:prstGeom>
+          <a:noFill/>
+          <a:ln w="0">
+            <a:noFill/>
+            <a:prstDash val="solid"/>
+          </a:ln>
+        </p:spPr>
+        <p:txBody>
+          <a:bodyPr wrap="square" lIns="0" tIns="0" rIns="0" bIns="0" anchor="t">
+            <a:normAutofit/>
+          </a:bodyPr>
+          <a:lstStyle/>
+          <a:p>
+            <a:pPr algn="l">
+              <a:defRPr sz="2025" b="0">
+                <a:solidFill>
+                  <a:srgbClr val="59616B"/>
+                </a:solidFill>
+                <a:latin typeface="Helvetica Neue"/>
+                <a:ea typeface="Helvetica Neue"/>
+                <a:cs typeface="Helvetica Neue"/>
+              </a:defRPr>
+            </a:pPr>
+            <a:r>
+              <a:rPr lang="en-US" sz="2200" b="0" dirty="0">
+                <a:solidFill>
+                  <a:srgbClr val="DEE8F2"/>
+                </a:solidFill>
+                <a:latin typeface="Aptos" panose="020B0004020202020204" pitchFamily="34" charset="0"/>
+                <a:ea typeface="Helvetica Neue"/>
+                <a:cs typeface="Helvetica Neue"/>
+              </a:rPr>
+              <a:t>Path to </a:t>
+            </a:r>
+            <a:r>
+              <a:rPr lang="en-US" sz="2200" b="0" dirty="0" err="1">
+                <a:solidFill>
+                  <a:srgbClr val="DEE8F2"/>
+                </a:solidFill>
+                <a:latin typeface="Aptos" panose="020B0004020202020204" pitchFamily="34" charset="0"/>
+                <a:ea typeface="Helvetica Neue"/>
+                <a:cs typeface="Helvetica Neue"/>
+              </a:rPr>
+              <a:t>commisioning</a:t>
+            </a:r>
+            <a:endParaRPr sz="2200" b="0" dirty="0">
+              <a:solidFill>
+                <a:srgbClr val="DEE8F2"/>
+              </a:solidFill>
+              <a:latin typeface="Aptos" panose="020B0004020202020204" pitchFamily="34" charset="0"/>
+              <a:ea typeface="Helvetica Neue"/>
+              <a:cs typeface="Helvetica Neue"/>
+            </a:endParaRPr>
+          </a:p>
+        </p:txBody>
+      </p:sp>
+      <p:sp>
+        <p:nvSpPr>
+          <p:cNvPr id="5" name="Rectangle 4">
+            <a:extLst>
+              <a:ext uri="{FF2B5EF4-FFF2-40B4-BE49-F238E27FC236}">
+                <a16:creationId xmlns:a16="http://schemas.microsoft.com/office/drawing/2014/main" id="{FD70773F-8C93-41F1-9E9B-6EE3F437BD4A}"/>
+              </a:ext>
+            </a:extLst>
+          </p:cNvPr>
+          <p:cNvSpPr>
+            <a:spLocks noGrp="1"/>
+          </p:cNvSpPr>
+          <p:nvPr/>
+        </p:nvSpPr>
+        <p:spPr>
+          <a:xfrm>
+            <a:off x="609600" y="5969000"/>
+            <a:ext cx="5588000" cy="355600"/>
+          </a:xfrm>
+          <a:prstGeom prst="rect">
+            <a:avLst/>
+          </a:prstGeom>
+          <a:noFill/>
+          <a:ln w="0">
+            <a:noFill/>
+            <a:prstDash val="solid"/>
+          </a:ln>
+        </p:spPr>
+        <p:txBody>
+          <a:bodyPr wrap="square" lIns="0" tIns="0" rIns="0" bIns="0" anchor="t">
+            <a:normAutofit/>
+          </a:bodyPr>
+          <a:lstStyle/>
+          <a:p>
+            <a:pPr algn="l">
+              <a:defRPr sz="1350" b="0">
+                <a:solidFill>
+                  <a:srgbClr val="000000"/>
+                </a:solidFill>
+                <a:latin typeface="Helvetica Neue"/>
+                <a:ea typeface="Helvetica Neue"/>
+                <a:cs typeface="Helvetica Neue"/>
+              </a:defRPr>
+            </a:pPr>
+            <a:r>
+              <a:rPr sz="1500" b="0">
+                <a:solidFill>
+                  <a:srgbClr val="DAE6F2"/>
+                </a:solidFill>
+                <a:latin typeface="Aptos" panose="020B0004020202020204" pitchFamily="34" charset="0"/>
+                <a:ea typeface="Helvetica Neue"/>
+                <a:cs typeface="Helvetica Neue"/>
+              </a:rPr>
+              <a:t>Course progress update  •  September 2026</a:t>
+            </a:r>
+          </a:p>
+        </p:txBody>
+      </p:sp>
+      <p:sp>
+        <p:nvSpPr>
+          <p:cNvPr id="7" name="Rectangle 6">
+            <a:extLst>
+              <a:ext uri="{FF2B5EF4-FFF2-40B4-BE49-F238E27FC236}">
+                <a16:creationId xmlns:a16="http://schemas.microsoft.com/office/drawing/2014/main" id="{105FB2DD-B9EE-4E50-ACD4-DD43F4B76831}"/>
+              </a:ext>
+            </a:extLst>
+          </p:cNvPr>
+          <p:cNvSpPr>
+            <a:spLocks noGrp="1"/>
+          </p:cNvSpPr>
+          <p:nvPr/>
+        </p:nvSpPr>
+        <p:spPr>
+          <a:xfrm>
+            <a:off x="609600" y="4978400"/>
+            <a:ext cx="5588000" cy="685800"/>
+          </a:xfrm>
+          <a:prstGeom prst="rect">
+            <a:avLst/>
+          </a:prstGeom>
+          <a:noFill/>
+          <a:ln w="0">
+            <a:noFill/>
+            <a:prstDash val="solid"/>
+          </a:ln>
+        </p:spPr>
+        <p:txBody>
+          <a:bodyPr wrap="square" lIns="0" tIns="0" rIns="0" bIns="0" anchor="t">
+            <a:normAutofit/>
+          </a:bodyPr>
+          <a:lstStyle/>
+          <a:p>
+            <a:pPr algn="l">
+              <a:defRPr sz="1050" b="0">
+                <a:solidFill>
+                  <a:srgbClr val="59616B"/>
+                </a:solidFill>
+                <a:latin typeface="Helvetica Neue"/>
+                <a:ea typeface="Helvetica Neue"/>
+                <a:cs typeface="Helvetica Neue"/>
+              </a:defRPr>
+            </a:pPr>
+            <a:r>
+              <a:rPr sz="1300" b="0">
+                <a:solidFill>
+                  <a:srgbClr val="DCE8F2"/>
+                </a:solidFill>
+                <a:latin typeface="Aptos" panose="020B0004020202020204" pitchFamily="34" charset="0"/>
+                <a:ea typeface="Helvetica Neue"/>
+                <a:cs typeface="Helvetica Neue"/>
+              </a:rPr>
+              <a:t>The toolhead combines an N20 lead-screw actuator, spring compliance, load cell, and guided pen carriage.</a:t>
+            </a:r>
+          </a:p>
+        </p:txBody>
+      </p:sp>
+      <p:sp>
+        <p:nvSpPr>
+          <p:cNvPr id="12" name="Opening Title Divider">
+            <a:extLst>
+              <a:ext uri="{FF2B5EF4-FFF2-40B4-BE49-F238E27FC236}">
+                <a16:creationId xmlns:a16="http://schemas.microsoft.com/office/drawing/2014/main" id="{EE4DA868-0CB6-CA6E-219B-CADE9894FC57}"/>
+              </a:ext>
+            </a:extLst>
+          </p:cNvPr>
+          <p:cNvSpPr/>
+          <p:nvPr/>
+        </p:nvSpPr>
+        <p:spPr>
+          <a:xfrm>
+            <a:off x="609600" y="3937000"/>
+            <a:ext cx="5334000" cy="38100"/>
+          </a:xfrm>
+          <a:prstGeom prst="rect">
+            <a:avLst/>
+          </a:prstGeom>
+          <a:solidFill>
+            <a:srgbClr val="71B4FF"/>
+          </a:solidFill>
+          <a:ln w="19050">
+            <a:noFill/>
+            <a:prstDash val="solid"/>
+          </a:ln>
+          <a:effectLst/>
+          <a:extLst>
+            <a:ext uri="{91240B29-F687-4F45-9708-019B960494DF}">
+              <a14:hiddenLine xmlns:a14="http://schemas.microsoft.com/office/drawing/2010/main" w="19050">
+                <a:solidFill>
+                  <a:schemeClr val="accent1">
+                    <a:shade val="15000"/>
+                  </a:schemeClr>
+                </a:solidFill>
+                <a:prstDash val="solid"/>
+              </a14:hiddenLine>
+            </a:ext>
+          </a:extLst>
+        </p:spPr>
+        <p:style>
+          <a:lnRef idx="2">
+            <a:schemeClr val="accent1">
+              <a:shade val="15000"/>
+            </a:schemeClr>
+          </a:lnRef>
+          <a:fillRef idx="1">
+            <a:schemeClr val="accent1"/>
+          </a:fillRef>
+          <a:effectRef idx="0">
+            <a:schemeClr val="accent1"/>
+          </a:effectRef>
+          <a:fontRef idx="minor">
+            <a:schemeClr val="lt1"/>
+          </a:fontRef>
+        </p:style>
+        <p:txBody>
+          <a:bodyPr rtlCol="0" anchor="ctr"/>
+          <a:lstStyle/>
+          <a:p>
+            <a:pPr algn="ctr"/>
+            <a:endParaRPr lang="en-US"/>
+          </a:p>
+        </p:txBody>
+      </p:sp>
     </p:spTree>
     <p:extLst>
       <p:ext uri="{BB962C8B-B14F-4D97-AF65-F5344CB8AC3E}">

</xml_diff>